<commit_message>
TX deployed bitstream and reports from the repository build; repro fixes from the second clean-clone test
- board/bitstreams/jscc_tx.{bit,hwh}, build/reports/tx_*.rpt: rebuilt from the current sources
  (three independent builds identical: LUT 52,679, WNS +0.261 ns, 4.51 W); numbers updated in
  README, report and poster
- bd scripts: no BD 5-104 error on a fresh project; sscc_ref.py reads the xsim directory by default

Co-Authored-By: Claude Opus 5.5 <noreply@anthropic.com>
</commit_message>
<xml_diff>
--- a/report/poster/poster_en.pptx
+++ b/report/poster/poster_en.pptx
@@ -129,7 +129,7 @@
           <p:cNvPr id="2" name="标题 1">
             <a:extLst>
               <a:ext uri="{FF2B5EF4-FFF2-40B4-BE49-F238E27FC236}">
-                <a16:creationId xmlns:a16="http://schemas.microsoft.com/office/drawing/2014/main" id="{3361AB3D-F13A-2F78-DD24-3FF3879B8EF8}"/>
+                <a16:creationId xmlns:a16="http://schemas.microsoft.com/office/drawing/2014/main" id="{12519FB6-34C2-8412-6540-9D1AE1079B8D}"/>
               </a:ext>
             </a:extLst>
           </p:cNvPr>
@@ -166,7 +166,7 @@
           <p:cNvPr id="3" name="副标题 2">
             <a:extLst>
               <a:ext uri="{FF2B5EF4-FFF2-40B4-BE49-F238E27FC236}">
-                <a16:creationId xmlns:a16="http://schemas.microsoft.com/office/drawing/2014/main" id="{0202A4B7-3313-D5B6-C005-CBA166D97E15}"/>
+                <a16:creationId xmlns:a16="http://schemas.microsoft.com/office/drawing/2014/main" id="{388048E2-9DE6-BD03-AD8F-F3E66CBEE65A}"/>
               </a:ext>
             </a:extLst>
           </p:cNvPr>
@@ -236,7 +236,7 @@
           <p:cNvPr id="4" name="日期占位符 3">
             <a:extLst>
               <a:ext uri="{FF2B5EF4-FFF2-40B4-BE49-F238E27FC236}">
-                <a16:creationId xmlns:a16="http://schemas.microsoft.com/office/drawing/2014/main" id="{B23A6606-A088-5FBF-0BFE-F6BE0A721C78}"/>
+                <a16:creationId xmlns:a16="http://schemas.microsoft.com/office/drawing/2014/main" id="{C4D48CA1-4587-AAB9-872E-B54CADCC1827}"/>
               </a:ext>
             </a:extLst>
           </p:cNvPr>
@@ -252,9 +252,9 @@
           <a:bodyPr/>
           <a:lstStyle/>
           <a:p>
-            <a:fld id="{0FDF490C-865A-46A7-9644-4676E9929DDD}" type="datetimeFigureOut">
+            <a:fld id="{BE8E5DDC-8DBC-495D-83D8-7932EBA21A75}" type="datetimeFigureOut">
               <a:rPr lang="zh-CN" altLang="en-US" smtClean="0"/>
-              <a:t>2026/10/12</a:t>
+              <a:t>2026/10/13</a:t>
             </a:fld>
             <a:endParaRPr lang="zh-CN" altLang="en-US"/>
           </a:p>
@@ -265,7 +265,7 @@
           <p:cNvPr id="5" name="页脚占位符 4">
             <a:extLst>
               <a:ext uri="{FF2B5EF4-FFF2-40B4-BE49-F238E27FC236}">
-                <a16:creationId xmlns:a16="http://schemas.microsoft.com/office/drawing/2014/main" id="{9D43FB4F-B92F-3E06-2F35-26B16EBBC86E}"/>
+                <a16:creationId xmlns:a16="http://schemas.microsoft.com/office/drawing/2014/main" id="{D1C2A123-19CD-9256-6ED7-91018FBA449C}"/>
               </a:ext>
             </a:extLst>
           </p:cNvPr>
@@ -290,7 +290,7 @@
           <p:cNvPr id="6" name="灯片编号占位符 5">
             <a:extLst>
               <a:ext uri="{FF2B5EF4-FFF2-40B4-BE49-F238E27FC236}">
-                <a16:creationId xmlns:a16="http://schemas.microsoft.com/office/drawing/2014/main" id="{931CA847-ED54-12C9-7F45-97D82F9CBDBD}"/>
+                <a16:creationId xmlns:a16="http://schemas.microsoft.com/office/drawing/2014/main" id="{F09A46F0-491A-8594-F742-D0819921042B}"/>
               </a:ext>
             </a:extLst>
           </p:cNvPr>
@@ -306,7 +306,7 @@
           <a:bodyPr/>
           <a:lstStyle/>
           <a:p>
-            <a:fld id="{7C259DA1-6AAB-40E2-800A-C51A0D9D0A1F}" type="slidenum">
+            <a:fld id="{41F10874-7FDD-43DA-9458-5F9582894316}" type="slidenum">
               <a:rPr lang="zh-CN" altLang="en-US" smtClean="0"/>
               <a:t>‹#›</a:t>
             </a:fld>
@@ -317,7 +317,7 @@
     </p:spTree>
     <p:extLst>
       <p:ext uri="{BB962C8B-B14F-4D97-AF65-F5344CB8AC3E}">
-        <p14:creationId xmlns:p14="http://schemas.microsoft.com/office/powerpoint/2010/main" val="1556825991"/>
+        <p14:creationId xmlns:p14="http://schemas.microsoft.com/office/powerpoint/2010/main" val="4202444517"/>
       </p:ext>
     </p:extLst>
   </p:cSld>
@@ -349,7 +349,7 @@
           <p:cNvPr id="2" name="标题 1">
             <a:extLst>
               <a:ext uri="{FF2B5EF4-FFF2-40B4-BE49-F238E27FC236}">
-                <a16:creationId xmlns:a16="http://schemas.microsoft.com/office/drawing/2014/main" id="{3AA2C72F-E94F-9A75-2ED9-CA977DFD1C1B}"/>
+                <a16:creationId xmlns:a16="http://schemas.microsoft.com/office/drawing/2014/main" id="{40D75071-C62B-8C02-4BBA-F550CF50BA88}"/>
               </a:ext>
             </a:extLst>
           </p:cNvPr>
@@ -377,7 +377,7 @@
           <p:cNvPr id="3" name="竖排文字占位符 2">
             <a:extLst>
               <a:ext uri="{FF2B5EF4-FFF2-40B4-BE49-F238E27FC236}">
-                <a16:creationId xmlns:a16="http://schemas.microsoft.com/office/drawing/2014/main" id="{96CA5A47-CFE9-AFD4-08C1-525B56969E53}"/>
+                <a16:creationId xmlns:a16="http://schemas.microsoft.com/office/drawing/2014/main" id="{AF9F8E03-13F6-2834-10C6-30C6FAE50343}"/>
               </a:ext>
             </a:extLst>
           </p:cNvPr>
@@ -434,7 +434,7 @@
           <p:cNvPr id="4" name="日期占位符 3">
             <a:extLst>
               <a:ext uri="{FF2B5EF4-FFF2-40B4-BE49-F238E27FC236}">
-                <a16:creationId xmlns:a16="http://schemas.microsoft.com/office/drawing/2014/main" id="{EDFE4232-4249-D109-1C50-5173056C38D3}"/>
+                <a16:creationId xmlns:a16="http://schemas.microsoft.com/office/drawing/2014/main" id="{7090408D-2B0D-AC8F-A43A-CDBACDE47D0C}"/>
               </a:ext>
             </a:extLst>
           </p:cNvPr>
@@ -450,9 +450,9 @@
           <a:bodyPr/>
           <a:lstStyle/>
           <a:p>
-            <a:fld id="{0FDF490C-865A-46A7-9644-4676E9929DDD}" type="datetimeFigureOut">
+            <a:fld id="{BE8E5DDC-8DBC-495D-83D8-7932EBA21A75}" type="datetimeFigureOut">
               <a:rPr lang="zh-CN" altLang="en-US" smtClean="0"/>
-              <a:t>2026/10/12</a:t>
+              <a:t>2026/10/13</a:t>
             </a:fld>
             <a:endParaRPr lang="zh-CN" altLang="en-US"/>
           </a:p>
@@ -463,7 +463,7 @@
           <p:cNvPr id="5" name="页脚占位符 4">
             <a:extLst>
               <a:ext uri="{FF2B5EF4-FFF2-40B4-BE49-F238E27FC236}">
-                <a16:creationId xmlns:a16="http://schemas.microsoft.com/office/drawing/2014/main" id="{1654C35D-7C3C-0655-38B4-A97D795B3CB9}"/>
+                <a16:creationId xmlns:a16="http://schemas.microsoft.com/office/drawing/2014/main" id="{03D0AEFF-0E60-D1C3-500B-44CCE5D9304B}"/>
               </a:ext>
             </a:extLst>
           </p:cNvPr>
@@ -488,7 +488,7 @@
           <p:cNvPr id="6" name="灯片编号占位符 5">
             <a:extLst>
               <a:ext uri="{FF2B5EF4-FFF2-40B4-BE49-F238E27FC236}">
-                <a16:creationId xmlns:a16="http://schemas.microsoft.com/office/drawing/2014/main" id="{2D2527F1-68B7-7BAA-BA64-F6582B6B40DB}"/>
+                <a16:creationId xmlns:a16="http://schemas.microsoft.com/office/drawing/2014/main" id="{99AF804C-B074-FF96-F424-F7DEA1CF72A5}"/>
               </a:ext>
             </a:extLst>
           </p:cNvPr>
@@ -504,7 +504,7 @@
           <a:bodyPr/>
           <a:lstStyle/>
           <a:p>
-            <a:fld id="{7C259DA1-6AAB-40E2-800A-C51A0D9D0A1F}" type="slidenum">
+            <a:fld id="{41F10874-7FDD-43DA-9458-5F9582894316}" type="slidenum">
               <a:rPr lang="zh-CN" altLang="en-US" smtClean="0"/>
               <a:t>‹#›</a:t>
             </a:fld>
@@ -515,7 +515,7 @@
     </p:spTree>
     <p:extLst>
       <p:ext uri="{BB962C8B-B14F-4D97-AF65-F5344CB8AC3E}">
-        <p14:creationId xmlns:p14="http://schemas.microsoft.com/office/powerpoint/2010/main" val="3065054552"/>
+        <p14:creationId xmlns:p14="http://schemas.microsoft.com/office/powerpoint/2010/main" val="3030597835"/>
       </p:ext>
     </p:extLst>
   </p:cSld>
@@ -547,7 +547,7 @@
           <p:cNvPr id="2" name="竖排标题 1">
             <a:extLst>
               <a:ext uri="{FF2B5EF4-FFF2-40B4-BE49-F238E27FC236}">
-                <a16:creationId xmlns:a16="http://schemas.microsoft.com/office/drawing/2014/main" id="{66DFC5B8-0719-85AD-5B39-BC31D990DDA1}"/>
+                <a16:creationId xmlns:a16="http://schemas.microsoft.com/office/drawing/2014/main" id="{3FAC9108-54FA-6FE3-A147-F7DEEA61739E}"/>
               </a:ext>
             </a:extLst>
           </p:cNvPr>
@@ -580,7 +580,7 @@
           <p:cNvPr id="3" name="竖排文字占位符 2">
             <a:extLst>
               <a:ext uri="{FF2B5EF4-FFF2-40B4-BE49-F238E27FC236}">
-                <a16:creationId xmlns:a16="http://schemas.microsoft.com/office/drawing/2014/main" id="{7973C0AA-F3A1-BBC5-4D65-A4785AF0854C}"/>
+                <a16:creationId xmlns:a16="http://schemas.microsoft.com/office/drawing/2014/main" id="{442950C5-8B83-E585-CA78-EEC5F991E5DA}"/>
               </a:ext>
             </a:extLst>
           </p:cNvPr>
@@ -642,7 +642,7 @@
           <p:cNvPr id="4" name="日期占位符 3">
             <a:extLst>
               <a:ext uri="{FF2B5EF4-FFF2-40B4-BE49-F238E27FC236}">
-                <a16:creationId xmlns:a16="http://schemas.microsoft.com/office/drawing/2014/main" id="{99CB470A-8C90-84E0-E451-E68EB4BEEDF1}"/>
+                <a16:creationId xmlns:a16="http://schemas.microsoft.com/office/drawing/2014/main" id="{645938DE-2D89-1A97-E1CA-487BA984A8A2}"/>
               </a:ext>
             </a:extLst>
           </p:cNvPr>
@@ -658,9 +658,9 @@
           <a:bodyPr/>
           <a:lstStyle/>
           <a:p>
-            <a:fld id="{0FDF490C-865A-46A7-9644-4676E9929DDD}" type="datetimeFigureOut">
+            <a:fld id="{BE8E5DDC-8DBC-495D-83D8-7932EBA21A75}" type="datetimeFigureOut">
               <a:rPr lang="zh-CN" altLang="en-US" smtClean="0"/>
-              <a:t>2026/10/12</a:t>
+              <a:t>2026/10/13</a:t>
             </a:fld>
             <a:endParaRPr lang="zh-CN" altLang="en-US"/>
           </a:p>
@@ -671,7 +671,7 @@
           <p:cNvPr id="5" name="页脚占位符 4">
             <a:extLst>
               <a:ext uri="{FF2B5EF4-FFF2-40B4-BE49-F238E27FC236}">
-                <a16:creationId xmlns:a16="http://schemas.microsoft.com/office/drawing/2014/main" id="{9391BD2A-7C92-344D-25A5-0DB80F0B3352}"/>
+                <a16:creationId xmlns:a16="http://schemas.microsoft.com/office/drawing/2014/main" id="{8ACF7864-F65F-4268-85CD-5E44A4F8717E}"/>
               </a:ext>
             </a:extLst>
           </p:cNvPr>
@@ -696,7 +696,7 @@
           <p:cNvPr id="6" name="灯片编号占位符 5">
             <a:extLst>
               <a:ext uri="{FF2B5EF4-FFF2-40B4-BE49-F238E27FC236}">
-                <a16:creationId xmlns:a16="http://schemas.microsoft.com/office/drawing/2014/main" id="{2DBD443C-6DBA-D27E-57B0-C32CB87567BC}"/>
+                <a16:creationId xmlns:a16="http://schemas.microsoft.com/office/drawing/2014/main" id="{8AD6E01D-16CE-CFC6-DD57-D6DB6979634E}"/>
               </a:ext>
             </a:extLst>
           </p:cNvPr>
@@ -712,7 +712,7 @@
           <a:bodyPr/>
           <a:lstStyle/>
           <a:p>
-            <a:fld id="{7C259DA1-6AAB-40E2-800A-C51A0D9D0A1F}" type="slidenum">
+            <a:fld id="{41F10874-7FDD-43DA-9458-5F9582894316}" type="slidenum">
               <a:rPr lang="zh-CN" altLang="en-US" smtClean="0"/>
               <a:t>‹#›</a:t>
             </a:fld>
@@ -723,7 +723,7 @@
     </p:spTree>
     <p:extLst>
       <p:ext uri="{BB962C8B-B14F-4D97-AF65-F5344CB8AC3E}">
-        <p14:creationId xmlns:p14="http://schemas.microsoft.com/office/powerpoint/2010/main" val="1613511848"/>
+        <p14:creationId xmlns:p14="http://schemas.microsoft.com/office/powerpoint/2010/main" val="642428704"/>
       </p:ext>
     </p:extLst>
   </p:cSld>
@@ -755,7 +755,7 @@
           <p:cNvPr id="2" name="标题 1">
             <a:extLst>
               <a:ext uri="{FF2B5EF4-FFF2-40B4-BE49-F238E27FC236}">
-                <a16:creationId xmlns:a16="http://schemas.microsoft.com/office/drawing/2014/main" id="{162F5E4E-5296-EC5C-2F01-3C7423EA1063}"/>
+                <a16:creationId xmlns:a16="http://schemas.microsoft.com/office/drawing/2014/main" id="{D54C3486-F063-4B53-B154-E923EBB03A7D}"/>
               </a:ext>
             </a:extLst>
           </p:cNvPr>
@@ -783,7 +783,7 @@
           <p:cNvPr id="3" name="内容占位符 2">
             <a:extLst>
               <a:ext uri="{FF2B5EF4-FFF2-40B4-BE49-F238E27FC236}">
-                <a16:creationId xmlns:a16="http://schemas.microsoft.com/office/drawing/2014/main" id="{FED6D9F0-D2FF-010C-CCE6-A5B2B0897F7E}"/>
+                <a16:creationId xmlns:a16="http://schemas.microsoft.com/office/drawing/2014/main" id="{807E657F-B64C-C031-E81C-2C67A456580C}"/>
               </a:ext>
             </a:extLst>
           </p:cNvPr>
@@ -840,7 +840,7 @@
           <p:cNvPr id="4" name="日期占位符 3">
             <a:extLst>
               <a:ext uri="{FF2B5EF4-FFF2-40B4-BE49-F238E27FC236}">
-                <a16:creationId xmlns:a16="http://schemas.microsoft.com/office/drawing/2014/main" id="{A2E09E8C-C3F1-C824-9E07-65F9AB2DB950}"/>
+                <a16:creationId xmlns:a16="http://schemas.microsoft.com/office/drawing/2014/main" id="{AE46672A-D35B-331E-5147-02461F7B9E1C}"/>
               </a:ext>
             </a:extLst>
           </p:cNvPr>
@@ -856,9 +856,9 @@
           <a:bodyPr/>
           <a:lstStyle/>
           <a:p>
-            <a:fld id="{0FDF490C-865A-46A7-9644-4676E9929DDD}" type="datetimeFigureOut">
+            <a:fld id="{BE8E5DDC-8DBC-495D-83D8-7932EBA21A75}" type="datetimeFigureOut">
               <a:rPr lang="zh-CN" altLang="en-US" smtClean="0"/>
-              <a:t>2026/10/12</a:t>
+              <a:t>2026/10/13</a:t>
             </a:fld>
             <a:endParaRPr lang="zh-CN" altLang="en-US"/>
           </a:p>
@@ -869,7 +869,7 @@
           <p:cNvPr id="5" name="页脚占位符 4">
             <a:extLst>
               <a:ext uri="{FF2B5EF4-FFF2-40B4-BE49-F238E27FC236}">
-                <a16:creationId xmlns:a16="http://schemas.microsoft.com/office/drawing/2014/main" id="{4A108481-68AB-FFC8-917D-84C950BD4ABF}"/>
+                <a16:creationId xmlns:a16="http://schemas.microsoft.com/office/drawing/2014/main" id="{975DE714-AA4D-2F8B-4A59-780293C7BDEC}"/>
               </a:ext>
             </a:extLst>
           </p:cNvPr>
@@ -894,7 +894,7 @@
           <p:cNvPr id="6" name="灯片编号占位符 5">
             <a:extLst>
               <a:ext uri="{FF2B5EF4-FFF2-40B4-BE49-F238E27FC236}">
-                <a16:creationId xmlns:a16="http://schemas.microsoft.com/office/drawing/2014/main" id="{33C7F222-207A-AA2A-4F05-9588AFEB9776}"/>
+                <a16:creationId xmlns:a16="http://schemas.microsoft.com/office/drawing/2014/main" id="{78137555-BF31-9252-5748-F431B16B9B88}"/>
               </a:ext>
             </a:extLst>
           </p:cNvPr>
@@ -910,7 +910,7 @@
           <a:bodyPr/>
           <a:lstStyle/>
           <a:p>
-            <a:fld id="{7C259DA1-6AAB-40E2-800A-C51A0D9D0A1F}" type="slidenum">
+            <a:fld id="{41F10874-7FDD-43DA-9458-5F9582894316}" type="slidenum">
               <a:rPr lang="zh-CN" altLang="en-US" smtClean="0"/>
               <a:t>‹#›</a:t>
             </a:fld>
@@ -921,7 +921,7 @@
     </p:spTree>
     <p:extLst>
       <p:ext uri="{BB962C8B-B14F-4D97-AF65-F5344CB8AC3E}">
-        <p14:creationId xmlns:p14="http://schemas.microsoft.com/office/powerpoint/2010/main" val="1481082335"/>
+        <p14:creationId xmlns:p14="http://schemas.microsoft.com/office/powerpoint/2010/main" val="1298233392"/>
       </p:ext>
     </p:extLst>
   </p:cSld>
@@ -953,7 +953,7 @@
           <p:cNvPr id="2" name="标题 1">
             <a:extLst>
               <a:ext uri="{FF2B5EF4-FFF2-40B4-BE49-F238E27FC236}">
-                <a16:creationId xmlns:a16="http://schemas.microsoft.com/office/drawing/2014/main" id="{4E749D06-4F1C-3AD9-4697-9A7A85DA40B7}"/>
+                <a16:creationId xmlns:a16="http://schemas.microsoft.com/office/drawing/2014/main" id="{B5F7A7BC-D5AC-3C32-C699-CEFCD842DBBF}"/>
               </a:ext>
             </a:extLst>
           </p:cNvPr>
@@ -990,7 +990,7 @@
           <p:cNvPr id="3" name="文本占位符 2">
             <a:extLst>
               <a:ext uri="{FF2B5EF4-FFF2-40B4-BE49-F238E27FC236}">
-                <a16:creationId xmlns:a16="http://schemas.microsoft.com/office/drawing/2014/main" id="{59965D4A-5CE2-E832-BCE1-1D7A8CA5BAD8}"/>
+                <a16:creationId xmlns:a16="http://schemas.microsoft.com/office/drawing/2014/main" id="{ED3D4D7A-D4D4-9AAB-D6AE-095575D872BB}"/>
               </a:ext>
             </a:extLst>
           </p:cNvPr>
@@ -1115,7 +1115,7 @@
           <p:cNvPr id="4" name="日期占位符 3">
             <a:extLst>
               <a:ext uri="{FF2B5EF4-FFF2-40B4-BE49-F238E27FC236}">
-                <a16:creationId xmlns:a16="http://schemas.microsoft.com/office/drawing/2014/main" id="{19840001-4457-0ACB-01A7-A44C570313FE}"/>
+                <a16:creationId xmlns:a16="http://schemas.microsoft.com/office/drawing/2014/main" id="{F30595C2-8A75-7F0E-1A24-0A8D20A1695F}"/>
               </a:ext>
             </a:extLst>
           </p:cNvPr>
@@ -1131,9 +1131,9 @@
           <a:bodyPr/>
           <a:lstStyle/>
           <a:p>
-            <a:fld id="{0FDF490C-865A-46A7-9644-4676E9929DDD}" type="datetimeFigureOut">
+            <a:fld id="{BE8E5DDC-8DBC-495D-83D8-7932EBA21A75}" type="datetimeFigureOut">
               <a:rPr lang="zh-CN" altLang="en-US" smtClean="0"/>
-              <a:t>2026/10/12</a:t>
+              <a:t>2026/10/13</a:t>
             </a:fld>
             <a:endParaRPr lang="zh-CN" altLang="en-US"/>
           </a:p>
@@ -1144,7 +1144,7 @@
           <p:cNvPr id="5" name="页脚占位符 4">
             <a:extLst>
               <a:ext uri="{FF2B5EF4-FFF2-40B4-BE49-F238E27FC236}">
-                <a16:creationId xmlns:a16="http://schemas.microsoft.com/office/drawing/2014/main" id="{9232C51C-B79F-362E-DB46-8ECED1F18449}"/>
+                <a16:creationId xmlns:a16="http://schemas.microsoft.com/office/drawing/2014/main" id="{5C0F7148-A04D-239D-6D71-D12574AD4899}"/>
               </a:ext>
             </a:extLst>
           </p:cNvPr>
@@ -1169,7 +1169,7 @@
           <p:cNvPr id="6" name="灯片编号占位符 5">
             <a:extLst>
               <a:ext uri="{FF2B5EF4-FFF2-40B4-BE49-F238E27FC236}">
-                <a16:creationId xmlns:a16="http://schemas.microsoft.com/office/drawing/2014/main" id="{994BA246-E733-0FA8-8549-433E669096C5}"/>
+                <a16:creationId xmlns:a16="http://schemas.microsoft.com/office/drawing/2014/main" id="{189BBBA6-93EC-00A2-8F67-29AA6A4A6389}"/>
               </a:ext>
             </a:extLst>
           </p:cNvPr>
@@ -1185,7 +1185,7 @@
           <a:bodyPr/>
           <a:lstStyle/>
           <a:p>
-            <a:fld id="{7C259DA1-6AAB-40E2-800A-C51A0D9D0A1F}" type="slidenum">
+            <a:fld id="{41F10874-7FDD-43DA-9458-5F9582894316}" type="slidenum">
               <a:rPr lang="zh-CN" altLang="en-US" smtClean="0"/>
               <a:t>‹#›</a:t>
             </a:fld>
@@ -1196,7 +1196,7 @@
     </p:spTree>
     <p:extLst>
       <p:ext uri="{BB962C8B-B14F-4D97-AF65-F5344CB8AC3E}">
-        <p14:creationId xmlns:p14="http://schemas.microsoft.com/office/powerpoint/2010/main" val="880283879"/>
+        <p14:creationId xmlns:p14="http://schemas.microsoft.com/office/powerpoint/2010/main" val="3063080850"/>
       </p:ext>
     </p:extLst>
   </p:cSld>
@@ -1228,7 +1228,7 @@
           <p:cNvPr id="2" name="标题 1">
             <a:extLst>
               <a:ext uri="{FF2B5EF4-FFF2-40B4-BE49-F238E27FC236}">
-                <a16:creationId xmlns:a16="http://schemas.microsoft.com/office/drawing/2014/main" id="{6A62D987-B4C9-B7C4-B82B-B31500503CD0}"/>
+                <a16:creationId xmlns:a16="http://schemas.microsoft.com/office/drawing/2014/main" id="{3FF32395-409D-AF0B-2CE9-640906510526}"/>
               </a:ext>
             </a:extLst>
           </p:cNvPr>
@@ -1256,7 +1256,7 @@
           <p:cNvPr id="3" name="内容占位符 2">
             <a:extLst>
               <a:ext uri="{FF2B5EF4-FFF2-40B4-BE49-F238E27FC236}">
-                <a16:creationId xmlns:a16="http://schemas.microsoft.com/office/drawing/2014/main" id="{B452AF38-5B3C-F92C-12AB-9138F871FDB3}"/>
+                <a16:creationId xmlns:a16="http://schemas.microsoft.com/office/drawing/2014/main" id="{D3B3B4CA-289E-6B8E-84EC-5D57E18BEF11}"/>
               </a:ext>
             </a:extLst>
           </p:cNvPr>
@@ -1318,7 +1318,7 @@
           <p:cNvPr id="4" name="内容占位符 3">
             <a:extLst>
               <a:ext uri="{FF2B5EF4-FFF2-40B4-BE49-F238E27FC236}">
-                <a16:creationId xmlns:a16="http://schemas.microsoft.com/office/drawing/2014/main" id="{240168E5-AB05-5B44-2F77-7F720599086C}"/>
+                <a16:creationId xmlns:a16="http://schemas.microsoft.com/office/drawing/2014/main" id="{E4553D61-E1F6-62E8-ADA5-162540DA488F}"/>
               </a:ext>
             </a:extLst>
           </p:cNvPr>
@@ -1380,7 +1380,7 @@
           <p:cNvPr id="5" name="日期占位符 4">
             <a:extLst>
               <a:ext uri="{FF2B5EF4-FFF2-40B4-BE49-F238E27FC236}">
-                <a16:creationId xmlns:a16="http://schemas.microsoft.com/office/drawing/2014/main" id="{0C687DE0-7695-4057-6B7E-7E8D97D65D86}"/>
+                <a16:creationId xmlns:a16="http://schemas.microsoft.com/office/drawing/2014/main" id="{E6760AF9-F847-9F78-3B30-76EA6DA496A0}"/>
               </a:ext>
             </a:extLst>
           </p:cNvPr>
@@ -1396,9 +1396,9 @@
           <a:bodyPr/>
           <a:lstStyle/>
           <a:p>
-            <a:fld id="{0FDF490C-865A-46A7-9644-4676E9929DDD}" type="datetimeFigureOut">
+            <a:fld id="{BE8E5DDC-8DBC-495D-83D8-7932EBA21A75}" type="datetimeFigureOut">
               <a:rPr lang="zh-CN" altLang="en-US" smtClean="0"/>
-              <a:t>2026/10/12</a:t>
+              <a:t>2026/10/13</a:t>
             </a:fld>
             <a:endParaRPr lang="zh-CN" altLang="en-US"/>
           </a:p>
@@ -1409,7 +1409,7 @@
           <p:cNvPr id="6" name="页脚占位符 5">
             <a:extLst>
               <a:ext uri="{FF2B5EF4-FFF2-40B4-BE49-F238E27FC236}">
-                <a16:creationId xmlns:a16="http://schemas.microsoft.com/office/drawing/2014/main" id="{175A00D9-8C4D-154A-E5C4-588BD084DF80}"/>
+                <a16:creationId xmlns:a16="http://schemas.microsoft.com/office/drawing/2014/main" id="{8C6127C1-56D0-AC64-45FF-E664A897BF14}"/>
               </a:ext>
             </a:extLst>
           </p:cNvPr>
@@ -1434,7 +1434,7 @@
           <p:cNvPr id="7" name="灯片编号占位符 6">
             <a:extLst>
               <a:ext uri="{FF2B5EF4-FFF2-40B4-BE49-F238E27FC236}">
-                <a16:creationId xmlns:a16="http://schemas.microsoft.com/office/drawing/2014/main" id="{A4FA45DD-0F60-49D0-79F7-0CE46C667653}"/>
+                <a16:creationId xmlns:a16="http://schemas.microsoft.com/office/drawing/2014/main" id="{E5BFB782-9680-2362-270D-8D478E99B4D0}"/>
               </a:ext>
             </a:extLst>
           </p:cNvPr>
@@ -1450,7 +1450,7 @@
           <a:bodyPr/>
           <a:lstStyle/>
           <a:p>
-            <a:fld id="{7C259DA1-6AAB-40E2-800A-C51A0D9D0A1F}" type="slidenum">
+            <a:fld id="{41F10874-7FDD-43DA-9458-5F9582894316}" type="slidenum">
               <a:rPr lang="zh-CN" altLang="en-US" smtClean="0"/>
               <a:t>‹#›</a:t>
             </a:fld>
@@ -1461,7 +1461,7 @@
     </p:spTree>
     <p:extLst>
       <p:ext uri="{BB962C8B-B14F-4D97-AF65-F5344CB8AC3E}">
-        <p14:creationId xmlns:p14="http://schemas.microsoft.com/office/powerpoint/2010/main" val="3604576461"/>
+        <p14:creationId xmlns:p14="http://schemas.microsoft.com/office/powerpoint/2010/main" val="3371829173"/>
       </p:ext>
     </p:extLst>
   </p:cSld>
@@ -1493,7 +1493,7 @@
           <p:cNvPr id="2" name="标题 1">
             <a:extLst>
               <a:ext uri="{FF2B5EF4-FFF2-40B4-BE49-F238E27FC236}">
-                <a16:creationId xmlns:a16="http://schemas.microsoft.com/office/drawing/2014/main" id="{A2EB2AD6-1CDA-1D42-C415-E0CE44FD3E43}"/>
+                <a16:creationId xmlns:a16="http://schemas.microsoft.com/office/drawing/2014/main" id="{B8BD012B-DC46-54C1-6980-A8829A575C29}"/>
               </a:ext>
             </a:extLst>
           </p:cNvPr>
@@ -1526,7 +1526,7 @@
           <p:cNvPr id="3" name="文本占位符 2">
             <a:extLst>
               <a:ext uri="{FF2B5EF4-FFF2-40B4-BE49-F238E27FC236}">
-                <a16:creationId xmlns:a16="http://schemas.microsoft.com/office/drawing/2014/main" id="{DD8025E2-E006-89E1-8B89-A2E8EE12A36E}"/>
+                <a16:creationId xmlns:a16="http://schemas.microsoft.com/office/drawing/2014/main" id="{45D48E36-21BC-46BF-1AED-844503849DAF}"/>
               </a:ext>
             </a:extLst>
           </p:cNvPr>
@@ -1597,7 +1597,7 @@
           <p:cNvPr id="4" name="内容占位符 3">
             <a:extLst>
               <a:ext uri="{FF2B5EF4-FFF2-40B4-BE49-F238E27FC236}">
-                <a16:creationId xmlns:a16="http://schemas.microsoft.com/office/drawing/2014/main" id="{4C456D9E-9593-542F-57E9-AC86E62236F2}"/>
+                <a16:creationId xmlns:a16="http://schemas.microsoft.com/office/drawing/2014/main" id="{F0051BAA-213A-2C59-FF05-92EBA45928F9}"/>
               </a:ext>
             </a:extLst>
           </p:cNvPr>
@@ -1659,7 +1659,7 @@
           <p:cNvPr id="5" name="文本占位符 4">
             <a:extLst>
               <a:ext uri="{FF2B5EF4-FFF2-40B4-BE49-F238E27FC236}">
-                <a16:creationId xmlns:a16="http://schemas.microsoft.com/office/drawing/2014/main" id="{D5A236F1-569A-806C-C038-FD86CDC9B6FC}"/>
+                <a16:creationId xmlns:a16="http://schemas.microsoft.com/office/drawing/2014/main" id="{E838B1D0-E89C-E75E-E080-6ECC3CA8BA47}"/>
               </a:ext>
             </a:extLst>
           </p:cNvPr>
@@ -1730,7 +1730,7 @@
           <p:cNvPr id="6" name="内容占位符 5">
             <a:extLst>
               <a:ext uri="{FF2B5EF4-FFF2-40B4-BE49-F238E27FC236}">
-                <a16:creationId xmlns:a16="http://schemas.microsoft.com/office/drawing/2014/main" id="{5DDB1B19-E557-6260-7594-7DFBB8131E76}"/>
+                <a16:creationId xmlns:a16="http://schemas.microsoft.com/office/drawing/2014/main" id="{70B94D84-A5C2-4BC5-D985-073A8F97F9B9}"/>
               </a:ext>
             </a:extLst>
           </p:cNvPr>
@@ -1792,7 +1792,7 @@
           <p:cNvPr id="7" name="日期占位符 6">
             <a:extLst>
               <a:ext uri="{FF2B5EF4-FFF2-40B4-BE49-F238E27FC236}">
-                <a16:creationId xmlns:a16="http://schemas.microsoft.com/office/drawing/2014/main" id="{DB507602-076A-51E5-D14D-FC7AFC703FD6}"/>
+                <a16:creationId xmlns:a16="http://schemas.microsoft.com/office/drawing/2014/main" id="{F9682FDF-E406-581D-A0E5-99EB659A93D2}"/>
               </a:ext>
             </a:extLst>
           </p:cNvPr>
@@ -1808,9 +1808,9 @@
           <a:bodyPr/>
           <a:lstStyle/>
           <a:p>
-            <a:fld id="{0FDF490C-865A-46A7-9644-4676E9929DDD}" type="datetimeFigureOut">
+            <a:fld id="{BE8E5DDC-8DBC-495D-83D8-7932EBA21A75}" type="datetimeFigureOut">
               <a:rPr lang="zh-CN" altLang="en-US" smtClean="0"/>
-              <a:t>2026/10/12</a:t>
+              <a:t>2026/10/13</a:t>
             </a:fld>
             <a:endParaRPr lang="zh-CN" altLang="en-US"/>
           </a:p>
@@ -1821,7 +1821,7 @@
           <p:cNvPr id="8" name="页脚占位符 7">
             <a:extLst>
               <a:ext uri="{FF2B5EF4-FFF2-40B4-BE49-F238E27FC236}">
-                <a16:creationId xmlns:a16="http://schemas.microsoft.com/office/drawing/2014/main" id="{4C2507F9-CCF0-568E-86F4-A8B50CCB9E34}"/>
+                <a16:creationId xmlns:a16="http://schemas.microsoft.com/office/drawing/2014/main" id="{BAA82327-B930-1FF4-CBBB-30017966D515}"/>
               </a:ext>
             </a:extLst>
           </p:cNvPr>
@@ -1846,7 +1846,7 @@
           <p:cNvPr id="9" name="灯片编号占位符 8">
             <a:extLst>
               <a:ext uri="{FF2B5EF4-FFF2-40B4-BE49-F238E27FC236}">
-                <a16:creationId xmlns:a16="http://schemas.microsoft.com/office/drawing/2014/main" id="{870FCF05-AC4A-48B6-9427-CAF8A06E1443}"/>
+                <a16:creationId xmlns:a16="http://schemas.microsoft.com/office/drawing/2014/main" id="{8F17A444-88FB-B13B-2688-53648FEDA8E0}"/>
               </a:ext>
             </a:extLst>
           </p:cNvPr>
@@ -1862,7 +1862,7 @@
           <a:bodyPr/>
           <a:lstStyle/>
           <a:p>
-            <a:fld id="{7C259DA1-6AAB-40E2-800A-C51A0D9D0A1F}" type="slidenum">
+            <a:fld id="{41F10874-7FDD-43DA-9458-5F9582894316}" type="slidenum">
               <a:rPr lang="zh-CN" altLang="en-US" smtClean="0"/>
               <a:t>‹#›</a:t>
             </a:fld>
@@ -1873,7 +1873,7 @@
     </p:spTree>
     <p:extLst>
       <p:ext uri="{BB962C8B-B14F-4D97-AF65-F5344CB8AC3E}">
-        <p14:creationId xmlns:p14="http://schemas.microsoft.com/office/powerpoint/2010/main" val="412664401"/>
+        <p14:creationId xmlns:p14="http://schemas.microsoft.com/office/powerpoint/2010/main" val="3390688890"/>
       </p:ext>
     </p:extLst>
   </p:cSld>
@@ -1905,7 +1905,7 @@
           <p:cNvPr id="2" name="标题 1">
             <a:extLst>
               <a:ext uri="{FF2B5EF4-FFF2-40B4-BE49-F238E27FC236}">
-                <a16:creationId xmlns:a16="http://schemas.microsoft.com/office/drawing/2014/main" id="{CA2EC9B2-AAFE-28F8-D4C5-9A9041B84EE3}"/>
+                <a16:creationId xmlns:a16="http://schemas.microsoft.com/office/drawing/2014/main" id="{C922E0C5-F38D-2E6B-2CE1-5DA7D7A03A0F}"/>
               </a:ext>
             </a:extLst>
           </p:cNvPr>
@@ -1933,7 +1933,7 @@
           <p:cNvPr id="3" name="日期占位符 2">
             <a:extLst>
               <a:ext uri="{FF2B5EF4-FFF2-40B4-BE49-F238E27FC236}">
-                <a16:creationId xmlns:a16="http://schemas.microsoft.com/office/drawing/2014/main" id="{C27D2C00-342D-E8DB-4A96-A5A5B9960090}"/>
+                <a16:creationId xmlns:a16="http://schemas.microsoft.com/office/drawing/2014/main" id="{66FB5951-6560-686F-DC96-335BD9D2E9F7}"/>
               </a:ext>
             </a:extLst>
           </p:cNvPr>
@@ -1949,9 +1949,9 @@
           <a:bodyPr/>
           <a:lstStyle/>
           <a:p>
-            <a:fld id="{0FDF490C-865A-46A7-9644-4676E9929DDD}" type="datetimeFigureOut">
+            <a:fld id="{BE8E5DDC-8DBC-495D-83D8-7932EBA21A75}" type="datetimeFigureOut">
               <a:rPr lang="zh-CN" altLang="en-US" smtClean="0"/>
-              <a:t>2026/10/12</a:t>
+              <a:t>2026/10/13</a:t>
             </a:fld>
             <a:endParaRPr lang="zh-CN" altLang="en-US"/>
           </a:p>
@@ -1962,7 +1962,7 @@
           <p:cNvPr id="4" name="页脚占位符 3">
             <a:extLst>
               <a:ext uri="{FF2B5EF4-FFF2-40B4-BE49-F238E27FC236}">
-                <a16:creationId xmlns:a16="http://schemas.microsoft.com/office/drawing/2014/main" id="{B30A2369-6ADE-F172-B0AB-2FBD9A10EECF}"/>
+                <a16:creationId xmlns:a16="http://schemas.microsoft.com/office/drawing/2014/main" id="{094B6044-8D8B-892D-2338-BF77058C54E0}"/>
               </a:ext>
             </a:extLst>
           </p:cNvPr>
@@ -1987,7 +1987,7 @@
           <p:cNvPr id="5" name="灯片编号占位符 4">
             <a:extLst>
               <a:ext uri="{FF2B5EF4-FFF2-40B4-BE49-F238E27FC236}">
-                <a16:creationId xmlns:a16="http://schemas.microsoft.com/office/drawing/2014/main" id="{17C49AE2-84E1-924F-8CC0-7235A535DE07}"/>
+                <a16:creationId xmlns:a16="http://schemas.microsoft.com/office/drawing/2014/main" id="{E7ECE743-EBAB-8D2C-EFB5-F1A8AC78A8B5}"/>
               </a:ext>
             </a:extLst>
           </p:cNvPr>
@@ -2003,7 +2003,7 @@
           <a:bodyPr/>
           <a:lstStyle/>
           <a:p>
-            <a:fld id="{7C259DA1-6AAB-40E2-800A-C51A0D9D0A1F}" type="slidenum">
+            <a:fld id="{41F10874-7FDD-43DA-9458-5F9582894316}" type="slidenum">
               <a:rPr lang="zh-CN" altLang="en-US" smtClean="0"/>
               <a:t>‹#›</a:t>
             </a:fld>
@@ -2014,7 +2014,7 @@
     </p:spTree>
     <p:extLst>
       <p:ext uri="{BB962C8B-B14F-4D97-AF65-F5344CB8AC3E}">
-        <p14:creationId xmlns:p14="http://schemas.microsoft.com/office/powerpoint/2010/main" val="2862717728"/>
+        <p14:creationId xmlns:p14="http://schemas.microsoft.com/office/powerpoint/2010/main" val="2037880767"/>
       </p:ext>
     </p:extLst>
   </p:cSld>
@@ -2046,7 +2046,7 @@
           <p:cNvPr id="2" name="日期占位符 1">
             <a:extLst>
               <a:ext uri="{FF2B5EF4-FFF2-40B4-BE49-F238E27FC236}">
-                <a16:creationId xmlns:a16="http://schemas.microsoft.com/office/drawing/2014/main" id="{4120B774-DBE2-EB25-F4D0-E14C88A9A256}"/>
+                <a16:creationId xmlns:a16="http://schemas.microsoft.com/office/drawing/2014/main" id="{360AD8FB-EFD9-DB0F-849C-C4730F889C48}"/>
               </a:ext>
             </a:extLst>
           </p:cNvPr>
@@ -2062,9 +2062,9 @@
           <a:bodyPr/>
           <a:lstStyle/>
           <a:p>
-            <a:fld id="{0FDF490C-865A-46A7-9644-4676E9929DDD}" type="datetimeFigureOut">
+            <a:fld id="{BE8E5DDC-8DBC-495D-83D8-7932EBA21A75}" type="datetimeFigureOut">
               <a:rPr lang="zh-CN" altLang="en-US" smtClean="0"/>
-              <a:t>2026/10/12</a:t>
+              <a:t>2026/10/13</a:t>
             </a:fld>
             <a:endParaRPr lang="zh-CN" altLang="en-US"/>
           </a:p>
@@ -2075,7 +2075,7 @@
           <p:cNvPr id="3" name="页脚占位符 2">
             <a:extLst>
               <a:ext uri="{FF2B5EF4-FFF2-40B4-BE49-F238E27FC236}">
-                <a16:creationId xmlns:a16="http://schemas.microsoft.com/office/drawing/2014/main" id="{EFCB3A96-C357-6A14-0F3F-DDD44AFF8F04}"/>
+                <a16:creationId xmlns:a16="http://schemas.microsoft.com/office/drawing/2014/main" id="{2B1B5294-2361-7470-8295-13DCC65BC7D7}"/>
               </a:ext>
             </a:extLst>
           </p:cNvPr>
@@ -2100,7 +2100,7 @@
           <p:cNvPr id="4" name="灯片编号占位符 3">
             <a:extLst>
               <a:ext uri="{FF2B5EF4-FFF2-40B4-BE49-F238E27FC236}">
-                <a16:creationId xmlns:a16="http://schemas.microsoft.com/office/drawing/2014/main" id="{A48B30B9-F865-1BB4-EC84-E19B024EB142}"/>
+                <a16:creationId xmlns:a16="http://schemas.microsoft.com/office/drawing/2014/main" id="{CEDE758B-2074-AC60-17BB-C9D47B433D71}"/>
               </a:ext>
             </a:extLst>
           </p:cNvPr>
@@ -2116,7 +2116,7 @@
           <a:bodyPr/>
           <a:lstStyle/>
           <a:p>
-            <a:fld id="{7C259DA1-6AAB-40E2-800A-C51A0D9D0A1F}" type="slidenum">
+            <a:fld id="{41F10874-7FDD-43DA-9458-5F9582894316}" type="slidenum">
               <a:rPr lang="zh-CN" altLang="en-US" smtClean="0"/>
               <a:t>‹#›</a:t>
             </a:fld>
@@ -2127,7 +2127,7 @@
     </p:spTree>
     <p:extLst>
       <p:ext uri="{BB962C8B-B14F-4D97-AF65-F5344CB8AC3E}">
-        <p14:creationId xmlns:p14="http://schemas.microsoft.com/office/powerpoint/2010/main" val="4173332216"/>
+        <p14:creationId xmlns:p14="http://schemas.microsoft.com/office/powerpoint/2010/main" val="2237687775"/>
       </p:ext>
     </p:extLst>
   </p:cSld>
@@ -2159,7 +2159,7 @@
           <p:cNvPr id="2" name="标题 1">
             <a:extLst>
               <a:ext uri="{FF2B5EF4-FFF2-40B4-BE49-F238E27FC236}">
-                <a16:creationId xmlns:a16="http://schemas.microsoft.com/office/drawing/2014/main" id="{DE404844-B683-F891-73E8-BF0F9B04B80C}"/>
+                <a16:creationId xmlns:a16="http://schemas.microsoft.com/office/drawing/2014/main" id="{452C6EC2-551F-1FFE-BE75-9E732AEBC34F}"/>
               </a:ext>
             </a:extLst>
           </p:cNvPr>
@@ -2196,7 +2196,7 @@
           <p:cNvPr id="3" name="内容占位符 2">
             <a:extLst>
               <a:ext uri="{FF2B5EF4-FFF2-40B4-BE49-F238E27FC236}">
-                <a16:creationId xmlns:a16="http://schemas.microsoft.com/office/drawing/2014/main" id="{C66EFC7A-7944-7DAC-F5A7-219C9CD96F8A}"/>
+                <a16:creationId xmlns:a16="http://schemas.microsoft.com/office/drawing/2014/main" id="{25177CDB-20FD-F51A-84E2-AB04393BE591}"/>
               </a:ext>
             </a:extLst>
           </p:cNvPr>
@@ -2286,7 +2286,7 @@
           <p:cNvPr id="4" name="文本占位符 3">
             <a:extLst>
               <a:ext uri="{FF2B5EF4-FFF2-40B4-BE49-F238E27FC236}">
-                <a16:creationId xmlns:a16="http://schemas.microsoft.com/office/drawing/2014/main" id="{8ED50E23-7FA8-BCCE-09F2-821BFAB1B790}"/>
+                <a16:creationId xmlns:a16="http://schemas.microsoft.com/office/drawing/2014/main" id="{43555D83-1717-3B8B-8DF9-EA3067F802AE}"/>
               </a:ext>
             </a:extLst>
           </p:cNvPr>
@@ -2357,7 +2357,7 @@
           <p:cNvPr id="5" name="日期占位符 4">
             <a:extLst>
               <a:ext uri="{FF2B5EF4-FFF2-40B4-BE49-F238E27FC236}">
-                <a16:creationId xmlns:a16="http://schemas.microsoft.com/office/drawing/2014/main" id="{37E5178B-DF7E-C34D-6022-14CBF02CAB68}"/>
+                <a16:creationId xmlns:a16="http://schemas.microsoft.com/office/drawing/2014/main" id="{4600AE04-8111-A131-ABAA-206697F823A8}"/>
               </a:ext>
             </a:extLst>
           </p:cNvPr>
@@ -2373,9 +2373,9 @@
           <a:bodyPr/>
           <a:lstStyle/>
           <a:p>
-            <a:fld id="{0FDF490C-865A-46A7-9644-4676E9929DDD}" type="datetimeFigureOut">
+            <a:fld id="{BE8E5DDC-8DBC-495D-83D8-7932EBA21A75}" type="datetimeFigureOut">
               <a:rPr lang="zh-CN" altLang="en-US" smtClean="0"/>
-              <a:t>2026/10/12</a:t>
+              <a:t>2026/10/13</a:t>
             </a:fld>
             <a:endParaRPr lang="zh-CN" altLang="en-US"/>
           </a:p>
@@ -2386,7 +2386,7 @@
           <p:cNvPr id="6" name="页脚占位符 5">
             <a:extLst>
               <a:ext uri="{FF2B5EF4-FFF2-40B4-BE49-F238E27FC236}">
-                <a16:creationId xmlns:a16="http://schemas.microsoft.com/office/drawing/2014/main" id="{38B36F55-8D6A-D6FC-6F96-534AE5E39239}"/>
+                <a16:creationId xmlns:a16="http://schemas.microsoft.com/office/drawing/2014/main" id="{707C7EAD-9961-DD31-037D-1C4798FFCBCE}"/>
               </a:ext>
             </a:extLst>
           </p:cNvPr>
@@ -2411,7 +2411,7 @@
           <p:cNvPr id="7" name="灯片编号占位符 6">
             <a:extLst>
               <a:ext uri="{FF2B5EF4-FFF2-40B4-BE49-F238E27FC236}">
-                <a16:creationId xmlns:a16="http://schemas.microsoft.com/office/drawing/2014/main" id="{306BBA19-A0F1-1983-5D07-FB4EE8876D0E}"/>
+                <a16:creationId xmlns:a16="http://schemas.microsoft.com/office/drawing/2014/main" id="{32AF2F69-E7E5-C713-43D2-EDC87291EED0}"/>
               </a:ext>
             </a:extLst>
           </p:cNvPr>
@@ -2427,7 +2427,7 @@
           <a:bodyPr/>
           <a:lstStyle/>
           <a:p>
-            <a:fld id="{7C259DA1-6AAB-40E2-800A-C51A0D9D0A1F}" type="slidenum">
+            <a:fld id="{41F10874-7FDD-43DA-9458-5F9582894316}" type="slidenum">
               <a:rPr lang="zh-CN" altLang="en-US" smtClean="0"/>
               <a:t>‹#›</a:t>
             </a:fld>
@@ -2438,7 +2438,7 @@
     </p:spTree>
     <p:extLst>
       <p:ext uri="{BB962C8B-B14F-4D97-AF65-F5344CB8AC3E}">
-        <p14:creationId xmlns:p14="http://schemas.microsoft.com/office/powerpoint/2010/main" val="3934420486"/>
+        <p14:creationId xmlns:p14="http://schemas.microsoft.com/office/powerpoint/2010/main" val="2888055600"/>
       </p:ext>
     </p:extLst>
   </p:cSld>
@@ -2470,7 +2470,7 @@
           <p:cNvPr id="2" name="标题 1">
             <a:extLst>
               <a:ext uri="{FF2B5EF4-FFF2-40B4-BE49-F238E27FC236}">
-                <a16:creationId xmlns:a16="http://schemas.microsoft.com/office/drawing/2014/main" id="{57748ACC-2D67-2179-203C-705DE290A198}"/>
+                <a16:creationId xmlns:a16="http://schemas.microsoft.com/office/drawing/2014/main" id="{DEF0E797-9076-C6BF-AB87-C3906BC7CFAE}"/>
               </a:ext>
             </a:extLst>
           </p:cNvPr>
@@ -2507,7 +2507,7 @@
           <p:cNvPr id="3" name="图片占位符 2">
             <a:extLst>
               <a:ext uri="{FF2B5EF4-FFF2-40B4-BE49-F238E27FC236}">
-                <a16:creationId xmlns:a16="http://schemas.microsoft.com/office/drawing/2014/main" id="{CEF32063-EE8E-296E-3341-D669CC261C3F}"/>
+                <a16:creationId xmlns:a16="http://schemas.microsoft.com/office/drawing/2014/main" id="{1FC206D9-B7C7-D077-D7A5-F2E8592E2A47}"/>
               </a:ext>
             </a:extLst>
           </p:cNvPr>
@@ -2574,7 +2574,7 @@
           <p:cNvPr id="4" name="文本占位符 3">
             <a:extLst>
               <a:ext uri="{FF2B5EF4-FFF2-40B4-BE49-F238E27FC236}">
-                <a16:creationId xmlns:a16="http://schemas.microsoft.com/office/drawing/2014/main" id="{9C654DD9-FD63-6972-0E4C-BC4C3FE63952}"/>
+                <a16:creationId xmlns:a16="http://schemas.microsoft.com/office/drawing/2014/main" id="{6738D70A-F53A-117C-905C-D915D3FEAD8C}"/>
               </a:ext>
             </a:extLst>
           </p:cNvPr>
@@ -2645,7 +2645,7 @@
           <p:cNvPr id="5" name="日期占位符 4">
             <a:extLst>
               <a:ext uri="{FF2B5EF4-FFF2-40B4-BE49-F238E27FC236}">
-                <a16:creationId xmlns:a16="http://schemas.microsoft.com/office/drawing/2014/main" id="{C1BD7881-888E-2116-0536-19E4FB70CC60}"/>
+                <a16:creationId xmlns:a16="http://schemas.microsoft.com/office/drawing/2014/main" id="{4CCF0C5A-7C78-6D5F-075A-098B911D8901}"/>
               </a:ext>
             </a:extLst>
           </p:cNvPr>
@@ -2661,9 +2661,9 @@
           <a:bodyPr/>
           <a:lstStyle/>
           <a:p>
-            <a:fld id="{0FDF490C-865A-46A7-9644-4676E9929DDD}" type="datetimeFigureOut">
+            <a:fld id="{BE8E5DDC-8DBC-495D-83D8-7932EBA21A75}" type="datetimeFigureOut">
               <a:rPr lang="zh-CN" altLang="en-US" smtClean="0"/>
-              <a:t>2026/10/12</a:t>
+              <a:t>2026/10/13</a:t>
             </a:fld>
             <a:endParaRPr lang="zh-CN" altLang="en-US"/>
           </a:p>
@@ -2674,7 +2674,7 @@
           <p:cNvPr id="6" name="页脚占位符 5">
             <a:extLst>
               <a:ext uri="{FF2B5EF4-FFF2-40B4-BE49-F238E27FC236}">
-                <a16:creationId xmlns:a16="http://schemas.microsoft.com/office/drawing/2014/main" id="{44A18864-E8CA-B4DA-2B49-13DD1A05E7BA}"/>
+                <a16:creationId xmlns:a16="http://schemas.microsoft.com/office/drawing/2014/main" id="{EAA5ED8E-98FD-6570-326B-079B5CB7FF08}"/>
               </a:ext>
             </a:extLst>
           </p:cNvPr>
@@ -2699,7 +2699,7 @@
           <p:cNvPr id="7" name="灯片编号占位符 6">
             <a:extLst>
               <a:ext uri="{FF2B5EF4-FFF2-40B4-BE49-F238E27FC236}">
-                <a16:creationId xmlns:a16="http://schemas.microsoft.com/office/drawing/2014/main" id="{6AF8C758-68AC-6BA4-4BF0-3F712525A6E2}"/>
+                <a16:creationId xmlns:a16="http://schemas.microsoft.com/office/drawing/2014/main" id="{BE63E2F0-3472-BA92-2EE8-8F6533EEEE37}"/>
               </a:ext>
             </a:extLst>
           </p:cNvPr>
@@ -2715,7 +2715,7 @@
           <a:bodyPr/>
           <a:lstStyle/>
           <a:p>
-            <a:fld id="{7C259DA1-6AAB-40E2-800A-C51A0D9D0A1F}" type="slidenum">
+            <a:fld id="{41F10874-7FDD-43DA-9458-5F9582894316}" type="slidenum">
               <a:rPr lang="zh-CN" altLang="en-US" smtClean="0"/>
               <a:t>‹#›</a:t>
             </a:fld>
@@ -2726,7 +2726,7 @@
     </p:spTree>
     <p:extLst>
       <p:ext uri="{BB962C8B-B14F-4D97-AF65-F5344CB8AC3E}">
-        <p14:creationId xmlns:p14="http://schemas.microsoft.com/office/powerpoint/2010/main" val="2258290619"/>
+        <p14:creationId xmlns:p14="http://schemas.microsoft.com/office/powerpoint/2010/main" val="803427723"/>
       </p:ext>
     </p:extLst>
   </p:cSld>
@@ -2763,7 +2763,7 @@
           <p:cNvPr id="2" name="标题占位符 1">
             <a:extLst>
               <a:ext uri="{FF2B5EF4-FFF2-40B4-BE49-F238E27FC236}">
-                <a16:creationId xmlns:a16="http://schemas.microsoft.com/office/drawing/2014/main" id="{3CA6654B-2809-AFA7-1240-1C0614ADD38E}"/>
+                <a16:creationId xmlns:a16="http://schemas.microsoft.com/office/drawing/2014/main" id="{F32B1E35-1CD3-DEB8-6765-865EA0A035AE}"/>
               </a:ext>
             </a:extLst>
           </p:cNvPr>
@@ -2801,7 +2801,7 @@
           <p:cNvPr id="3" name="文本占位符 2">
             <a:extLst>
               <a:ext uri="{FF2B5EF4-FFF2-40B4-BE49-F238E27FC236}">
-                <a16:creationId xmlns:a16="http://schemas.microsoft.com/office/drawing/2014/main" id="{A733D867-9C33-222C-C0C9-19F75C6544D3}"/>
+                <a16:creationId xmlns:a16="http://schemas.microsoft.com/office/drawing/2014/main" id="{D6F23B91-C5FF-DA89-DD24-C7A193B18FDB}"/>
               </a:ext>
             </a:extLst>
           </p:cNvPr>
@@ -2868,7 +2868,7 @@
           <p:cNvPr id="4" name="日期占位符 3">
             <a:extLst>
               <a:ext uri="{FF2B5EF4-FFF2-40B4-BE49-F238E27FC236}">
-                <a16:creationId xmlns:a16="http://schemas.microsoft.com/office/drawing/2014/main" id="{B010D3F6-DA34-AEA3-E610-277E2B045D58}"/>
+                <a16:creationId xmlns:a16="http://schemas.microsoft.com/office/drawing/2014/main" id="{A01F3C51-5ECA-677F-C797-96A575FD6DF1}"/>
               </a:ext>
             </a:extLst>
           </p:cNvPr>
@@ -2902,9 +2902,9 @@
             </a:lvl1pPr>
           </a:lstStyle>
           <a:p>
-            <a:fld id="{0FDF490C-865A-46A7-9644-4676E9929DDD}" type="datetimeFigureOut">
+            <a:fld id="{BE8E5DDC-8DBC-495D-83D8-7932EBA21A75}" type="datetimeFigureOut">
               <a:rPr lang="zh-CN" altLang="en-US" smtClean="0"/>
-              <a:t>2026/10/12</a:t>
+              <a:t>2026/10/13</a:t>
             </a:fld>
             <a:endParaRPr lang="zh-CN" altLang="en-US"/>
           </a:p>
@@ -2915,7 +2915,7 @@
           <p:cNvPr id="5" name="页脚占位符 4">
             <a:extLst>
               <a:ext uri="{FF2B5EF4-FFF2-40B4-BE49-F238E27FC236}">
-                <a16:creationId xmlns:a16="http://schemas.microsoft.com/office/drawing/2014/main" id="{B1A852DF-5A55-41BA-A547-4C4ECE50A794}"/>
+                <a16:creationId xmlns:a16="http://schemas.microsoft.com/office/drawing/2014/main" id="{D136B8A2-35F5-FF93-15AC-54AA3734753A}"/>
               </a:ext>
             </a:extLst>
           </p:cNvPr>
@@ -2958,7 +2958,7 @@
           <p:cNvPr id="6" name="灯片编号占位符 5">
             <a:extLst>
               <a:ext uri="{FF2B5EF4-FFF2-40B4-BE49-F238E27FC236}">
-                <a16:creationId xmlns:a16="http://schemas.microsoft.com/office/drawing/2014/main" id="{81DD0A27-CCCF-E059-C98E-8D18694254DC}"/>
+                <a16:creationId xmlns:a16="http://schemas.microsoft.com/office/drawing/2014/main" id="{7F5A1667-2070-4521-8776-9E3BA04A7AD4}"/>
               </a:ext>
             </a:extLst>
           </p:cNvPr>
@@ -2992,7 +2992,7 @@
             </a:lvl1pPr>
           </a:lstStyle>
           <a:p>
-            <a:fld id="{7C259DA1-6AAB-40E2-800A-C51A0D9D0A1F}" type="slidenum">
+            <a:fld id="{41F10874-7FDD-43DA-9458-5F9582894316}" type="slidenum">
               <a:rPr lang="zh-CN" altLang="en-US" smtClean="0"/>
               <a:t>‹#›</a:t>
             </a:fld>
@@ -3003,7 +3003,7 @@
     </p:spTree>
     <p:extLst>
       <p:ext uri="{BB962C8B-B14F-4D97-AF65-F5344CB8AC3E}">
-        <p14:creationId xmlns:p14="http://schemas.microsoft.com/office/powerpoint/2010/main" val="2906134052"/>
+        <p14:creationId xmlns:p14="http://schemas.microsoft.com/office/powerpoint/2010/main" val="4004596357"/>
       </p:ext>
     </p:extLst>
   </p:cSld>
@@ -3326,7 +3326,7 @@
           <p:cNvPr id="2" name="poster title">
             <a:extLst>
               <a:ext uri="{FF2B5EF4-FFF2-40B4-BE49-F238E27FC236}">
-                <a16:creationId xmlns:a16="http://schemas.microsoft.com/office/drawing/2014/main" id="{6C744693-9816-5078-F864-9EBD8BC27B2C}"/>
+                <a16:creationId xmlns:a16="http://schemas.microsoft.com/office/drawing/2014/main" id="{D907E541-EF34-F777-2F78-D43B7DE421ED}"/>
               </a:ext>
             </a:extLst>
           </p:cNvPr>
@@ -3372,7 +3372,7 @@
           <p:cNvPr id="3" name="subtitle">
             <a:extLst>
               <a:ext uri="{FF2B5EF4-FFF2-40B4-BE49-F238E27FC236}">
-                <a16:creationId xmlns:a16="http://schemas.microsoft.com/office/drawing/2014/main" id="{4004AA05-DCDC-311D-1357-068A645B8D9B}"/>
+                <a16:creationId xmlns:a16="http://schemas.microsoft.com/office/drawing/2014/main" id="{998AA84E-C807-05F6-FB5F-4AD2506BBB4E}"/>
               </a:ext>
             </a:extLst>
           </p:cNvPr>
@@ -3418,7 +3418,7 @@
           <p:cNvPr id="4" name="stat 0">
             <a:extLst>
               <a:ext uri="{FF2B5EF4-FFF2-40B4-BE49-F238E27FC236}">
-                <a16:creationId xmlns:a16="http://schemas.microsoft.com/office/drawing/2014/main" id="{8672DFDA-3B96-B90A-849A-9E4EDA5AE92A}"/>
+                <a16:creationId xmlns:a16="http://schemas.microsoft.com/office/drawing/2014/main" id="{27771538-55D1-75AF-C390-0A6E44361034}"/>
               </a:ext>
             </a:extLst>
           </p:cNvPr>
@@ -3488,7 +3488,7 @@
           <p:cNvPr id="5" name="stat value 0">
             <a:extLst>
               <a:ext uri="{FF2B5EF4-FFF2-40B4-BE49-F238E27FC236}">
-                <a16:creationId xmlns:a16="http://schemas.microsoft.com/office/drawing/2014/main" id="{1E122D7F-2E09-2142-A857-B41F3D047DDB}"/>
+                <a16:creationId xmlns:a16="http://schemas.microsoft.com/office/drawing/2014/main" id="{A363A2A9-4BED-64C2-1465-0A820B622D92}"/>
               </a:ext>
             </a:extLst>
           </p:cNvPr>
@@ -3534,7 +3534,7 @@
           <p:cNvPr id="6" name="stat label 0">
             <a:extLst>
               <a:ext uri="{FF2B5EF4-FFF2-40B4-BE49-F238E27FC236}">
-                <a16:creationId xmlns:a16="http://schemas.microsoft.com/office/drawing/2014/main" id="{5F689573-C2E5-1731-016C-8113B43196BE}"/>
+                <a16:creationId xmlns:a16="http://schemas.microsoft.com/office/drawing/2014/main" id="{4A2B69FD-3621-6623-CF9B-C2A066A6E1C3}"/>
               </a:ext>
             </a:extLst>
           </p:cNvPr>
@@ -3580,7 +3580,7 @@
           <p:cNvPr id="7" name="stat 1">
             <a:extLst>
               <a:ext uri="{FF2B5EF4-FFF2-40B4-BE49-F238E27FC236}">
-                <a16:creationId xmlns:a16="http://schemas.microsoft.com/office/drawing/2014/main" id="{B8A9D80E-4ACC-F71C-B19E-64714F2FD759}"/>
+                <a16:creationId xmlns:a16="http://schemas.microsoft.com/office/drawing/2014/main" id="{81912138-8AD2-9F88-9DC3-FAB53BCA9D25}"/>
               </a:ext>
             </a:extLst>
           </p:cNvPr>
@@ -3650,7 +3650,7 @@
           <p:cNvPr id="8" name="stat value 1">
             <a:extLst>
               <a:ext uri="{FF2B5EF4-FFF2-40B4-BE49-F238E27FC236}">
-                <a16:creationId xmlns:a16="http://schemas.microsoft.com/office/drawing/2014/main" id="{4C304B33-64A3-E667-4ABF-130BBF70489B}"/>
+                <a16:creationId xmlns:a16="http://schemas.microsoft.com/office/drawing/2014/main" id="{7006E723-2FC2-5D12-0A79-8A37EB2EA2C4}"/>
               </a:ext>
             </a:extLst>
           </p:cNvPr>
@@ -3696,7 +3696,7 @@
           <p:cNvPr id="9" name="stat label 1">
             <a:extLst>
               <a:ext uri="{FF2B5EF4-FFF2-40B4-BE49-F238E27FC236}">
-                <a16:creationId xmlns:a16="http://schemas.microsoft.com/office/drawing/2014/main" id="{B09D15A0-2739-6770-5405-66483B287B59}"/>
+                <a16:creationId xmlns:a16="http://schemas.microsoft.com/office/drawing/2014/main" id="{ADAF3ECF-49CC-3638-D39F-7E3363622112}"/>
               </a:ext>
             </a:extLst>
           </p:cNvPr>
@@ -3742,7 +3742,7 @@
           <p:cNvPr id="10" name="stat 2">
             <a:extLst>
               <a:ext uri="{FF2B5EF4-FFF2-40B4-BE49-F238E27FC236}">
-                <a16:creationId xmlns:a16="http://schemas.microsoft.com/office/drawing/2014/main" id="{086AAF36-8CAB-E977-E7D4-06FF2FB77834}"/>
+                <a16:creationId xmlns:a16="http://schemas.microsoft.com/office/drawing/2014/main" id="{CD0E532C-7D9C-3310-229A-195E092ED09E}"/>
               </a:ext>
             </a:extLst>
           </p:cNvPr>
@@ -3812,7 +3812,7 @@
           <p:cNvPr id="11" name="stat value 2">
             <a:extLst>
               <a:ext uri="{FF2B5EF4-FFF2-40B4-BE49-F238E27FC236}">
-                <a16:creationId xmlns:a16="http://schemas.microsoft.com/office/drawing/2014/main" id="{91CA04AB-147D-7C65-4BCA-4B8FE19CD36E}"/>
+                <a16:creationId xmlns:a16="http://schemas.microsoft.com/office/drawing/2014/main" id="{0551E793-5B4E-913D-B64F-9019B977CB41}"/>
               </a:ext>
             </a:extLst>
           </p:cNvPr>
@@ -3858,7 +3858,7 @@
           <p:cNvPr id="12" name="stat label 2">
             <a:extLst>
               <a:ext uri="{FF2B5EF4-FFF2-40B4-BE49-F238E27FC236}">
-                <a16:creationId xmlns:a16="http://schemas.microsoft.com/office/drawing/2014/main" id="{882E9260-A822-ACDA-D436-8706F1711AE6}"/>
+                <a16:creationId xmlns:a16="http://schemas.microsoft.com/office/drawing/2014/main" id="{DE7B3DB0-C377-A60A-E67B-C3558E0C5287}"/>
               </a:ext>
             </a:extLst>
           </p:cNvPr>
@@ -3904,7 +3904,7 @@
           <p:cNvPr id="13" name="stat 3">
             <a:extLst>
               <a:ext uri="{FF2B5EF4-FFF2-40B4-BE49-F238E27FC236}">
-                <a16:creationId xmlns:a16="http://schemas.microsoft.com/office/drawing/2014/main" id="{B01B911C-6A59-3524-A9A7-BE912F918C39}"/>
+                <a16:creationId xmlns:a16="http://schemas.microsoft.com/office/drawing/2014/main" id="{180F8A2F-1348-FC90-9AD8-1A93F7614F3E}"/>
               </a:ext>
             </a:extLst>
           </p:cNvPr>
@@ -3974,7 +3974,7 @@
           <p:cNvPr id="14" name="stat value 3">
             <a:extLst>
               <a:ext uri="{FF2B5EF4-FFF2-40B4-BE49-F238E27FC236}">
-                <a16:creationId xmlns:a16="http://schemas.microsoft.com/office/drawing/2014/main" id="{F5CF9537-3674-DAC4-D5AE-28CAA6F86CB6}"/>
+                <a16:creationId xmlns:a16="http://schemas.microsoft.com/office/drawing/2014/main" id="{9F4908E6-E41D-1AA8-A20D-3439B6954E66}"/>
               </a:ext>
             </a:extLst>
           </p:cNvPr>
@@ -4020,7 +4020,7 @@
           <p:cNvPr id="15" name="stat label 3">
             <a:extLst>
               <a:ext uri="{FF2B5EF4-FFF2-40B4-BE49-F238E27FC236}">
-                <a16:creationId xmlns:a16="http://schemas.microsoft.com/office/drawing/2014/main" id="{07E3297C-3387-4268-F54C-E54F70674522}"/>
+                <a16:creationId xmlns:a16="http://schemas.microsoft.com/office/drawing/2014/main" id="{674804A4-7C5D-1E37-6AF8-FE5C6E635C57}"/>
               </a:ext>
             </a:extLst>
           </p:cNvPr>
@@ -4066,7 +4066,7 @@
           <p:cNvPr id="16" name="stat 4">
             <a:extLst>
               <a:ext uri="{FF2B5EF4-FFF2-40B4-BE49-F238E27FC236}">
-                <a16:creationId xmlns:a16="http://schemas.microsoft.com/office/drawing/2014/main" id="{2FCC626A-FA5A-EB2A-779E-C4DCFA9A5C51}"/>
+                <a16:creationId xmlns:a16="http://schemas.microsoft.com/office/drawing/2014/main" id="{7E97397A-D367-1FA6-0D00-1C5AC31F0941}"/>
               </a:ext>
             </a:extLst>
           </p:cNvPr>
@@ -4136,7 +4136,7 @@
           <p:cNvPr id="17" name="stat value 4">
             <a:extLst>
               <a:ext uri="{FF2B5EF4-FFF2-40B4-BE49-F238E27FC236}">
-                <a16:creationId xmlns:a16="http://schemas.microsoft.com/office/drawing/2014/main" id="{E46BEDDD-7862-9B63-9677-4806036D0BEF}"/>
+                <a16:creationId xmlns:a16="http://schemas.microsoft.com/office/drawing/2014/main" id="{8E3B7FAE-8796-02D6-0BC0-6D21A736D7FB}"/>
               </a:ext>
             </a:extLst>
           </p:cNvPr>
@@ -4182,7 +4182,7 @@
           <p:cNvPr id="18" name="stat label 4">
             <a:extLst>
               <a:ext uri="{FF2B5EF4-FFF2-40B4-BE49-F238E27FC236}">
-                <a16:creationId xmlns:a16="http://schemas.microsoft.com/office/drawing/2014/main" id="{FBFD4341-E23F-B298-2939-80185E04861C}"/>
+                <a16:creationId xmlns:a16="http://schemas.microsoft.com/office/drawing/2014/main" id="{29E01A97-9952-A90F-5E0A-84ADACADC824}"/>
               </a:ext>
             </a:extLst>
           </p:cNvPr>
@@ -4228,7 +4228,7 @@
           <p:cNvPr id="19" name="card 1">
             <a:extLst>
               <a:ext uri="{FF2B5EF4-FFF2-40B4-BE49-F238E27FC236}">
-                <a16:creationId xmlns:a16="http://schemas.microsoft.com/office/drawing/2014/main" id="{3E1C5252-8219-D5A7-8B4F-B8B8E33EC260}"/>
+                <a16:creationId xmlns:a16="http://schemas.microsoft.com/office/drawing/2014/main" id="{4AC753BA-EE6B-A0A5-628F-D7B597B1BCDE}"/>
               </a:ext>
             </a:extLst>
           </p:cNvPr>
@@ -4298,7 +4298,7 @@
           <p:cNvPr id="20" name="badge 1">
             <a:extLst>
               <a:ext uri="{FF2B5EF4-FFF2-40B4-BE49-F238E27FC236}">
-                <a16:creationId xmlns:a16="http://schemas.microsoft.com/office/drawing/2014/main" id="{9C6E937A-4E4A-98DC-E989-63FF7335EC55}"/>
+                <a16:creationId xmlns:a16="http://schemas.microsoft.com/office/drawing/2014/main" id="{58FE3D1B-E0FB-977D-DBB1-A630B16A147D}"/>
               </a:ext>
             </a:extLst>
           </p:cNvPr>
@@ -4380,7 +4380,7 @@
           <p:cNvPr id="21" name="title 1">
             <a:extLst>
               <a:ext uri="{FF2B5EF4-FFF2-40B4-BE49-F238E27FC236}">
-                <a16:creationId xmlns:a16="http://schemas.microsoft.com/office/drawing/2014/main" id="{2208C23C-5825-F510-C6B1-5A81D32138D7}"/>
+                <a16:creationId xmlns:a16="http://schemas.microsoft.com/office/drawing/2014/main" id="{1980FD73-0392-8696-07ED-278CB443C9CA}"/>
               </a:ext>
             </a:extLst>
           </p:cNvPr>
@@ -4426,7 +4426,7 @@
           <p:cNvPr id="23" name="图片 22">
             <a:extLst>
               <a:ext uri="{FF2B5EF4-FFF2-40B4-BE49-F238E27FC236}">
-                <a16:creationId xmlns:a16="http://schemas.microsoft.com/office/drawing/2014/main" id="{F4225661-19CC-E60A-2F60-CEA051D07C42}"/>
+                <a16:creationId xmlns:a16="http://schemas.microsoft.com/office/drawing/2014/main" id="{DA61493D-89FB-1E79-1FDD-A34D0C81CA46}"/>
               </a:ext>
             </a:extLst>
           </p:cNvPr>
@@ -4462,7 +4462,7 @@
           <p:cNvPr id="24" name="文本框 23">
             <a:extLst>
               <a:ext uri="{FF2B5EF4-FFF2-40B4-BE49-F238E27FC236}">
-                <a16:creationId xmlns:a16="http://schemas.microsoft.com/office/drawing/2014/main" id="{1A92A3ED-59EB-CDB3-9E51-E390E85DF2CD}"/>
+                <a16:creationId xmlns:a16="http://schemas.microsoft.com/office/drawing/2014/main" id="{E9B97563-FB0C-ACF3-839E-365332215162}"/>
               </a:ext>
             </a:extLst>
           </p:cNvPr>
@@ -4508,7 +4508,7 @@
           <p:cNvPr id="25" name="card 2">
             <a:extLst>
               <a:ext uri="{FF2B5EF4-FFF2-40B4-BE49-F238E27FC236}">
-                <a16:creationId xmlns:a16="http://schemas.microsoft.com/office/drawing/2014/main" id="{AACE9CBE-1248-BC62-1FBA-1D70970187D0}"/>
+                <a16:creationId xmlns:a16="http://schemas.microsoft.com/office/drawing/2014/main" id="{DFF6720A-2616-F078-81F9-ED51C91C2A5A}"/>
               </a:ext>
             </a:extLst>
           </p:cNvPr>
@@ -4578,7 +4578,7 @@
           <p:cNvPr id="26" name="badge 2">
             <a:extLst>
               <a:ext uri="{FF2B5EF4-FFF2-40B4-BE49-F238E27FC236}">
-                <a16:creationId xmlns:a16="http://schemas.microsoft.com/office/drawing/2014/main" id="{CAF971A8-973A-7733-27B4-6291A88F6EF2}"/>
+                <a16:creationId xmlns:a16="http://schemas.microsoft.com/office/drawing/2014/main" id="{A238221B-4497-1DE7-97A1-C417CCF17A63}"/>
               </a:ext>
             </a:extLst>
           </p:cNvPr>
@@ -4660,7 +4660,7 @@
           <p:cNvPr id="27" name="title 2">
             <a:extLst>
               <a:ext uri="{FF2B5EF4-FFF2-40B4-BE49-F238E27FC236}">
-                <a16:creationId xmlns:a16="http://schemas.microsoft.com/office/drawing/2014/main" id="{25FA2011-BA11-A350-78FA-A633BC2FC3DD}"/>
+                <a16:creationId xmlns:a16="http://schemas.microsoft.com/office/drawing/2014/main" id="{6DC44B0E-3293-AE9C-05E2-3982479DA8F8}"/>
               </a:ext>
             </a:extLst>
           </p:cNvPr>
@@ -4706,7 +4706,7 @@
           <p:cNvPr id="28" name="文本框 27">
             <a:extLst>
               <a:ext uri="{FF2B5EF4-FFF2-40B4-BE49-F238E27FC236}">
-                <a16:creationId xmlns:a16="http://schemas.microsoft.com/office/drawing/2014/main" id="{A9855358-4191-98B5-225E-85FCF56456B2}"/>
+                <a16:creationId xmlns:a16="http://schemas.microsoft.com/office/drawing/2014/main" id="{3AF1CD94-BBC1-2BBB-AA61-2D5EE9870D54}"/>
               </a:ext>
             </a:extLst>
           </p:cNvPr>
@@ -4753,7 +4753,7 @@
           <p:cNvPr id="29" name="文本框 28">
             <a:extLst>
               <a:ext uri="{FF2B5EF4-FFF2-40B4-BE49-F238E27FC236}">
-                <a16:creationId xmlns:a16="http://schemas.microsoft.com/office/drawing/2014/main" id="{5C5314AF-37FC-8FDC-5B35-DA1A12C03B86}"/>
+                <a16:creationId xmlns:a16="http://schemas.microsoft.com/office/drawing/2014/main" id="{616F71F4-B4A3-E763-5860-DBD9274F3CC1}"/>
               </a:ext>
             </a:extLst>
           </p:cNvPr>
@@ -4800,7 +4800,7 @@
           <p:cNvPr id="30" name="矩形: 圆角 29">
             <a:extLst>
               <a:ext uri="{FF2B5EF4-FFF2-40B4-BE49-F238E27FC236}">
-                <a16:creationId xmlns:a16="http://schemas.microsoft.com/office/drawing/2014/main" id="{8D9FA62E-2EBB-96B1-9CC1-42ADBC8057E7}"/>
+                <a16:creationId xmlns:a16="http://schemas.microsoft.com/office/drawing/2014/main" id="{4CD07E43-DED7-943D-8B61-02B241247F3B}"/>
               </a:ext>
             </a:extLst>
           </p:cNvPr>
@@ -4882,7 +4882,7 @@
           <p:cNvPr id="31" name="矩形: 圆角 30">
             <a:extLst>
               <a:ext uri="{FF2B5EF4-FFF2-40B4-BE49-F238E27FC236}">
-                <a16:creationId xmlns:a16="http://schemas.microsoft.com/office/drawing/2014/main" id="{EA49EB3D-AC56-4187-A14E-6D9D63980B10}"/>
+                <a16:creationId xmlns:a16="http://schemas.microsoft.com/office/drawing/2014/main" id="{5AFD651D-9500-80A7-DB79-C96A792620A6}"/>
               </a:ext>
             </a:extLst>
           </p:cNvPr>
@@ -4964,7 +4964,7 @@
           <p:cNvPr id="32" name="直接箭头连接符 31">
             <a:extLst>
               <a:ext uri="{FF2B5EF4-FFF2-40B4-BE49-F238E27FC236}">
-                <a16:creationId xmlns:a16="http://schemas.microsoft.com/office/drawing/2014/main" id="{4C0E6F7F-51AB-470C-244D-7F2B295B3DBA}"/>
+                <a16:creationId xmlns:a16="http://schemas.microsoft.com/office/drawing/2014/main" id="{503335A7-0A12-857D-C5EC-001A95BD8E9F}"/>
               </a:ext>
             </a:extLst>
           </p:cNvPr>
@@ -5006,7 +5006,7 @@
           <p:cNvPr id="33" name="直接箭头连接符 32">
             <a:extLst>
               <a:ext uri="{FF2B5EF4-FFF2-40B4-BE49-F238E27FC236}">
-                <a16:creationId xmlns:a16="http://schemas.microsoft.com/office/drawing/2014/main" id="{3FE896E5-A4F9-E9E1-C3B4-4B8B48E83AA5}"/>
+                <a16:creationId xmlns:a16="http://schemas.microsoft.com/office/drawing/2014/main" id="{4782A184-8D0C-4730-FBCF-5FF9084E929D}"/>
               </a:ext>
             </a:extLst>
           </p:cNvPr>
@@ -5048,7 +5048,7 @@
           <p:cNvPr id="34" name="矩形: 圆角 33">
             <a:extLst>
               <a:ext uri="{FF2B5EF4-FFF2-40B4-BE49-F238E27FC236}">
-                <a16:creationId xmlns:a16="http://schemas.microsoft.com/office/drawing/2014/main" id="{E4E1F4B4-3841-76D6-6E60-2AF65551497E}"/>
+                <a16:creationId xmlns:a16="http://schemas.microsoft.com/office/drawing/2014/main" id="{24123639-7A64-292E-0CA1-265122675892}"/>
               </a:ext>
             </a:extLst>
           </p:cNvPr>
@@ -5130,7 +5130,7 @@
           <p:cNvPr id="35" name="矩形: 圆角 34">
             <a:extLst>
               <a:ext uri="{FF2B5EF4-FFF2-40B4-BE49-F238E27FC236}">
-                <a16:creationId xmlns:a16="http://schemas.microsoft.com/office/drawing/2014/main" id="{5E06D000-9498-1422-E26D-315D3B23AEB2}"/>
+                <a16:creationId xmlns:a16="http://schemas.microsoft.com/office/drawing/2014/main" id="{5CD8C88D-569E-B812-2C7A-765C6C7914F3}"/>
               </a:ext>
             </a:extLst>
           </p:cNvPr>
@@ -5212,7 +5212,7 @@
           <p:cNvPr id="36" name="直接箭头连接符 35">
             <a:extLst>
               <a:ext uri="{FF2B5EF4-FFF2-40B4-BE49-F238E27FC236}">
-                <a16:creationId xmlns:a16="http://schemas.microsoft.com/office/drawing/2014/main" id="{134003DC-0914-0C82-7778-73033423426D}"/>
+                <a16:creationId xmlns:a16="http://schemas.microsoft.com/office/drawing/2014/main" id="{97DB9C56-7B47-E019-A155-50445374AF7B}"/>
               </a:ext>
             </a:extLst>
           </p:cNvPr>
@@ -5254,7 +5254,7 @@
           <p:cNvPr id="37" name="直接箭头连接符 36">
             <a:extLst>
               <a:ext uri="{FF2B5EF4-FFF2-40B4-BE49-F238E27FC236}">
-                <a16:creationId xmlns:a16="http://schemas.microsoft.com/office/drawing/2014/main" id="{899D935D-A358-F8F9-8287-970BDF15EA3A}"/>
+                <a16:creationId xmlns:a16="http://schemas.microsoft.com/office/drawing/2014/main" id="{280CD0EB-78A7-9933-5729-CA6312527137}"/>
               </a:ext>
             </a:extLst>
           </p:cNvPr>
@@ -5296,7 +5296,7 @@
           <p:cNvPr id="38" name="矩形: 圆角 37">
             <a:extLst>
               <a:ext uri="{FF2B5EF4-FFF2-40B4-BE49-F238E27FC236}">
-                <a16:creationId xmlns:a16="http://schemas.microsoft.com/office/drawing/2014/main" id="{E1D040C9-B72C-A27D-AA71-613D0F1EE70A}"/>
+                <a16:creationId xmlns:a16="http://schemas.microsoft.com/office/drawing/2014/main" id="{983CBB7C-234C-E289-A274-C95271020C29}"/>
               </a:ext>
             </a:extLst>
           </p:cNvPr>
@@ -5378,7 +5378,7 @@
           <p:cNvPr id="39" name="矩形: 圆角 38">
             <a:extLst>
               <a:ext uri="{FF2B5EF4-FFF2-40B4-BE49-F238E27FC236}">
-                <a16:creationId xmlns:a16="http://schemas.microsoft.com/office/drawing/2014/main" id="{3A048B1B-537F-CABB-E4FB-FDE4BA8F61B9}"/>
+                <a16:creationId xmlns:a16="http://schemas.microsoft.com/office/drawing/2014/main" id="{B03683E9-9901-29BB-53E1-F403A9BAE621}"/>
               </a:ext>
             </a:extLst>
           </p:cNvPr>
@@ -5460,7 +5460,7 @@
           <p:cNvPr id="40" name="直接箭头连接符 39">
             <a:extLst>
               <a:ext uri="{FF2B5EF4-FFF2-40B4-BE49-F238E27FC236}">
-                <a16:creationId xmlns:a16="http://schemas.microsoft.com/office/drawing/2014/main" id="{997BE20F-A6B1-0F10-CC60-D17E0A19AAA3}"/>
+                <a16:creationId xmlns:a16="http://schemas.microsoft.com/office/drawing/2014/main" id="{94C4DD22-11D8-2B3E-07E5-7A2FBF55CA98}"/>
               </a:ext>
             </a:extLst>
           </p:cNvPr>
@@ -5502,7 +5502,7 @@
           <p:cNvPr id="41" name="直接箭头连接符 40">
             <a:extLst>
               <a:ext uri="{FF2B5EF4-FFF2-40B4-BE49-F238E27FC236}">
-                <a16:creationId xmlns:a16="http://schemas.microsoft.com/office/drawing/2014/main" id="{6BE86A3A-9B45-8E1A-EE33-F0B9520E3904}"/>
+                <a16:creationId xmlns:a16="http://schemas.microsoft.com/office/drawing/2014/main" id="{2AD18C80-ECA5-0144-FBA6-D676765A2F1E}"/>
               </a:ext>
             </a:extLst>
           </p:cNvPr>
@@ -5544,7 +5544,7 @@
           <p:cNvPr id="42" name="矩形: 圆角 41">
             <a:extLst>
               <a:ext uri="{FF2B5EF4-FFF2-40B4-BE49-F238E27FC236}">
-                <a16:creationId xmlns:a16="http://schemas.microsoft.com/office/drawing/2014/main" id="{FD4AE8C9-F5D5-D17D-5F12-B1F2E692162D}"/>
+                <a16:creationId xmlns:a16="http://schemas.microsoft.com/office/drawing/2014/main" id="{63888C46-73E3-FAC3-DBFB-167428B60BF7}"/>
               </a:ext>
             </a:extLst>
           </p:cNvPr>
@@ -5626,7 +5626,7 @@
           <p:cNvPr id="43" name="矩形: 圆角 42">
             <a:extLst>
               <a:ext uri="{FF2B5EF4-FFF2-40B4-BE49-F238E27FC236}">
-                <a16:creationId xmlns:a16="http://schemas.microsoft.com/office/drawing/2014/main" id="{CB788CED-7AC2-2F94-3076-19AE6E0B21C5}"/>
+                <a16:creationId xmlns:a16="http://schemas.microsoft.com/office/drawing/2014/main" id="{51F3DFE3-D243-3F6F-A12C-A9E26B2C88D6}"/>
               </a:ext>
             </a:extLst>
           </p:cNvPr>
@@ -5708,7 +5708,7 @@
           <p:cNvPr id="44" name="直接箭头连接符 43">
             <a:extLst>
               <a:ext uri="{FF2B5EF4-FFF2-40B4-BE49-F238E27FC236}">
-                <a16:creationId xmlns:a16="http://schemas.microsoft.com/office/drawing/2014/main" id="{8777CC2A-A9EA-327E-0ECA-F7D165357350}"/>
+                <a16:creationId xmlns:a16="http://schemas.microsoft.com/office/drawing/2014/main" id="{650E8FAD-9DB6-26A3-84A8-6F0704DCA2E7}"/>
               </a:ext>
             </a:extLst>
           </p:cNvPr>
@@ -5750,7 +5750,7 @@
           <p:cNvPr id="45" name="文本框 44">
             <a:extLst>
               <a:ext uri="{FF2B5EF4-FFF2-40B4-BE49-F238E27FC236}">
-                <a16:creationId xmlns:a16="http://schemas.microsoft.com/office/drawing/2014/main" id="{383D90D8-B540-B63D-D16E-88E5C150E940}"/>
+                <a16:creationId xmlns:a16="http://schemas.microsoft.com/office/drawing/2014/main" id="{50E341C4-DAAC-5DAB-4BAD-F2351869A2C5}"/>
               </a:ext>
             </a:extLst>
           </p:cNvPr>
@@ -5797,7 +5797,7 @@
           <p:cNvPr id="46" name="文本框 45">
             <a:extLst>
               <a:ext uri="{FF2B5EF4-FFF2-40B4-BE49-F238E27FC236}">
-                <a16:creationId xmlns:a16="http://schemas.microsoft.com/office/drawing/2014/main" id="{CF1D8FC9-082C-DE8A-C848-C419B4B49DEE}"/>
+                <a16:creationId xmlns:a16="http://schemas.microsoft.com/office/drawing/2014/main" id="{F3AB406F-583E-558B-E0C2-AE5A30463CB8}"/>
               </a:ext>
             </a:extLst>
           </p:cNvPr>
@@ -5843,7 +5843,7 @@
           <p:cNvPr id="47" name="card 3">
             <a:extLst>
               <a:ext uri="{FF2B5EF4-FFF2-40B4-BE49-F238E27FC236}">
-                <a16:creationId xmlns:a16="http://schemas.microsoft.com/office/drawing/2014/main" id="{A35961E8-923B-F22B-246F-F0B3A92C2836}"/>
+                <a16:creationId xmlns:a16="http://schemas.microsoft.com/office/drawing/2014/main" id="{9948B86B-465E-B6A2-D22C-703C6F9F63E3}"/>
               </a:ext>
             </a:extLst>
           </p:cNvPr>
@@ -5913,7 +5913,7 @@
           <p:cNvPr id="48" name="badge 3">
             <a:extLst>
               <a:ext uri="{FF2B5EF4-FFF2-40B4-BE49-F238E27FC236}">
-                <a16:creationId xmlns:a16="http://schemas.microsoft.com/office/drawing/2014/main" id="{83E829D4-E89E-12D6-B636-68EBFC610B57}"/>
+                <a16:creationId xmlns:a16="http://schemas.microsoft.com/office/drawing/2014/main" id="{AE1521F0-C578-8E87-B0D1-4F6A756BDF57}"/>
               </a:ext>
             </a:extLst>
           </p:cNvPr>
@@ -5995,7 +5995,7 @@
           <p:cNvPr id="49" name="title 3">
             <a:extLst>
               <a:ext uri="{FF2B5EF4-FFF2-40B4-BE49-F238E27FC236}">
-                <a16:creationId xmlns:a16="http://schemas.microsoft.com/office/drawing/2014/main" id="{CF73AC8B-9440-7F1B-CAB3-30F1353FBD4E}"/>
+                <a16:creationId xmlns:a16="http://schemas.microsoft.com/office/drawing/2014/main" id="{2ABB9E2E-6AC6-9437-B950-D0B567C332C0}"/>
               </a:ext>
             </a:extLst>
           </p:cNvPr>
@@ -6041,7 +6041,7 @@
           <p:cNvPr id="50" name="文本框 49">
             <a:extLst>
               <a:ext uri="{FF2B5EF4-FFF2-40B4-BE49-F238E27FC236}">
-                <a16:creationId xmlns:a16="http://schemas.microsoft.com/office/drawing/2014/main" id="{A1A3FD2B-4D0A-D714-9BE0-AD7AB7800639}"/>
+                <a16:creationId xmlns:a16="http://schemas.microsoft.com/office/drawing/2014/main" id="{757D6735-9858-B8A7-A7A1-E14989242E51}"/>
               </a:ext>
             </a:extLst>
           </p:cNvPr>
@@ -6087,7 +6087,7 @@
           <p:cNvPr id="51" name="矩形: 圆角 50">
             <a:extLst>
               <a:ext uri="{FF2B5EF4-FFF2-40B4-BE49-F238E27FC236}">
-                <a16:creationId xmlns:a16="http://schemas.microsoft.com/office/drawing/2014/main" id="{4A9A2BE7-BE36-6A64-1629-6F78AF38BBC6}"/>
+                <a16:creationId xmlns:a16="http://schemas.microsoft.com/office/drawing/2014/main" id="{903CFAAA-1F96-772C-A7F1-4A162B52178E}"/>
               </a:ext>
             </a:extLst>
           </p:cNvPr>
@@ -6171,7 +6171,7 @@
           <p:cNvPr id="52" name="矩形: 圆角 51">
             <a:extLst>
               <a:ext uri="{FF2B5EF4-FFF2-40B4-BE49-F238E27FC236}">
-                <a16:creationId xmlns:a16="http://schemas.microsoft.com/office/drawing/2014/main" id="{4523B5AB-B9F6-DE4A-DD43-98A9B3519A78}"/>
+                <a16:creationId xmlns:a16="http://schemas.microsoft.com/office/drawing/2014/main" id="{67A744AC-BB59-3D7E-9933-B549E45C4249}"/>
               </a:ext>
             </a:extLst>
           </p:cNvPr>
@@ -6255,7 +6255,7 @@
           <p:cNvPr id="53" name="直接箭头连接符 52">
             <a:extLst>
               <a:ext uri="{FF2B5EF4-FFF2-40B4-BE49-F238E27FC236}">
-                <a16:creationId xmlns:a16="http://schemas.microsoft.com/office/drawing/2014/main" id="{20E9C90F-E2BE-2FB5-C9EA-BA5ABBF68EC3}"/>
+                <a16:creationId xmlns:a16="http://schemas.microsoft.com/office/drawing/2014/main" id="{1F39E7CD-42D0-4AFA-1A5B-CF399B88CB09}"/>
               </a:ext>
             </a:extLst>
           </p:cNvPr>
@@ -6301,7 +6301,7 @@
           <p:cNvPr id="54" name="矩形: 圆角 53">
             <a:extLst>
               <a:ext uri="{FF2B5EF4-FFF2-40B4-BE49-F238E27FC236}">
-                <a16:creationId xmlns:a16="http://schemas.microsoft.com/office/drawing/2014/main" id="{01B7CAA0-425A-A876-08E0-456A8C77BAD3}"/>
+                <a16:creationId xmlns:a16="http://schemas.microsoft.com/office/drawing/2014/main" id="{DEB90D95-8F1C-9B38-6CD9-2A91DC55FF0D}"/>
               </a:ext>
             </a:extLst>
           </p:cNvPr>
@@ -6385,7 +6385,7 @@
           <p:cNvPr id="55" name="直接箭头连接符 54">
             <a:extLst>
               <a:ext uri="{FF2B5EF4-FFF2-40B4-BE49-F238E27FC236}">
-                <a16:creationId xmlns:a16="http://schemas.microsoft.com/office/drawing/2014/main" id="{CC0EC43B-DABB-1B94-DB9F-9A03623A105E}"/>
+                <a16:creationId xmlns:a16="http://schemas.microsoft.com/office/drawing/2014/main" id="{B140D45A-7D5B-352D-66C9-A59601521CA9}"/>
               </a:ext>
             </a:extLst>
           </p:cNvPr>
@@ -6431,7 +6431,7 @@
           <p:cNvPr id="56" name="矩形: 圆角 55">
             <a:extLst>
               <a:ext uri="{FF2B5EF4-FFF2-40B4-BE49-F238E27FC236}">
-                <a16:creationId xmlns:a16="http://schemas.microsoft.com/office/drawing/2014/main" id="{1DDE98B8-B1A7-8372-5C0F-963CF420C963}"/>
+                <a16:creationId xmlns:a16="http://schemas.microsoft.com/office/drawing/2014/main" id="{67A53A47-9DDC-BBA3-201F-63C4607CA43C}"/>
               </a:ext>
             </a:extLst>
           </p:cNvPr>
@@ -6515,7 +6515,7 @@
           <p:cNvPr id="57" name="直接箭头连接符 56">
             <a:extLst>
               <a:ext uri="{FF2B5EF4-FFF2-40B4-BE49-F238E27FC236}">
-                <a16:creationId xmlns:a16="http://schemas.microsoft.com/office/drawing/2014/main" id="{464A2574-DB48-9732-B844-7E34A6473E94}"/>
+                <a16:creationId xmlns:a16="http://schemas.microsoft.com/office/drawing/2014/main" id="{54CDA925-203E-CAAD-2A98-F14105934C94}"/>
               </a:ext>
             </a:extLst>
           </p:cNvPr>
@@ -6561,7 +6561,7 @@
           <p:cNvPr id="58" name="矩形: 圆角 57">
             <a:extLst>
               <a:ext uri="{FF2B5EF4-FFF2-40B4-BE49-F238E27FC236}">
-                <a16:creationId xmlns:a16="http://schemas.microsoft.com/office/drawing/2014/main" id="{613F93AF-8654-67F4-9F0F-D8CB223A2F1E}"/>
+                <a16:creationId xmlns:a16="http://schemas.microsoft.com/office/drawing/2014/main" id="{BA7ADC38-D7F9-0C0D-3750-D91EB4C6FAD1}"/>
               </a:ext>
             </a:extLst>
           </p:cNvPr>
@@ -6645,7 +6645,7 @@
           <p:cNvPr id="59" name="直接箭头连接符 58">
             <a:extLst>
               <a:ext uri="{FF2B5EF4-FFF2-40B4-BE49-F238E27FC236}">
-                <a16:creationId xmlns:a16="http://schemas.microsoft.com/office/drawing/2014/main" id="{F10BA6CB-54D5-A91F-02D8-9A4FD99082D0}"/>
+                <a16:creationId xmlns:a16="http://schemas.microsoft.com/office/drawing/2014/main" id="{683CD1FA-D29A-24A6-341F-2A40E9E68491}"/>
               </a:ext>
             </a:extLst>
           </p:cNvPr>
@@ -6691,7 +6691,7 @@
           <p:cNvPr id="60" name="矩形: 圆角 59">
             <a:extLst>
               <a:ext uri="{FF2B5EF4-FFF2-40B4-BE49-F238E27FC236}">
-                <a16:creationId xmlns:a16="http://schemas.microsoft.com/office/drawing/2014/main" id="{0A95BEF9-7831-9319-95A3-9836EBE542AF}"/>
+                <a16:creationId xmlns:a16="http://schemas.microsoft.com/office/drawing/2014/main" id="{618DC254-8DD8-02BC-ED60-B0C9E76C8A4A}"/>
               </a:ext>
             </a:extLst>
           </p:cNvPr>
@@ -6775,7 +6775,7 @@
           <p:cNvPr id="61" name="直接箭头连接符 60">
             <a:extLst>
               <a:ext uri="{FF2B5EF4-FFF2-40B4-BE49-F238E27FC236}">
-                <a16:creationId xmlns:a16="http://schemas.microsoft.com/office/drawing/2014/main" id="{527F54B7-7DBA-C315-8DF1-C8B0BBB0078D}"/>
+                <a16:creationId xmlns:a16="http://schemas.microsoft.com/office/drawing/2014/main" id="{6D41A184-239E-E211-42AB-79295E4AC5C4}"/>
               </a:ext>
             </a:extLst>
           </p:cNvPr>
@@ -6821,7 +6821,7 @@
           <p:cNvPr id="62" name="矩形: 圆角 61">
             <a:extLst>
               <a:ext uri="{FF2B5EF4-FFF2-40B4-BE49-F238E27FC236}">
-                <a16:creationId xmlns:a16="http://schemas.microsoft.com/office/drawing/2014/main" id="{7FE23C0F-74AF-2F62-3E69-2FF6F29DF10B}"/>
+                <a16:creationId xmlns:a16="http://schemas.microsoft.com/office/drawing/2014/main" id="{1C76FA0A-D4D8-5F03-7C4B-EAEA71E70F01}"/>
               </a:ext>
             </a:extLst>
           </p:cNvPr>
@@ -6905,7 +6905,7 @@
           <p:cNvPr id="63" name="直接箭头连接符 62">
             <a:extLst>
               <a:ext uri="{FF2B5EF4-FFF2-40B4-BE49-F238E27FC236}">
-                <a16:creationId xmlns:a16="http://schemas.microsoft.com/office/drawing/2014/main" id="{30188A99-77CC-A3A0-21C8-C1E4BFB430EF}"/>
+                <a16:creationId xmlns:a16="http://schemas.microsoft.com/office/drawing/2014/main" id="{89E4BB2C-9B1C-23F7-FD0F-B7E2FB8F3B59}"/>
               </a:ext>
             </a:extLst>
           </p:cNvPr>
@@ -6951,7 +6951,7 @@
           <p:cNvPr id="64" name="矩形: 圆角 63">
             <a:extLst>
               <a:ext uri="{FF2B5EF4-FFF2-40B4-BE49-F238E27FC236}">
-                <a16:creationId xmlns:a16="http://schemas.microsoft.com/office/drawing/2014/main" id="{330DA733-1AE0-480D-6301-EA65E33DF1F1}"/>
+                <a16:creationId xmlns:a16="http://schemas.microsoft.com/office/drawing/2014/main" id="{24EAE674-1482-E553-7EC9-23FF5D3A6735}"/>
               </a:ext>
             </a:extLst>
           </p:cNvPr>
@@ -7035,7 +7035,7 @@
           <p:cNvPr id="65" name="直接箭头连接符 64">
             <a:extLst>
               <a:ext uri="{FF2B5EF4-FFF2-40B4-BE49-F238E27FC236}">
-                <a16:creationId xmlns:a16="http://schemas.microsoft.com/office/drawing/2014/main" id="{BEADFA17-01B1-114A-1CB8-6402C9CFD700}"/>
+                <a16:creationId xmlns:a16="http://schemas.microsoft.com/office/drawing/2014/main" id="{B8A997A0-313C-110B-3590-8412A9D30024}"/>
               </a:ext>
             </a:extLst>
           </p:cNvPr>
@@ -7081,7 +7081,7 @@
           <p:cNvPr id="66" name="矩形: 圆角 65">
             <a:extLst>
               <a:ext uri="{FF2B5EF4-FFF2-40B4-BE49-F238E27FC236}">
-                <a16:creationId xmlns:a16="http://schemas.microsoft.com/office/drawing/2014/main" id="{C5BE1D9E-AF82-EB42-A000-E129EADD7E6E}"/>
+                <a16:creationId xmlns:a16="http://schemas.microsoft.com/office/drawing/2014/main" id="{EC738D8B-47D9-0FB8-C61D-0720041951EC}"/>
               </a:ext>
             </a:extLst>
           </p:cNvPr>
@@ -7165,7 +7165,7 @@
           <p:cNvPr id="67" name="直接箭头连接符 66">
             <a:extLst>
               <a:ext uri="{FF2B5EF4-FFF2-40B4-BE49-F238E27FC236}">
-                <a16:creationId xmlns:a16="http://schemas.microsoft.com/office/drawing/2014/main" id="{8FCD6A74-56ED-1311-0DF2-F882231912A3}"/>
+                <a16:creationId xmlns:a16="http://schemas.microsoft.com/office/drawing/2014/main" id="{39FB3B9E-75F6-EDB3-4FF4-16D866FE64F9}"/>
               </a:ext>
             </a:extLst>
           </p:cNvPr>
@@ -7211,7 +7211,7 @@
           <p:cNvPr id="68" name="矩形: 圆角 67">
             <a:extLst>
               <a:ext uri="{FF2B5EF4-FFF2-40B4-BE49-F238E27FC236}">
-                <a16:creationId xmlns:a16="http://schemas.microsoft.com/office/drawing/2014/main" id="{3964E846-C7C8-3B26-F119-7628F9B51033}"/>
+                <a16:creationId xmlns:a16="http://schemas.microsoft.com/office/drawing/2014/main" id="{2BC1716A-578F-0EA6-8998-4F003CC5E416}"/>
               </a:ext>
             </a:extLst>
           </p:cNvPr>
@@ -7295,7 +7295,7 @@
           <p:cNvPr id="69" name="矩形: 圆角 68">
             <a:extLst>
               <a:ext uri="{FF2B5EF4-FFF2-40B4-BE49-F238E27FC236}">
-                <a16:creationId xmlns:a16="http://schemas.microsoft.com/office/drawing/2014/main" id="{D41BC8F7-D843-C3DB-F6A7-BBF9C9AFEEB1}"/>
+                <a16:creationId xmlns:a16="http://schemas.microsoft.com/office/drawing/2014/main" id="{5A3B205A-0711-986C-05B6-CA6AAFA42331}"/>
               </a:ext>
             </a:extLst>
           </p:cNvPr>
@@ -7379,7 +7379,7 @@
           <p:cNvPr id="70" name="直接箭头连接符 69">
             <a:extLst>
               <a:ext uri="{FF2B5EF4-FFF2-40B4-BE49-F238E27FC236}">
-                <a16:creationId xmlns:a16="http://schemas.microsoft.com/office/drawing/2014/main" id="{C4B3A299-2F96-CE9C-3486-70B333E05587}"/>
+                <a16:creationId xmlns:a16="http://schemas.microsoft.com/office/drawing/2014/main" id="{E3D54DAC-A3F1-AE1C-2A3E-038E51BD2165}"/>
               </a:ext>
             </a:extLst>
           </p:cNvPr>
@@ -7425,7 +7425,7 @@
           <p:cNvPr id="71" name="矩形: 圆角 70">
             <a:extLst>
               <a:ext uri="{FF2B5EF4-FFF2-40B4-BE49-F238E27FC236}">
-                <a16:creationId xmlns:a16="http://schemas.microsoft.com/office/drawing/2014/main" id="{470AFDD4-E226-5F29-E3C6-7DD2CA6E58CA}"/>
+                <a16:creationId xmlns:a16="http://schemas.microsoft.com/office/drawing/2014/main" id="{0C27030E-A015-1653-34D5-893E4E3757B0}"/>
               </a:ext>
             </a:extLst>
           </p:cNvPr>
@@ -7509,7 +7509,7 @@
           <p:cNvPr id="72" name="直接箭头连接符 71">
             <a:extLst>
               <a:ext uri="{FF2B5EF4-FFF2-40B4-BE49-F238E27FC236}">
-                <a16:creationId xmlns:a16="http://schemas.microsoft.com/office/drawing/2014/main" id="{B06A2E5B-2E40-9910-2853-370A1E993FE1}"/>
+                <a16:creationId xmlns:a16="http://schemas.microsoft.com/office/drawing/2014/main" id="{3ACF0569-103A-42A3-164E-921876304F76}"/>
               </a:ext>
             </a:extLst>
           </p:cNvPr>
@@ -7555,7 +7555,7 @@
           <p:cNvPr id="73" name="矩形: 圆角 72">
             <a:extLst>
               <a:ext uri="{FF2B5EF4-FFF2-40B4-BE49-F238E27FC236}">
-                <a16:creationId xmlns:a16="http://schemas.microsoft.com/office/drawing/2014/main" id="{C22F7CD4-F9A4-DAD2-EE37-5A76433A05ED}"/>
+                <a16:creationId xmlns:a16="http://schemas.microsoft.com/office/drawing/2014/main" id="{6047F4E2-E821-A93A-C318-4256622C846C}"/>
               </a:ext>
             </a:extLst>
           </p:cNvPr>
@@ -7639,7 +7639,7 @@
           <p:cNvPr id="74" name="直接箭头连接符 73">
             <a:extLst>
               <a:ext uri="{FF2B5EF4-FFF2-40B4-BE49-F238E27FC236}">
-                <a16:creationId xmlns:a16="http://schemas.microsoft.com/office/drawing/2014/main" id="{4752A47E-3503-E329-8F0F-C36D7456ED9B}"/>
+                <a16:creationId xmlns:a16="http://schemas.microsoft.com/office/drawing/2014/main" id="{A2C90E8D-33B9-4D40-B97A-E2F62285D9B5}"/>
               </a:ext>
             </a:extLst>
           </p:cNvPr>
@@ -7685,7 +7685,7 @@
           <p:cNvPr id="75" name="矩形: 圆角 74">
             <a:extLst>
               <a:ext uri="{FF2B5EF4-FFF2-40B4-BE49-F238E27FC236}">
-                <a16:creationId xmlns:a16="http://schemas.microsoft.com/office/drawing/2014/main" id="{045B200C-4815-A66E-F932-4F924BC67AF7}"/>
+                <a16:creationId xmlns:a16="http://schemas.microsoft.com/office/drawing/2014/main" id="{EBD9B2F9-1C1D-E113-FB9E-937E9B90AD45}"/>
               </a:ext>
             </a:extLst>
           </p:cNvPr>
@@ -7769,7 +7769,7 @@
           <p:cNvPr id="76" name="直接箭头连接符 75">
             <a:extLst>
               <a:ext uri="{FF2B5EF4-FFF2-40B4-BE49-F238E27FC236}">
-                <a16:creationId xmlns:a16="http://schemas.microsoft.com/office/drawing/2014/main" id="{F0E969EF-D9F9-806E-0E65-337C445E6A20}"/>
+                <a16:creationId xmlns:a16="http://schemas.microsoft.com/office/drawing/2014/main" id="{F382524F-4D55-E6F9-074E-19C543DC34F8}"/>
               </a:ext>
             </a:extLst>
           </p:cNvPr>
@@ -7815,7 +7815,7 @@
           <p:cNvPr id="77" name="矩形: 圆角 76">
             <a:extLst>
               <a:ext uri="{FF2B5EF4-FFF2-40B4-BE49-F238E27FC236}">
-                <a16:creationId xmlns:a16="http://schemas.microsoft.com/office/drawing/2014/main" id="{7E0FC30F-0ECF-A5B7-32D3-AC882033B662}"/>
+                <a16:creationId xmlns:a16="http://schemas.microsoft.com/office/drawing/2014/main" id="{CD8D7BF3-6B95-6CC0-7843-D6A60098EAA8}"/>
               </a:ext>
             </a:extLst>
           </p:cNvPr>
@@ -7899,7 +7899,7 @@
           <p:cNvPr id="78" name="直接箭头连接符 77">
             <a:extLst>
               <a:ext uri="{FF2B5EF4-FFF2-40B4-BE49-F238E27FC236}">
-                <a16:creationId xmlns:a16="http://schemas.microsoft.com/office/drawing/2014/main" id="{A108F778-4FD6-B721-EB31-D4295791D73F}"/>
+                <a16:creationId xmlns:a16="http://schemas.microsoft.com/office/drawing/2014/main" id="{E5B1AB76-8010-00EB-C7F7-0FEC14FCE991}"/>
               </a:ext>
             </a:extLst>
           </p:cNvPr>
@@ -7945,7 +7945,7 @@
           <p:cNvPr id="79" name="矩形: 圆角 78">
             <a:extLst>
               <a:ext uri="{FF2B5EF4-FFF2-40B4-BE49-F238E27FC236}">
-                <a16:creationId xmlns:a16="http://schemas.microsoft.com/office/drawing/2014/main" id="{EDA13281-C3B0-0FB4-561D-7A0BB779DDCF}"/>
+                <a16:creationId xmlns:a16="http://schemas.microsoft.com/office/drawing/2014/main" id="{AE708656-155F-D214-A6B1-393D2AB1117F}"/>
               </a:ext>
             </a:extLst>
           </p:cNvPr>
@@ -8029,7 +8029,7 @@
           <p:cNvPr id="80" name="直接箭头连接符 79">
             <a:extLst>
               <a:ext uri="{FF2B5EF4-FFF2-40B4-BE49-F238E27FC236}">
-                <a16:creationId xmlns:a16="http://schemas.microsoft.com/office/drawing/2014/main" id="{9BC52AE9-F1BD-99DA-C428-1973786360F2}"/>
+                <a16:creationId xmlns:a16="http://schemas.microsoft.com/office/drawing/2014/main" id="{12F377F4-8179-FC0E-B919-6E5AB6D0EBB2}"/>
               </a:ext>
             </a:extLst>
           </p:cNvPr>
@@ -8075,7 +8075,7 @@
           <p:cNvPr id="81" name="矩形: 圆角 80">
             <a:extLst>
               <a:ext uri="{FF2B5EF4-FFF2-40B4-BE49-F238E27FC236}">
-                <a16:creationId xmlns:a16="http://schemas.microsoft.com/office/drawing/2014/main" id="{A9FB2EE3-7EB2-8583-E898-28FC73D1867F}"/>
+                <a16:creationId xmlns:a16="http://schemas.microsoft.com/office/drawing/2014/main" id="{6ECCAF79-C919-ED2C-9E20-2E58410C94E1}"/>
               </a:ext>
             </a:extLst>
           </p:cNvPr>
@@ -8159,7 +8159,7 @@
           <p:cNvPr id="82" name="直接箭头连接符 81">
             <a:extLst>
               <a:ext uri="{FF2B5EF4-FFF2-40B4-BE49-F238E27FC236}">
-                <a16:creationId xmlns:a16="http://schemas.microsoft.com/office/drawing/2014/main" id="{1758C07D-8883-81B7-5483-A60150AF9704}"/>
+                <a16:creationId xmlns:a16="http://schemas.microsoft.com/office/drawing/2014/main" id="{5EB85A99-0763-9235-EA4F-37308BA1F112}"/>
               </a:ext>
             </a:extLst>
           </p:cNvPr>
@@ -8205,7 +8205,7 @@
           <p:cNvPr id="83" name="矩形: 圆角 82">
             <a:extLst>
               <a:ext uri="{FF2B5EF4-FFF2-40B4-BE49-F238E27FC236}">
-                <a16:creationId xmlns:a16="http://schemas.microsoft.com/office/drawing/2014/main" id="{B872A803-6936-04F5-601D-5DFC24B772A8}"/>
+                <a16:creationId xmlns:a16="http://schemas.microsoft.com/office/drawing/2014/main" id="{C1D4207D-B7D4-019E-8AD2-5EB24B05164E}"/>
               </a:ext>
             </a:extLst>
           </p:cNvPr>
@@ -8289,7 +8289,7 @@
           <p:cNvPr id="84" name="直接箭头连接符 83">
             <a:extLst>
               <a:ext uri="{FF2B5EF4-FFF2-40B4-BE49-F238E27FC236}">
-                <a16:creationId xmlns:a16="http://schemas.microsoft.com/office/drawing/2014/main" id="{C2B6EDCE-EFB3-6566-DB2E-8009C3694EC5}"/>
+                <a16:creationId xmlns:a16="http://schemas.microsoft.com/office/drawing/2014/main" id="{3FF20E93-2B46-6489-E539-2635BB45B783}"/>
               </a:ext>
             </a:extLst>
           </p:cNvPr>
@@ -8335,7 +8335,7 @@
           <p:cNvPr id="85" name="矩形: 圆角 84">
             <a:extLst>
               <a:ext uri="{FF2B5EF4-FFF2-40B4-BE49-F238E27FC236}">
-                <a16:creationId xmlns:a16="http://schemas.microsoft.com/office/drawing/2014/main" id="{A3E4ACE8-3721-D083-7121-81E177E6009C}"/>
+                <a16:creationId xmlns:a16="http://schemas.microsoft.com/office/drawing/2014/main" id="{3D752CD0-2C7E-CB26-0ABD-89338D7BC9BB}"/>
               </a:ext>
             </a:extLst>
           </p:cNvPr>
@@ -8419,7 +8419,7 @@
           <p:cNvPr id="86" name="直接箭头连接符 85">
             <a:extLst>
               <a:ext uri="{FF2B5EF4-FFF2-40B4-BE49-F238E27FC236}">
-                <a16:creationId xmlns:a16="http://schemas.microsoft.com/office/drawing/2014/main" id="{038C8D5A-6088-ACD2-67D9-7FA8CECA2677}"/>
+                <a16:creationId xmlns:a16="http://schemas.microsoft.com/office/drawing/2014/main" id="{4BC9506E-A971-9441-D142-68927D87298A}"/>
               </a:ext>
             </a:extLst>
           </p:cNvPr>
@@ -8465,7 +8465,7 @@
           <p:cNvPr id="87" name="连接符: 肘形 86">
             <a:extLst>
               <a:ext uri="{FF2B5EF4-FFF2-40B4-BE49-F238E27FC236}">
-                <a16:creationId xmlns:a16="http://schemas.microsoft.com/office/drawing/2014/main" id="{D0DA5DB7-4612-F2A8-8C87-A889ACA3AF20}"/>
+                <a16:creationId xmlns:a16="http://schemas.microsoft.com/office/drawing/2014/main" id="{3E2BB58A-3ECD-D026-0AF6-3A546573C0E7}"/>
               </a:ext>
             </a:extLst>
           </p:cNvPr>
@@ -8513,7 +8513,7 @@
           <p:cNvPr id="88" name="矩形: 圆角 87">
             <a:extLst>
               <a:ext uri="{FF2B5EF4-FFF2-40B4-BE49-F238E27FC236}">
-                <a16:creationId xmlns:a16="http://schemas.microsoft.com/office/drawing/2014/main" id="{215208B2-596E-BAA4-78CD-AA46FB0F1D13}"/>
+                <a16:creationId xmlns:a16="http://schemas.microsoft.com/office/drawing/2014/main" id="{20D58471-D5D0-542E-72D4-D9359565A75C}"/>
               </a:ext>
             </a:extLst>
           </p:cNvPr>
@@ -8583,7 +8583,7 @@
           <p:cNvPr id="89" name="文本框 88">
             <a:extLst>
               <a:ext uri="{FF2B5EF4-FFF2-40B4-BE49-F238E27FC236}">
-                <a16:creationId xmlns:a16="http://schemas.microsoft.com/office/drawing/2014/main" id="{2EEFF4AD-1C6E-F45B-8DB0-F6EEEA4F4E7D}"/>
+                <a16:creationId xmlns:a16="http://schemas.microsoft.com/office/drawing/2014/main" id="{73ECB067-C60A-BE39-C831-5EA080AA47AD}"/>
               </a:ext>
             </a:extLst>
           </p:cNvPr>
@@ -8629,7 +8629,7 @@
           <p:cNvPr id="90" name="文本框 89">
             <a:extLst>
               <a:ext uri="{FF2B5EF4-FFF2-40B4-BE49-F238E27FC236}">
-                <a16:creationId xmlns:a16="http://schemas.microsoft.com/office/drawing/2014/main" id="{FA0497CE-EA51-BBA6-2D2E-91DFF9933C16}"/>
+                <a16:creationId xmlns:a16="http://schemas.microsoft.com/office/drawing/2014/main" id="{6266DEB2-7BD8-F8E9-6C59-0D45E7230B3A}"/>
               </a:ext>
             </a:extLst>
           </p:cNvPr>
@@ -8675,7 +8675,7 @@
           <p:cNvPr id="91" name="文本框 90">
             <a:extLst>
               <a:ext uri="{FF2B5EF4-FFF2-40B4-BE49-F238E27FC236}">
-                <a16:creationId xmlns:a16="http://schemas.microsoft.com/office/drawing/2014/main" id="{F5FD9853-C7C6-68B2-951F-4A7D5C567B37}"/>
+                <a16:creationId xmlns:a16="http://schemas.microsoft.com/office/drawing/2014/main" id="{7A87E92A-AD72-0936-904E-292BE086E77A}"/>
               </a:ext>
             </a:extLst>
           </p:cNvPr>
@@ -8752,7 +8752,7 @@
           <p:cNvPr id="92" name="card 4">
             <a:extLst>
               <a:ext uri="{FF2B5EF4-FFF2-40B4-BE49-F238E27FC236}">
-                <a16:creationId xmlns:a16="http://schemas.microsoft.com/office/drawing/2014/main" id="{2E2169F8-3155-6A13-439B-586F6311E7FF}"/>
+                <a16:creationId xmlns:a16="http://schemas.microsoft.com/office/drawing/2014/main" id="{B20AB575-DDA3-8A9A-B442-83202A8F87E5}"/>
               </a:ext>
             </a:extLst>
           </p:cNvPr>
@@ -8822,7 +8822,7 @@
           <p:cNvPr id="93" name="badge 4">
             <a:extLst>
               <a:ext uri="{FF2B5EF4-FFF2-40B4-BE49-F238E27FC236}">
-                <a16:creationId xmlns:a16="http://schemas.microsoft.com/office/drawing/2014/main" id="{D9DD6845-9065-B838-B1EC-22F8A78807BE}"/>
+                <a16:creationId xmlns:a16="http://schemas.microsoft.com/office/drawing/2014/main" id="{2681D068-6943-5B32-4ACF-15D37398FB3A}"/>
               </a:ext>
             </a:extLst>
           </p:cNvPr>
@@ -8904,7 +8904,7 @@
           <p:cNvPr id="94" name="title 4">
             <a:extLst>
               <a:ext uri="{FF2B5EF4-FFF2-40B4-BE49-F238E27FC236}">
-                <a16:creationId xmlns:a16="http://schemas.microsoft.com/office/drawing/2014/main" id="{88593BBD-434A-02CD-1B27-C5A9647CCE69}"/>
+                <a16:creationId xmlns:a16="http://schemas.microsoft.com/office/drawing/2014/main" id="{F9991551-B5D0-36B2-EC8D-2B8FDA85F15F}"/>
               </a:ext>
             </a:extLst>
           </p:cNvPr>
@@ -8950,7 +8950,7 @@
           <p:cNvPr id="95" name="文本框 94">
             <a:extLst>
               <a:ext uri="{FF2B5EF4-FFF2-40B4-BE49-F238E27FC236}">
-                <a16:creationId xmlns:a16="http://schemas.microsoft.com/office/drawing/2014/main" id="{6C59AB35-4DAC-3D3E-B832-5EFC7A9B2C85}"/>
+                <a16:creationId xmlns:a16="http://schemas.microsoft.com/office/drawing/2014/main" id="{53763C73-A1AE-ADE3-9F2B-DE9508DB03C3}"/>
               </a:ext>
             </a:extLst>
           </p:cNvPr>
@@ -9069,7 +9069,7 @@
           <p:cNvPr id="97" name="图片 96">
             <a:extLst>
               <a:ext uri="{FF2B5EF4-FFF2-40B4-BE49-F238E27FC236}">
-                <a16:creationId xmlns:a16="http://schemas.microsoft.com/office/drawing/2014/main" id="{B36CC9BC-6420-6212-C1D9-9353821746C0}"/>
+                <a16:creationId xmlns:a16="http://schemas.microsoft.com/office/drawing/2014/main" id="{08C1F404-9F33-DDA2-B64A-4C52939507E1}"/>
               </a:ext>
             </a:extLst>
           </p:cNvPr>
@@ -9110,7 +9110,7 @@
           <p:cNvPr id="98" name="文本框 97">
             <a:extLst>
               <a:ext uri="{FF2B5EF4-FFF2-40B4-BE49-F238E27FC236}">
-                <a16:creationId xmlns:a16="http://schemas.microsoft.com/office/drawing/2014/main" id="{59949D33-3E46-B11E-C04E-F6FC0F39F0F3}"/>
+                <a16:creationId xmlns:a16="http://schemas.microsoft.com/office/drawing/2014/main" id="{EC787625-29C1-7B86-2D9D-AF997C9F7682}"/>
               </a:ext>
             </a:extLst>
           </p:cNvPr>
@@ -9157,7 +9157,7 @@
           <p:cNvPr id="99" name="card 5">
             <a:extLst>
               <a:ext uri="{FF2B5EF4-FFF2-40B4-BE49-F238E27FC236}">
-                <a16:creationId xmlns:a16="http://schemas.microsoft.com/office/drawing/2014/main" id="{0CF138FB-B619-5FFF-55E2-69301234A0E6}"/>
+                <a16:creationId xmlns:a16="http://schemas.microsoft.com/office/drawing/2014/main" id="{7276B9E9-D420-E4D5-F2EB-5977F476B5B2}"/>
               </a:ext>
             </a:extLst>
           </p:cNvPr>
@@ -9227,7 +9227,7 @@
           <p:cNvPr id="100" name="badge 5">
             <a:extLst>
               <a:ext uri="{FF2B5EF4-FFF2-40B4-BE49-F238E27FC236}">
-                <a16:creationId xmlns:a16="http://schemas.microsoft.com/office/drawing/2014/main" id="{B87A8511-2E51-A4FA-87DF-C095493DA41C}"/>
+                <a16:creationId xmlns:a16="http://schemas.microsoft.com/office/drawing/2014/main" id="{7731B3D4-E91B-1BC1-2607-D666E16DFEDA}"/>
               </a:ext>
             </a:extLst>
           </p:cNvPr>
@@ -9309,7 +9309,7 @@
           <p:cNvPr id="101" name="title 5">
             <a:extLst>
               <a:ext uri="{FF2B5EF4-FFF2-40B4-BE49-F238E27FC236}">
-                <a16:creationId xmlns:a16="http://schemas.microsoft.com/office/drawing/2014/main" id="{C20A0E08-E8C7-94A0-2E42-2FAEE373FB17}"/>
+                <a16:creationId xmlns:a16="http://schemas.microsoft.com/office/drawing/2014/main" id="{7FE643CE-524B-9DE7-8673-F5DFC5FE30CE}"/>
               </a:ext>
             </a:extLst>
           </p:cNvPr>
@@ -9355,7 +9355,7 @@
           <p:cNvPr id="102" name="文本框 101">
             <a:extLst>
               <a:ext uri="{FF2B5EF4-FFF2-40B4-BE49-F238E27FC236}">
-                <a16:creationId xmlns:a16="http://schemas.microsoft.com/office/drawing/2014/main" id="{63B381C3-1516-429C-F471-848178BA5F87}"/>
+                <a16:creationId xmlns:a16="http://schemas.microsoft.com/office/drawing/2014/main" id="{95050220-ECBC-0072-62F0-57B381DF511C}"/>
               </a:ext>
             </a:extLst>
           </p:cNvPr>
@@ -9453,7 +9453,7 @@
           <p:cNvPr id="103" name="矩形: 圆角 102">
             <a:extLst>
               <a:ext uri="{FF2B5EF4-FFF2-40B4-BE49-F238E27FC236}">
-                <a16:creationId xmlns:a16="http://schemas.microsoft.com/office/drawing/2014/main" id="{D9AADF56-7A2E-072B-B834-001DFAA75A6B}"/>
+                <a16:creationId xmlns:a16="http://schemas.microsoft.com/office/drawing/2014/main" id="{7762CB4C-ED42-5B12-849D-C2900B8F8364}"/>
               </a:ext>
             </a:extLst>
           </p:cNvPr>
@@ -9535,7 +9535,7 @@
           <p:cNvPr id="104" name="直接箭头连接符 103">
             <a:extLst>
               <a:ext uri="{FF2B5EF4-FFF2-40B4-BE49-F238E27FC236}">
-                <a16:creationId xmlns:a16="http://schemas.microsoft.com/office/drawing/2014/main" id="{6CF68156-A2A1-D8D8-7094-E1BD5ECDA4A8}"/>
+                <a16:creationId xmlns:a16="http://schemas.microsoft.com/office/drawing/2014/main" id="{5EAD585B-A919-102F-B51D-EAD9710C4CA6}"/>
               </a:ext>
             </a:extLst>
           </p:cNvPr>
@@ -9577,7 +9577,7 @@
           <p:cNvPr id="105" name="矩形: 圆角 104">
             <a:extLst>
               <a:ext uri="{FF2B5EF4-FFF2-40B4-BE49-F238E27FC236}">
-                <a16:creationId xmlns:a16="http://schemas.microsoft.com/office/drawing/2014/main" id="{A8D04817-4A89-8016-1FB6-C0133437B0FB}"/>
+                <a16:creationId xmlns:a16="http://schemas.microsoft.com/office/drawing/2014/main" id="{D7C7177C-8516-E70B-A3FD-2E55508E6EF7}"/>
               </a:ext>
             </a:extLst>
           </p:cNvPr>
@@ -9659,7 +9659,7 @@
           <p:cNvPr id="106" name="直接箭头连接符 105">
             <a:extLst>
               <a:ext uri="{FF2B5EF4-FFF2-40B4-BE49-F238E27FC236}">
-                <a16:creationId xmlns:a16="http://schemas.microsoft.com/office/drawing/2014/main" id="{D7BD9C74-AD02-0662-E111-C4592100BA99}"/>
+                <a16:creationId xmlns:a16="http://schemas.microsoft.com/office/drawing/2014/main" id="{F069743A-69CB-6019-F7F9-E07F095D64AD}"/>
               </a:ext>
             </a:extLst>
           </p:cNvPr>
@@ -9701,7 +9701,7 @@
           <p:cNvPr id="107" name="矩形: 圆角 106">
             <a:extLst>
               <a:ext uri="{FF2B5EF4-FFF2-40B4-BE49-F238E27FC236}">
-                <a16:creationId xmlns:a16="http://schemas.microsoft.com/office/drawing/2014/main" id="{3F65A75A-35D1-93F2-5831-CA8E6E2C3031}"/>
+                <a16:creationId xmlns:a16="http://schemas.microsoft.com/office/drawing/2014/main" id="{C631A303-F312-2259-ECA6-C0DA85D97C0E}"/>
               </a:ext>
             </a:extLst>
           </p:cNvPr>
@@ -9783,7 +9783,7 @@
           <p:cNvPr id="108" name="直接箭头连接符 107">
             <a:extLst>
               <a:ext uri="{FF2B5EF4-FFF2-40B4-BE49-F238E27FC236}">
-                <a16:creationId xmlns:a16="http://schemas.microsoft.com/office/drawing/2014/main" id="{6539E4C7-AAFA-4591-4799-F43F95EC4BD4}"/>
+                <a16:creationId xmlns:a16="http://schemas.microsoft.com/office/drawing/2014/main" id="{F90C66D5-D175-DC23-9BB1-E01C658DCFEC}"/>
               </a:ext>
             </a:extLst>
           </p:cNvPr>
@@ -9825,7 +9825,7 @@
           <p:cNvPr id="109" name="矩形: 圆角 108">
             <a:extLst>
               <a:ext uri="{FF2B5EF4-FFF2-40B4-BE49-F238E27FC236}">
-                <a16:creationId xmlns:a16="http://schemas.microsoft.com/office/drawing/2014/main" id="{07D0067F-9E5E-FCC4-0850-9FD0F86312F5}"/>
+                <a16:creationId xmlns:a16="http://schemas.microsoft.com/office/drawing/2014/main" id="{3A74B5CA-15EC-8E30-2803-D870E0F4FECA}"/>
               </a:ext>
             </a:extLst>
           </p:cNvPr>
@@ -9907,7 +9907,7 @@
           <p:cNvPr id="110" name="文本框 109">
             <a:extLst>
               <a:ext uri="{FF2B5EF4-FFF2-40B4-BE49-F238E27FC236}">
-                <a16:creationId xmlns:a16="http://schemas.microsoft.com/office/drawing/2014/main" id="{5E7E3D2F-E67B-9923-EA27-3223FA87BF7C}"/>
+                <a16:creationId xmlns:a16="http://schemas.microsoft.com/office/drawing/2014/main" id="{8A979131-6870-7ADD-4EB9-39D55852ED83}"/>
               </a:ext>
             </a:extLst>
           </p:cNvPr>
@@ -9954,7 +9954,7 @@
           <p:cNvPr id="111" name="文本框 110">
             <a:extLst>
               <a:ext uri="{FF2B5EF4-FFF2-40B4-BE49-F238E27FC236}">
-                <a16:creationId xmlns:a16="http://schemas.microsoft.com/office/drawing/2014/main" id="{94D7C0D9-1D66-00A8-9E35-7B2C7838438E}"/>
+                <a16:creationId xmlns:a16="http://schemas.microsoft.com/office/drawing/2014/main" id="{9CD67D8E-38BC-3000-2797-9318EAEAA901}"/>
               </a:ext>
             </a:extLst>
           </p:cNvPr>
@@ -10000,7 +10000,7 @@
           <p:cNvPr id="112" name="表格 111">
             <a:extLst>
               <a:ext uri="{FF2B5EF4-FFF2-40B4-BE49-F238E27FC236}">
-                <a16:creationId xmlns:a16="http://schemas.microsoft.com/office/drawing/2014/main" id="{4A0C434F-77A0-3C20-217B-7B69E6CC7B5E}"/>
+                <a16:creationId xmlns:a16="http://schemas.microsoft.com/office/drawing/2014/main" id="{CB0F9B42-DA6C-9716-212D-3E2F09BFD7CA}"/>
               </a:ext>
             </a:extLst>
           </p:cNvPr>
@@ -10010,7 +10010,7 @@
           <p:nvPr>
             <p:extLst>
               <p:ext uri="{D42A27DB-BD31-4B8C-83A1-F6EECF244321}">
-                <p14:modId xmlns:p14="http://schemas.microsoft.com/office/powerpoint/2010/main" val="2910230044"/>
+                <p14:modId xmlns:p14="http://schemas.microsoft.com/office/powerpoint/2010/main" val="4275897796"/>
               </p:ext>
             </p:extLst>
           </p:nvPr>
@@ -10029,21 +10029,21 @@
                 <a:gridCol w="3594100">
                   <a:extLst>
                     <a:ext uri="{9D8B030D-6E8A-4147-A177-3AD203B41FA5}">
-                      <a16:colId xmlns:a16="http://schemas.microsoft.com/office/drawing/2014/main" val="2787468656"/>
+                      <a16:colId xmlns:a16="http://schemas.microsoft.com/office/drawing/2014/main" val="4014726553"/>
                     </a:ext>
                   </a:extLst>
                 </a:gridCol>
                 <a:gridCol w="2286000">
                   <a:extLst>
                     <a:ext uri="{9D8B030D-6E8A-4147-A177-3AD203B41FA5}">
-                      <a16:colId xmlns:a16="http://schemas.microsoft.com/office/drawing/2014/main" val="2133135099"/>
+                      <a16:colId xmlns:a16="http://schemas.microsoft.com/office/drawing/2014/main" val="3018637457"/>
                     </a:ext>
                   </a:extLst>
                 </a:gridCol>
                 <a:gridCol w="2286000">
                   <a:extLst>
                     <a:ext uri="{9D8B030D-6E8A-4147-A177-3AD203B41FA5}">
-                      <a16:colId xmlns:a16="http://schemas.microsoft.com/office/drawing/2014/main" val="1176779284"/>
+                      <a16:colId xmlns:a16="http://schemas.microsoft.com/office/drawing/2014/main" val="4003018153"/>
                     </a:ext>
                   </a:extLst>
                 </a:gridCol>
@@ -10129,7 +10129,7 @@
                 </a:tc>
                 <a:extLst>
                   <a:ext uri="{0D108BD9-81ED-4DB2-BD59-A6C34878D82A}">
-                    <a16:rowId xmlns:a16="http://schemas.microsoft.com/office/drawing/2014/main" val="3315518391"/>
+                    <a16:rowId xmlns:a16="http://schemas.microsoft.com/office/drawing/2014/main" val="3070731997"/>
                   </a:ext>
                 </a:extLst>
               </a:tr>
@@ -10223,7 +10223,7 @@
                 </a:tc>
                 <a:extLst>
                   <a:ext uri="{0D108BD9-81ED-4DB2-BD59-A6C34878D82A}">
-                    <a16:rowId xmlns:a16="http://schemas.microsoft.com/office/drawing/2014/main" val="543254836"/>
+                    <a16:rowId xmlns:a16="http://schemas.microsoft.com/office/drawing/2014/main" val="2326238389"/>
                   </a:ext>
                 </a:extLst>
               </a:tr>
@@ -10317,7 +10317,7 @@
                 </a:tc>
                 <a:extLst>
                   <a:ext uri="{0D108BD9-81ED-4DB2-BD59-A6C34878D82A}">
-                    <a16:rowId xmlns:a16="http://schemas.microsoft.com/office/drawing/2014/main" val="18990172"/>
+                    <a16:rowId xmlns:a16="http://schemas.microsoft.com/office/drawing/2014/main" val="161774773"/>
                   </a:ext>
                 </a:extLst>
               </a:tr>
@@ -10411,7 +10411,7 @@
                 </a:tc>
                 <a:extLst>
                   <a:ext uri="{0D108BD9-81ED-4DB2-BD59-A6C34878D82A}">
-                    <a16:rowId xmlns:a16="http://schemas.microsoft.com/office/drawing/2014/main" val="921972455"/>
+                    <a16:rowId xmlns:a16="http://schemas.microsoft.com/office/drawing/2014/main" val="1619479670"/>
                   </a:ext>
                 </a:extLst>
               </a:tr>
@@ -10505,7 +10505,7 @@
                 </a:tc>
                 <a:extLst>
                   <a:ext uri="{0D108BD9-81ED-4DB2-BD59-A6C34878D82A}">
-                    <a16:rowId xmlns:a16="http://schemas.microsoft.com/office/drawing/2014/main" val="1042747767"/>
+                    <a16:rowId xmlns:a16="http://schemas.microsoft.com/office/drawing/2014/main" val="1559185791"/>
                   </a:ext>
                 </a:extLst>
               </a:tr>
@@ -10518,7 +10518,7 @@
           <p:cNvPr id="113" name="文本框 112">
             <a:extLst>
               <a:ext uri="{FF2B5EF4-FFF2-40B4-BE49-F238E27FC236}">
-                <a16:creationId xmlns:a16="http://schemas.microsoft.com/office/drawing/2014/main" id="{52A4F72B-8C68-CBE6-E746-2F023F52F9BE}"/>
+                <a16:creationId xmlns:a16="http://schemas.microsoft.com/office/drawing/2014/main" id="{2B54F5AF-6699-2AAA-1AB8-F5173D2C013B}"/>
               </a:ext>
             </a:extLst>
           </p:cNvPr>
@@ -10564,7 +10564,7 @@
           <p:cNvPr id="114" name="表格 113">
             <a:extLst>
               <a:ext uri="{FF2B5EF4-FFF2-40B4-BE49-F238E27FC236}">
-                <a16:creationId xmlns:a16="http://schemas.microsoft.com/office/drawing/2014/main" id="{88198563-9479-7BB1-B8A6-ED1957E368FD}"/>
+                <a16:creationId xmlns:a16="http://schemas.microsoft.com/office/drawing/2014/main" id="{707EB77B-DC0D-8552-2948-0B4F71E337AE}"/>
               </a:ext>
             </a:extLst>
           </p:cNvPr>
@@ -10574,7 +10574,7 @@
           <p:nvPr>
             <p:extLst>
               <p:ext uri="{D42A27DB-BD31-4B8C-83A1-F6EECF244321}">
-                <p14:modId xmlns:p14="http://schemas.microsoft.com/office/powerpoint/2010/main" val="139694482"/>
+                <p14:modId xmlns:p14="http://schemas.microsoft.com/office/powerpoint/2010/main" val="1902862977"/>
               </p:ext>
             </p:extLst>
           </p:nvPr>
@@ -10593,42 +10593,42 @@
                 <a:gridCol w="1054100">
                   <a:extLst>
                     <a:ext uri="{9D8B030D-6E8A-4147-A177-3AD203B41FA5}">
-                      <a16:colId xmlns:a16="http://schemas.microsoft.com/office/drawing/2014/main" val="1858995676"/>
+                      <a16:colId xmlns:a16="http://schemas.microsoft.com/office/drawing/2014/main" val="374448750"/>
                     </a:ext>
                   </a:extLst>
                 </a:gridCol>
                 <a:gridCol w="1524000">
                   <a:extLst>
                     <a:ext uri="{9D8B030D-6E8A-4147-A177-3AD203B41FA5}">
-                      <a16:colId xmlns:a16="http://schemas.microsoft.com/office/drawing/2014/main" val="1909301067"/>
+                      <a16:colId xmlns:a16="http://schemas.microsoft.com/office/drawing/2014/main" val="3018366560"/>
                     </a:ext>
                   </a:extLst>
                 </a:gridCol>
                 <a:gridCol w="1587500">
                   <a:extLst>
                     <a:ext uri="{9D8B030D-6E8A-4147-A177-3AD203B41FA5}">
-                      <a16:colId xmlns:a16="http://schemas.microsoft.com/office/drawing/2014/main" val="1864659958"/>
+                      <a16:colId xmlns:a16="http://schemas.microsoft.com/office/drawing/2014/main" val="57786743"/>
                     </a:ext>
                   </a:extLst>
                 </a:gridCol>
                 <a:gridCol w="1270000">
                   <a:extLst>
                     <a:ext uri="{9D8B030D-6E8A-4147-A177-3AD203B41FA5}">
-                      <a16:colId xmlns:a16="http://schemas.microsoft.com/office/drawing/2014/main" val="3651419296"/>
+                      <a16:colId xmlns:a16="http://schemas.microsoft.com/office/drawing/2014/main" val="972226433"/>
                     </a:ext>
                   </a:extLst>
                 </a:gridCol>
                 <a:gridCol w="1270000">
                   <a:extLst>
                     <a:ext uri="{9D8B030D-6E8A-4147-A177-3AD203B41FA5}">
-                      <a16:colId xmlns:a16="http://schemas.microsoft.com/office/drawing/2014/main" val="3531262032"/>
+                      <a16:colId xmlns:a16="http://schemas.microsoft.com/office/drawing/2014/main" val="980480718"/>
                     </a:ext>
                   </a:extLst>
                 </a:gridCol>
                 <a:gridCol w="1460500">
                   <a:extLst>
                     <a:ext uri="{9D8B030D-6E8A-4147-A177-3AD203B41FA5}">
-                      <a16:colId xmlns:a16="http://schemas.microsoft.com/office/drawing/2014/main" val="2927265393"/>
+                      <a16:colId xmlns:a16="http://schemas.microsoft.com/office/drawing/2014/main" val="607827423"/>
                     </a:ext>
                   </a:extLst>
                 </a:gridCol>
@@ -10801,7 +10801,7 @@
                 </a:tc>
                 <a:extLst>
                   <a:ext uri="{0D108BD9-81ED-4DB2-BD59-A6C34878D82A}">
-                    <a16:rowId xmlns:a16="http://schemas.microsoft.com/office/drawing/2014/main" val="2455379884"/>
+                    <a16:rowId xmlns:a16="http://schemas.microsoft.com/office/drawing/2014/main" val="2394424475"/>
                   </a:ext>
                 </a:extLst>
               </a:tr>
@@ -10964,7 +10964,7 @@
                           </a:solidFill>
                           <a:latin typeface="Calibri" panose="020F0502020204030204" pitchFamily="34" charset="0"/>
                         </a:rPr>
-                        <a:t>+0.15</a:t>
+                        <a:t>+0.26</a:t>
                       </a:r>
                       <a:endParaRPr lang="zh-CN" altLang="en-US" sz="2100" b="0">
                         <a:solidFill>
@@ -10982,7 +10982,7 @@
                 </a:tc>
                 <a:extLst>
                   <a:ext uri="{0D108BD9-81ED-4DB2-BD59-A6C34878D82A}">
-                    <a16:rowId xmlns:a16="http://schemas.microsoft.com/office/drawing/2014/main" val="2234093653"/>
+                    <a16:rowId xmlns:a16="http://schemas.microsoft.com/office/drawing/2014/main" val="1956640234"/>
                   </a:ext>
                 </a:extLst>
               </a:tr>
@@ -11163,7 +11163,7 @@
                 </a:tc>
                 <a:extLst>
                   <a:ext uri="{0D108BD9-81ED-4DB2-BD59-A6C34878D82A}">
-                    <a16:rowId xmlns:a16="http://schemas.microsoft.com/office/drawing/2014/main" val="1119201674"/>
+                    <a16:rowId xmlns:a16="http://schemas.microsoft.com/office/drawing/2014/main" val="1983762462"/>
                   </a:ext>
                 </a:extLst>
               </a:tr>
@@ -11176,7 +11176,7 @@
           <p:cNvPr id="115" name="card 6">
             <a:extLst>
               <a:ext uri="{FF2B5EF4-FFF2-40B4-BE49-F238E27FC236}">
-                <a16:creationId xmlns:a16="http://schemas.microsoft.com/office/drawing/2014/main" id="{DED2AD83-E2B8-428E-9697-2F2FCED92181}"/>
+                <a16:creationId xmlns:a16="http://schemas.microsoft.com/office/drawing/2014/main" id="{BA1AD1B0-AF34-5396-D21F-05029F9B7AEE}"/>
               </a:ext>
             </a:extLst>
           </p:cNvPr>
@@ -11246,7 +11246,7 @@
           <p:cNvPr id="116" name="badge 6">
             <a:extLst>
               <a:ext uri="{FF2B5EF4-FFF2-40B4-BE49-F238E27FC236}">
-                <a16:creationId xmlns:a16="http://schemas.microsoft.com/office/drawing/2014/main" id="{3B0872F4-5FB8-4AB8-A7EE-7B8B671CD969}"/>
+                <a16:creationId xmlns:a16="http://schemas.microsoft.com/office/drawing/2014/main" id="{7453FACF-14F4-C613-59B0-C2C2C0EB9D02}"/>
               </a:ext>
             </a:extLst>
           </p:cNvPr>
@@ -11328,7 +11328,7 @@
           <p:cNvPr id="117" name="title 6">
             <a:extLst>
               <a:ext uri="{FF2B5EF4-FFF2-40B4-BE49-F238E27FC236}">
-                <a16:creationId xmlns:a16="http://schemas.microsoft.com/office/drawing/2014/main" id="{A0C5FF35-C156-7473-C672-664FCA107DB3}"/>
+                <a16:creationId xmlns:a16="http://schemas.microsoft.com/office/drawing/2014/main" id="{8B0F140A-F65E-726B-01E3-F73A942E7E1A}"/>
               </a:ext>
             </a:extLst>
           </p:cNvPr>
@@ -11374,7 +11374,7 @@
           <p:cNvPr id="119" name="图片 118">
             <a:extLst>
               <a:ext uri="{FF2B5EF4-FFF2-40B4-BE49-F238E27FC236}">
-                <a16:creationId xmlns:a16="http://schemas.microsoft.com/office/drawing/2014/main" id="{CA072971-CB47-331B-D818-FBFCA0E1C87D}"/>
+                <a16:creationId xmlns:a16="http://schemas.microsoft.com/office/drawing/2014/main" id="{F5911503-E58C-C992-45BB-5DB5378095E6}"/>
               </a:ext>
             </a:extLst>
           </p:cNvPr>
@@ -11410,7 +11410,7 @@
           <p:cNvPr id="120" name="文本框 119">
             <a:extLst>
               <a:ext uri="{FF2B5EF4-FFF2-40B4-BE49-F238E27FC236}">
-                <a16:creationId xmlns:a16="http://schemas.microsoft.com/office/drawing/2014/main" id="{D7FEB570-69CA-9170-B049-91DA3AF3BC48}"/>
+                <a16:creationId xmlns:a16="http://schemas.microsoft.com/office/drawing/2014/main" id="{8682FFC2-191C-2228-1A13-52381D3B10BA}"/>
               </a:ext>
             </a:extLst>
           </p:cNvPr>
@@ -11487,7 +11487,7 @@
           <p:cNvPr id="121" name="card 7">
             <a:extLst>
               <a:ext uri="{FF2B5EF4-FFF2-40B4-BE49-F238E27FC236}">
-                <a16:creationId xmlns:a16="http://schemas.microsoft.com/office/drawing/2014/main" id="{F48EACCD-7B29-8F71-F357-384A94E9B2F3}"/>
+                <a16:creationId xmlns:a16="http://schemas.microsoft.com/office/drawing/2014/main" id="{4A7F605B-7E68-D95A-839F-768930810AAA}"/>
               </a:ext>
             </a:extLst>
           </p:cNvPr>
@@ -11557,7 +11557,7 @@
           <p:cNvPr id="122" name="badge 7">
             <a:extLst>
               <a:ext uri="{FF2B5EF4-FFF2-40B4-BE49-F238E27FC236}">
-                <a16:creationId xmlns:a16="http://schemas.microsoft.com/office/drawing/2014/main" id="{97C97CD9-43DA-CE79-243C-62C86437E0D8}"/>
+                <a16:creationId xmlns:a16="http://schemas.microsoft.com/office/drawing/2014/main" id="{0BAEF2EE-A656-CEF6-0989-4EA9FE115409}"/>
               </a:ext>
             </a:extLst>
           </p:cNvPr>
@@ -11639,7 +11639,7 @@
           <p:cNvPr id="123" name="title 7">
             <a:extLst>
               <a:ext uri="{FF2B5EF4-FFF2-40B4-BE49-F238E27FC236}">
-                <a16:creationId xmlns:a16="http://schemas.microsoft.com/office/drawing/2014/main" id="{C7791312-BB2B-AA42-C4F6-B51EDD9AB97C}"/>
+                <a16:creationId xmlns:a16="http://schemas.microsoft.com/office/drawing/2014/main" id="{AB014EBB-5986-78B7-4270-6B291B1B347F}"/>
               </a:ext>
             </a:extLst>
           </p:cNvPr>
@@ -11685,7 +11685,7 @@
           <p:cNvPr id="124" name="表格 123">
             <a:extLst>
               <a:ext uri="{FF2B5EF4-FFF2-40B4-BE49-F238E27FC236}">
-                <a16:creationId xmlns:a16="http://schemas.microsoft.com/office/drawing/2014/main" id="{ADCF0D8F-7CF3-1527-2297-EA4E5EC46180}"/>
+                <a16:creationId xmlns:a16="http://schemas.microsoft.com/office/drawing/2014/main" id="{10DA6328-6BCF-5A41-C725-78E3CED9E3FB}"/>
               </a:ext>
             </a:extLst>
           </p:cNvPr>
@@ -11695,7 +11695,7 @@
           <p:nvPr>
             <p:extLst>
               <p:ext uri="{D42A27DB-BD31-4B8C-83A1-F6EECF244321}">
-                <p14:modId xmlns:p14="http://schemas.microsoft.com/office/powerpoint/2010/main" val="3726457239"/>
+                <p14:modId xmlns:p14="http://schemas.microsoft.com/office/powerpoint/2010/main" val="437787023"/>
               </p:ext>
             </p:extLst>
           </p:nvPr>
@@ -11714,21 +11714,21 @@
                 <a:gridCol w="2730500">
                   <a:extLst>
                     <a:ext uri="{9D8B030D-6E8A-4147-A177-3AD203B41FA5}">
-                      <a16:colId xmlns:a16="http://schemas.microsoft.com/office/drawing/2014/main" val="2275296977"/>
+                      <a16:colId xmlns:a16="http://schemas.microsoft.com/office/drawing/2014/main" val="129918804"/>
                     </a:ext>
                   </a:extLst>
                 </a:gridCol>
                 <a:gridCol w="2705100">
                   <a:extLst>
                     <a:ext uri="{9D8B030D-6E8A-4147-A177-3AD203B41FA5}">
-                      <a16:colId xmlns:a16="http://schemas.microsoft.com/office/drawing/2014/main" val="374560581"/>
+                      <a16:colId xmlns:a16="http://schemas.microsoft.com/office/drawing/2014/main" val="993240396"/>
                     </a:ext>
                   </a:extLst>
                 </a:gridCol>
                 <a:gridCol w="2730500">
                   <a:extLst>
                     <a:ext uri="{9D8B030D-6E8A-4147-A177-3AD203B41FA5}">
-                      <a16:colId xmlns:a16="http://schemas.microsoft.com/office/drawing/2014/main" val="668507788"/>
+                      <a16:colId xmlns:a16="http://schemas.microsoft.com/office/drawing/2014/main" val="499665444"/>
                     </a:ext>
                   </a:extLst>
                 </a:gridCol>
@@ -11814,7 +11814,7 @@
                 </a:tc>
                 <a:extLst>
                   <a:ext uri="{0D108BD9-81ED-4DB2-BD59-A6C34878D82A}">
-                    <a16:rowId xmlns:a16="http://schemas.microsoft.com/office/drawing/2014/main" val="1130496953"/>
+                    <a16:rowId xmlns:a16="http://schemas.microsoft.com/office/drawing/2014/main" val="1818555207"/>
                   </a:ext>
                 </a:extLst>
               </a:tr>
@@ -11908,7 +11908,7 @@
                 </a:tc>
                 <a:extLst>
                   <a:ext uri="{0D108BD9-81ED-4DB2-BD59-A6C34878D82A}">
-                    <a16:rowId xmlns:a16="http://schemas.microsoft.com/office/drawing/2014/main" val="2627200832"/>
+                    <a16:rowId xmlns:a16="http://schemas.microsoft.com/office/drawing/2014/main" val="1393723304"/>
                   </a:ext>
                 </a:extLst>
               </a:tr>
@@ -12002,7 +12002,7 @@
                 </a:tc>
                 <a:extLst>
                   <a:ext uri="{0D108BD9-81ED-4DB2-BD59-A6C34878D82A}">
-                    <a16:rowId xmlns:a16="http://schemas.microsoft.com/office/drawing/2014/main" val="220487213"/>
+                    <a16:rowId xmlns:a16="http://schemas.microsoft.com/office/drawing/2014/main" val="86234312"/>
                   </a:ext>
                 </a:extLst>
               </a:tr>
@@ -12096,7 +12096,7 @@
                 </a:tc>
                 <a:extLst>
                   <a:ext uri="{0D108BD9-81ED-4DB2-BD59-A6C34878D82A}">
-                    <a16:rowId xmlns:a16="http://schemas.microsoft.com/office/drawing/2014/main" val="650140841"/>
+                    <a16:rowId xmlns:a16="http://schemas.microsoft.com/office/drawing/2014/main" val="2913505710"/>
                   </a:ext>
                 </a:extLst>
               </a:tr>
@@ -12190,7 +12190,7 @@
                 </a:tc>
                 <a:extLst>
                   <a:ext uri="{0D108BD9-81ED-4DB2-BD59-A6C34878D82A}">
-                    <a16:rowId xmlns:a16="http://schemas.microsoft.com/office/drawing/2014/main" val="571500526"/>
+                    <a16:rowId xmlns:a16="http://schemas.microsoft.com/office/drawing/2014/main" val="658396329"/>
                   </a:ext>
                 </a:extLst>
               </a:tr>
@@ -12284,7 +12284,7 @@
                 </a:tc>
                 <a:extLst>
                   <a:ext uri="{0D108BD9-81ED-4DB2-BD59-A6C34878D82A}">
-                    <a16:rowId xmlns:a16="http://schemas.microsoft.com/office/drawing/2014/main" val="2573623666"/>
+                    <a16:rowId xmlns:a16="http://schemas.microsoft.com/office/drawing/2014/main" val="1673636343"/>
                   </a:ext>
                 </a:extLst>
               </a:tr>
@@ -12297,7 +12297,7 @@
           <p:cNvPr id="125" name="文本框 124">
             <a:extLst>
               <a:ext uri="{FF2B5EF4-FFF2-40B4-BE49-F238E27FC236}">
-                <a16:creationId xmlns:a16="http://schemas.microsoft.com/office/drawing/2014/main" id="{E44546C8-07A6-3E41-C933-9C13BF88F906}"/>
+                <a16:creationId xmlns:a16="http://schemas.microsoft.com/office/drawing/2014/main" id="{5FE32F0F-FA31-BAC9-1E89-8C4339115356}"/>
               </a:ext>
             </a:extLst>
           </p:cNvPr>
@@ -12343,7 +12343,7 @@
           <p:cNvPr id="126" name="card 8">
             <a:extLst>
               <a:ext uri="{FF2B5EF4-FFF2-40B4-BE49-F238E27FC236}">
-                <a16:creationId xmlns:a16="http://schemas.microsoft.com/office/drawing/2014/main" id="{AB00C2A3-2EE3-D2D7-74CA-BD60824874B2}"/>
+                <a16:creationId xmlns:a16="http://schemas.microsoft.com/office/drawing/2014/main" id="{DFC22B31-AB82-B8DC-EC93-8C7C27B24A0B}"/>
               </a:ext>
             </a:extLst>
           </p:cNvPr>
@@ -12413,7 +12413,7 @@
           <p:cNvPr id="127" name="badge 8">
             <a:extLst>
               <a:ext uri="{FF2B5EF4-FFF2-40B4-BE49-F238E27FC236}">
-                <a16:creationId xmlns:a16="http://schemas.microsoft.com/office/drawing/2014/main" id="{5F69600A-F752-3D49-AF29-30C53B6E2857}"/>
+                <a16:creationId xmlns:a16="http://schemas.microsoft.com/office/drawing/2014/main" id="{CBCA01D9-9929-F260-5EDC-209DF585E89E}"/>
               </a:ext>
             </a:extLst>
           </p:cNvPr>
@@ -12495,7 +12495,7 @@
           <p:cNvPr id="128" name="title 8">
             <a:extLst>
               <a:ext uri="{FF2B5EF4-FFF2-40B4-BE49-F238E27FC236}">
-                <a16:creationId xmlns:a16="http://schemas.microsoft.com/office/drawing/2014/main" id="{89486330-4443-08C6-5E2D-5CC22C0BE89D}"/>
+                <a16:creationId xmlns:a16="http://schemas.microsoft.com/office/drawing/2014/main" id="{492AAF10-7D65-3545-813D-145CFCE6BD4C}"/>
               </a:ext>
             </a:extLst>
           </p:cNvPr>
@@ -12541,7 +12541,7 @@
           <p:cNvPr id="130" name="图片 129">
             <a:extLst>
               <a:ext uri="{FF2B5EF4-FFF2-40B4-BE49-F238E27FC236}">
-                <a16:creationId xmlns:a16="http://schemas.microsoft.com/office/drawing/2014/main" id="{91857929-D64A-C827-7C78-68FCD6EB0A7C}"/>
+                <a16:creationId xmlns:a16="http://schemas.microsoft.com/office/drawing/2014/main" id="{273804B8-CD0D-5E41-97F4-E21B6EE17E43}"/>
               </a:ext>
             </a:extLst>
           </p:cNvPr>
@@ -12577,7 +12577,7 @@
           <p:cNvPr id="131" name="文本框 130">
             <a:extLst>
               <a:ext uri="{FF2B5EF4-FFF2-40B4-BE49-F238E27FC236}">
-                <a16:creationId xmlns:a16="http://schemas.microsoft.com/office/drawing/2014/main" id="{35A7B70C-DEAA-DAEC-B01E-85AF33F38C48}"/>
+                <a16:creationId xmlns:a16="http://schemas.microsoft.com/office/drawing/2014/main" id="{60DA4EAE-22C7-6EE3-F43C-65AF9899BEF4}"/>
               </a:ext>
             </a:extLst>
           </p:cNvPr>
@@ -12717,7 +12717,7 @@
           <p:cNvPr id="133" name="图片 132">
             <a:extLst>
               <a:ext uri="{FF2B5EF4-FFF2-40B4-BE49-F238E27FC236}">
-                <a16:creationId xmlns:a16="http://schemas.microsoft.com/office/drawing/2014/main" id="{21A4D6D7-FACF-8F92-5915-18AEC5A06A2B}"/>
+                <a16:creationId xmlns:a16="http://schemas.microsoft.com/office/drawing/2014/main" id="{6C1B6074-7AFE-22CE-49A5-3FCAF978DF55}"/>
               </a:ext>
             </a:extLst>
           </p:cNvPr>
@@ -12753,7 +12753,7 @@
           <p:cNvPr id="134" name="文本框 133">
             <a:extLst>
               <a:ext uri="{FF2B5EF4-FFF2-40B4-BE49-F238E27FC236}">
-                <a16:creationId xmlns:a16="http://schemas.microsoft.com/office/drawing/2014/main" id="{EF3CBDF2-B146-6DD3-6F97-5A7C5718DA58}"/>
+                <a16:creationId xmlns:a16="http://schemas.microsoft.com/office/drawing/2014/main" id="{FAAADF6C-7CFB-20B4-C796-E7BDA0552A3B}"/>
               </a:ext>
             </a:extLst>
           </p:cNvPr>
@@ -12799,7 +12799,7 @@
           <p:cNvPr id="135" name="文本框 134">
             <a:extLst>
               <a:ext uri="{FF2B5EF4-FFF2-40B4-BE49-F238E27FC236}">
-                <a16:creationId xmlns:a16="http://schemas.microsoft.com/office/drawing/2014/main" id="{5D6405FC-D5AD-EF0F-FA67-D68C69621A25}"/>
+                <a16:creationId xmlns:a16="http://schemas.microsoft.com/office/drawing/2014/main" id="{3CE4E6E5-B0F7-C244-0D38-3FFF72C53725}"/>
               </a:ext>
             </a:extLst>
           </p:cNvPr>
@@ -12843,7 +12843,7 @@
     </p:spTree>
     <p:extLst>
       <p:ext uri="{BB962C8B-B14F-4D97-AF65-F5344CB8AC3E}">
-        <p14:creationId xmlns:p14="http://schemas.microsoft.com/office/powerpoint/2010/main" val="3588585770"/>
+        <p14:creationId xmlns:p14="http://schemas.microsoft.com/office/powerpoint/2010/main" val="1801104658"/>
       </p:ext>
     </p:extLst>
   </p:cSld>

</xml_diff>

<commit_message>
Measured power from the on-board PMBus telemetry: table 3-1/3-2, overview, comparison with [3], poster
- board/tests/power_rails.py: rail sampling (IRPS5401 via pynq.get_rails), PL / PS / DDR groups
- data/measurements/power: TX / RX in DeepJSCC-Q, SSCC and idle (60 s means)

Co-Authored-By: Claude Opus 5.5 <noreply@anthropic.com>
</commit_message>
<xml_diff>
--- a/report/poster/poster_en.pptx
+++ b/report/poster/poster_en.pptx
@@ -129,7 +129,7 @@
           <p:cNvPr id="2" name="标题 1">
             <a:extLst>
               <a:ext uri="{FF2B5EF4-FFF2-40B4-BE49-F238E27FC236}">
-                <a16:creationId xmlns:a16="http://schemas.microsoft.com/office/drawing/2014/main" id="{12519FB6-34C2-8412-6540-9D1AE1079B8D}"/>
+                <a16:creationId xmlns:a16="http://schemas.microsoft.com/office/drawing/2014/main" id="{72E1D925-21DE-2EAD-BAE8-CC5F32B8ABB8}"/>
               </a:ext>
             </a:extLst>
           </p:cNvPr>
@@ -166,7 +166,7 @@
           <p:cNvPr id="3" name="副标题 2">
             <a:extLst>
               <a:ext uri="{FF2B5EF4-FFF2-40B4-BE49-F238E27FC236}">
-                <a16:creationId xmlns:a16="http://schemas.microsoft.com/office/drawing/2014/main" id="{388048E2-9DE6-BD03-AD8F-F3E66CBEE65A}"/>
+                <a16:creationId xmlns:a16="http://schemas.microsoft.com/office/drawing/2014/main" id="{B5701ECF-56E1-C938-2BCE-9B2F78F40248}"/>
               </a:ext>
             </a:extLst>
           </p:cNvPr>
@@ -236,7 +236,7 @@
           <p:cNvPr id="4" name="日期占位符 3">
             <a:extLst>
               <a:ext uri="{FF2B5EF4-FFF2-40B4-BE49-F238E27FC236}">
-                <a16:creationId xmlns:a16="http://schemas.microsoft.com/office/drawing/2014/main" id="{C4D48CA1-4587-AAB9-872E-B54CADCC1827}"/>
+                <a16:creationId xmlns:a16="http://schemas.microsoft.com/office/drawing/2014/main" id="{46639C92-5940-B9AF-65BC-DDEBAF653908}"/>
               </a:ext>
             </a:extLst>
           </p:cNvPr>
@@ -252,9 +252,9 @@
           <a:bodyPr/>
           <a:lstStyle/>
           <a:p>
-            <a:fld id="{BE8E5DDC-8DBC-495D-83D8-7932EBA21A75}" type="datetimeFigureOut">
+            <a:fld id="{6384808E-1183-4387-8AB9-77C9D907A16E}" type="datetimeFigureOut">
               <a:rPr lang="zh-CN" altLang="en-US" smtClean="0"/>
-              <a:t>2026/10/13</a:t>
+              <a:t>2026/10/14</a:t>
             </a:fld>
             <a:endParaRPr lang="zh-CN" altLang="en-US"/>
           </a:p>
@@ -265,7 +265,7 @@
           <p:cNvPr id="5" name="页脚占位符 4">
             <a:extLst>
               <a:ext uri="{FF2B5EF4-FFF2-40B4-BE49-F238E27FC236}">
-                <a16:creationId xmlns:a16="http://schemas.microsoft.com/office/drawing/2014/main" id="{D1C2A123-19CD-9256-6ED7-91018FBA449C}"/>
+                <a16:creationId xmlns:a16="http://schemas.microsoft.com/office/drawing/2014/main" id="{31A02BC3-5921-14E1-2305-8E5FBC21D5EB}"/>
               </a:ext>
             </a:extLst>
           </p:cNvPr>
@@ -290,7 +290,7 @@
           <p:cNvPr id="6" name="灯片编号占位符 5">
             <a:extLst>
               <a:ext uri="{FF2B5EF4-FFF2-40B4-BE49-F238E27FC236}">
-                <a16:creationId xmlns:a16="http://schemas.microsoft.com/office/drawing/2014/main" id="{F09A46F0-491A-8594-F742-D0819921042B}"/>
+                <a16:creationId xmlns:a16="http://schemas.microsoft.com/office/drawing/2014/main" id="{634114F6-865C-CF0D-6B77-84D19EA29626}"/>
               </a:ext>
             </a:extLst>
           </p:cNvPr>
@@ -306,7 +306,7 @@
           <a:bodyPr/>
           <a:lstStyle/>
           <a:p>
-            <a:fld id="{41F10874-7FDD-43DA-9458-5F9582894316}" type="slidenum">
+            <a:fld id="{15780841-F22E-4DB3-84CB-AB615471C832}" type="slidenum">
               <a:rPr lang="zh-CN" altLang="en-US" smtClean="0"/>
               <a:t>‹#›</a:t>
             </a:fld>
@@ -317,7 +317,7 @@
     </p:spTree>
     <p:extLst>
       <p:ext uri="{BB962C8B-B14F-4D97-AF65-F5344CB8AC3E}">
-        <p14:creationId xmlns:p14="http://schemas.microsoft.com/office/powerpoint/2010/main" val="4202444517"/>
+        <p14:creationId xmlns:p14="http://schemas.microsoft.com/office/powerpoint/2010/main" val="1060995223"/>
       </p:ext>
     </p:extLst>
   </p:cSld>
@@ -349,7 +349,7 @@
           <p:cNvPr id="2" name="标题 1">
             <a:extLst>
               <a:ext uri="{FF2B5EF4-FFF2-40B4-BE49-F238E27FC236}">
-                <a16:creationId xmlns:a16="http://schemas.microsoft.com/office/drawing/2014/main" id="{40D75071-C62B-8C02-4BBA-F550CF50BA88}"/>
+                <a16:creationId xmlns:a16="http://schemas.microsoft.com/office/drawing/2014/main" id="{A9EA3C9D-7769-F368-7EC8-5E4668838319}"/>
               </a:ext>
             </a:extLst>
           </p:cNvPr>
@@ -377,7 +377,7 @@
           <p:cNvPr id="3" name="竖排文字占位符 2">
             <a:extLst>
               <a:ext uri="{FF2B5EF4-FFF2-40B4-BE49-F238E27FC236}">
-                <a16:creationId xmlns:a16="http://schemas.microsoft.com/office/drawing/2014/main" id="{AF9F8E03-13F6-2834-10C6-30C6FAE50343}"/>
+                <a16:creationId xmlns:a16="http://schemas.microsoft.com/office/drawing/2014/main" id="{CD544C82-F4B5-0822-2889-20B7D00EE8A8}"/>
               </a:ext>
             </a:extLst>
           </p:cNvPr>
@@ -434,7 +434,7 @@
           <p:cNvPr id="4" name="日期占位符 3">
             <a:extLst>
               <a:ext uri="{FF2B5EF4-FFF2-40B4-BE49-F238E27FC236}">
-                <a16:creationId xmlns:a16="http://schemas.microsoft.com/office/drawing/2014/main" id="{7090408D-2B0D-AC8F-A43A-CDBACDE47D0C}"/>
+                <a16:creationId xmlns:a16="http://schemas.microsoft.com/office/drawing/2014/main" id="{89A90BA1-9AA2-FCE3-0CAE-B682B4C07B17}"/>
               </a:ext>
             </a:extLst>
           </p:cNvPr>
@@ -450,9 +450,9 @@
           <a:bodyPr/>
           <a:lstStyle/>
           <a:p>
-            <a:fld id="{BE8E5DDC-8DBC-495D-83D8-7932EBA21A75}" type="datetimeFigureOut">
+            <a:fld id="{6384808E-1183-4387-8AB9-77C9D907A16E}" type="datetimeFigureOut">
               <a:rPr lang="zh-CN" altLang="en-US" smtClean="0"/>
-              <a:t>2026/10/13</a:t>
+              <a:t>2026/10/14</a:t>
             </a:fld>
             <a:endParaRPr lang="zh-CN" altLang="en-US"/>
           </a:p>
@@ -463,7 +463,7 @@
           <p:cNvPr id="5" name="页脚占位符 4">
             <a:extLst>
               <a:ext uri="{FF2B5EF4-FFF2-40B4-BE49-F238E27FC236}">
-                <a16:creationId xmlns:a16="http://schemas.microsoft.com/office/drawing/2014/main" id="{03D0AEFF-0E60-D1C3-500B-44CCE5D9304B}"/>
+                <a16:creationId xmlns:a16="http://schemas.microsoft.com/office/drawing/2014/main" id="{924A5574-6A31-14E6-992C-C7A9AB39A679}"/>
               </a:ext>
             </a:extLst>
           </p:cNvPr>
@@ -488,7 +488,7 @@
           <p:cNvPr id="6" name="灯片编号占位符 5">
             <a:extLst>
               <a:ext uri="{FF2B5EF4-FFF2-40B4-BE49-F238E27FC236}">
-                <a16:creationId xmlns:a16="http://schemas.microsoft.com/office/drawing/2014/main" id="{99AF804C-B074-FF96-F424-F7DEA1CF72A5}"/>
+                <a16:creationId xmlns:a16="http://schemas.microsoft.com/office/drawing/2014/main" id="{BFF74426-15BC-7386-D8FA-82A1706614D8}"/>
               </a:ext>
             </a:extLst>
           </p:cNvPr>
@@ -504,7 +504,7 @@
           <a:bodyPr/>
           <a:lstStyle/>
           <a:p>
-            <a:fld id="{41F10874-7FDD-43DA-9458-5F9582894316}" type="slidenum">
+            <a:fld id="{15780841-F22E-4DB3-84CB-AB615471C832}" type="slidenum">
               <a:rPr lang="zh-CN" altLang="en-US" smtClean="0"/>
               <a:t>‹#›</a:t>
             </a:fld>
@@ -515,7 +515,7 @@
     </p:spTree>
     <p:extLst>
       <p:ext uri="{BB962C8B-B14F-4D97-AF65-F5344CB8AC3E}">
-        <p14:creationId xmlns:p14="http://schemas.microsoft.com/office/powerpoint/2010/main" val="3030597835"/>
+        <p14:creationId xmlns:p14="http://schemas.microsoft.com/office/powerpoint/2010/main" val="895909683"/>
       </p:ext>
     </p:extLst>
   </p:cSld>
@@ -547,7 +547,7 @@
           <p:cNvPr id="2" name="竖排标题 1">
             <a:extLst>
               <a:ext uri="{FF2B5EF4-FFF2-40B4-BE49-F238E27FC236}">
-                <a16:creationId xmlns:a16="http://schemas.microsoft.com/office/drawing/2014/main" id="{3FAC9108-54FA-6FE3-A147-F7DEEA61739E}"/>
+                <a16:creationId xmlns:a16="http://schemas.microsoft.com/office/drawing/2014/main" id="{04FD2A6C-431D-A126-497B-3DC9FC72BD16}"/>
               </a:ext>
             </a:extLst>
           </p:cNvPr>
@@ -580,7 +580,7 @@
           <p:cNvPr id="3" name="竖排文字占位符 2">
             <a:extLst>
               <a:ext uri="{FF2B5EF4-FFF2-40B4-BE49-F238E27FC236}">
-                <a16:creationId xmlns:a16="http://schemas.microsoft.com/office/drawing/2014/main" id="{442950C5-8B83-E585-CA78-EEC5F991E5DA}"/>
+                <a16:creationId xmlns:a16="http://schemas.microsoft.com/office/drawing/2014/main" id="{BB078B50-A39F-E366-F8CC-7E440F05F0C7}"/>
               </a:ext>
             </a:extLst>
           </p:cNvPr>
@@ -642,7 +642,7 @@
           <p:cNvPr id="4" name="日期占位符 3">
             <a:extLst>
               <a:ext uri="{FF2B5EF4-FFF2-40B4-BE49-F238E27FC236}">
-                <a16:creationId xmlns:a16="http://schemas.microsoft.com/office/drawing/2014/main" id="{645938DE-2D89-1A97-E1CA-487BA984A8A2}"/>
+                <a16:creationId xmlns:a16="http://schemas.microsoft.com/office/drawing/2014/main" id="{C7FEC1D0-7702-E4EC-9545-8714D244612F}"/>
               </a:ext>
             </a:extLst>
           </p:cNvPr>
@@ -658,9 +658,9 @@
           <a:bodyPr/>
           <a:lstStyle/>
           <a:p>
-            <a:fld id="{BE8E5DDC-8DBC-495D-83D8-7932EBA21A75}" type="datetimeFigureOut">
+            <a:fld id="{6384808E-1183-4387-8AB9-77C9D907A16E}" type="datetimeFigureOut">
               <a:rPr lang="zh-CN" altLang="en-US" smtClean="0"/>
-              <a:t>2026/10/13</a:t>
+              <a:t>2026/10/14</a:t>
             </a:fld>
             <a:endParaRPr lang="zh-CN" altLang="en-US"/>
           </a:p>
@@ -671,7 +671,7 @@
           <p:cNvPr id="5" name="页脚占位符 4">
             <a:extLst>
               <a:ext uri="{FF2B5EF4-FFF2-40B4-BE49-F238E27FC236}">
-                <a16:creationId xmlns:a16="http://schemas.microsoft.com/office/drawing/2014/main" id="{8ACF7864-F65F-4268-85CD-5E44A4F8717E}"/>
+                <a16:creationId xmlns:a16="http://schemas.microsoft.com/office/drawing/2014/main" id="{59036DBE-AD12-3516-35D9-958059D519BC}"/>
               </a:ext>
             </a:extLst>
           </p:cNvPr>
@@ -696,7 +696,7 @@
           <p:cNvPr id="6" name="灯片编号占位符 5">
             <a:extLst>
               <a:ext uri="{FF2B5EF4-FFF2-40B4-BE49-F238E27FC236}">
-                <a16:creationId xmlns:a16="http://schemas.microsoft.com/office/drawing/2014/main" id="{8AD6E01D-16CE-CFC6-DD57-D6DB6979634E}"/>
+                <a16:creationId xmlns:a16="http://schemas.microsoft.com/office/drawing/2014/main" id="{2829A27F-8D08-06E5-3BB1-66A068B5452D}"/>
               </a:ext>
             </a:extLst>
           </p:cNvPr>
@@ -712,7 +712,7 @@
           <a:bodyPr/>
           <a:lstStyle/>
           <a:p>
-            <a:fld id="{41F10874-7FDD-43DA-9458-5F9582894316}" type="slidenum">
+            <a:fld id="{15780841-F22E-4DB3-84CB-AB615471C832}" type="slidenum">
               <a:rPr lang="zh-CN" altLang="en-US" smtClean="0"/>
               <a:t>‹#›</a:t>
             </a:fld>
@@ -723,7 +723,7 @@
     </p:spTree>
     <p:extLst>
       <p:ext uri="{BB962C8B-B14F-4D97-AF65-F5344CB8AC3E}">
-        <p14:creationId xmlns:p14="http://schemas.microsoft.com/office/powerpoint/2010/main" val="642428704"/>
+        <p14:creationId xmlns:p14="http://schemas.microsoft.com/office/powerpoint/2010/main" val="555987709"/>
       </p:ext>
     </p:extLst>
   </p:cSld>
@@ -755,7 +755,7 @@
           <p:cNvPr id="2" name="标题 1">
             <a:extLst>
               <a:ext uri="{FF2B5EF4-FFF2-40B4-BE49-F238E27FC236}">
-                <a16:creationId xmlns:a16="http://schemas.microsoft.com/office/drawing/2014/main" id="{D54C3486-F063-4B53-B154-E923EBB03A7D}"/>
+                <a16:creationId xmlns:a16="http://schemas.microsoft.com/office/drawing/2014/main" id="{A701A0BD-D103-EC23-24B3-0ABC35E4DE19}"/>
               </a:ext>
             </a:extLst>
           </p:cNvPr>
@@ -783,7 +783,7 @@
           <p:cNvPr id="3" name="内容占位符 2">
             <a:extLst>
               <a:ext uri="{FF2B5EF4-FFF2-40B4-BE49-F238E27FC236}">
-                <a16:creationId xmlns:a16="http://schemas.microsoft.com/office/drawing/2014/main" id="{807E657F-B64C-C031-E81C-2C67A456580C}"/>
+                <a16:creationId xmlns:a16="http://schemas.microsoft.com/office/drawing/2014/main" id="{1AE9539D-0462-094C-CB58-5F3817D81610}"/>
               </a:ext>
             </a:extLst>
           </p:cNvPr>
@@ -840,7 +840,7 @@
           <p:cNvPr id="4" name="日期占位符 3">
             <a:extLst>
               <a:ext uri="{FF2B5EF4-FFF2-40B4-BE49-F238E27FC236}">
-                <a16:creationId xmlns:a16="http://schemas.microsoft.com/office/drawing/2014/main" id="{AE46672A-D35B-331E-5147-02461F7B9E1C}"/>
+                <a16:creationId xmlns:a16="http://schemas.microsoft.com/office/drawing/2014/main" id="{DD65C108-6811-E799-8F69-41FEA2B50071}"/>
               </a:ext>
             </a:extLst>
           </p:cNvPr>
@@ -856,9 +856,9 @@
           <a:bodyPr/>
           <a:lstStyle/>
           <a:p>
-            <a:fld id="{BE8E5DDC-8DBC-495D-83D8-7932EBA21A75}" type="datetimeFigureOut">
+            <a:fld id="{6384808E-1183-4387-8AB9-77C9D907A16E}" type="datetimeFigureOut">
               <a:rPr lang="zh-CN" altLang="en-US" smtClean="0"/>
-              <a:t>2026/10/13</a:t>
+              <a:t>2026/10/14</a:t>
             </a:fld>
             <a:endParaRPr lang="zh-CN" altLang="en-US"/>
           </a:p>
@@ -869,7 +869,7 @@
           <p:cNvPr id="5" name="页脚占位符 4">
             <a:extLst>
               <a:ext uri="{FF2B5EF4-FFF2-40B4-BE49-F238E27FC236}">
-                <a16:creationId xmlns:a16="http://schemas.microsoft.com/office/drawing/2014/main" id="{975DE714-AA4D-2F8B-4A59-780293C7BDEC}"/>
+                <a16:creationId xmlns:a16="http://schemas.microsoft.com/office/drawing/2014/main" id="{4846EAE5-D002-4468-DAEC-ABC3EFC9FA25}"/>
               </a:ext>
             </a:extLst>
           </p:cNvPr>
@@ -894,7 +894,7 @@
           <p:cNvPr id="6" name="灯片编号占位符 5">
             <a:extLst>
               <a:ext uri="{FF2B5EF4-FFF2-40B4-BE49-F238E27FC236}">
-                <a16:creationId xmlns:a16="http://schemas.microsoft.com/office/drawing/2014/main" id="{78137555-BF31-9252-5748-F431B16B9B88}"/>
+                <a16:creationId xmlns:a16="http://schemas.microsoft.com/office/drawing/2014/main" id="{FDCE8EE9-21AC-9A9D-5346-CE980DD4F09A}"/>
               </a:ext>
             </a:extLst>
           </p:cNvPr>
@@ -910,7 +910,7 @@
           <a:bodyPr/>
           <a:lstStyle/>
           <a:p>
-            <a:fld id="{41F10874-7FDD-43DA-9458-5F9582894316}" type="slidenum">
+            <a:fld id="{15780841-F22E-4DB3-84CB-AB615471C832}" type="slidenum">
               <a:rPr lang="zh-CN" altLang="en-US" smtClean="0"/>
               <a:t>‹#›</a:t>
             </a:fld>
@@ -921,7 +921,7 @@
     </p:spTree>
     <p:extLst>
       <p:ext uri="{BB962C8B-B14F-4D97-AF65-F5344CB8AC3E}">
-        <p14:creationId xmlns:p14="http://schemas.microsoft.com/office/powerpoint/2010/main" val="1298233392"/>
+        <p14:creationId xmlns:p14="http://schemas.microsoft.com/office/powerpoint/2010/main" val="2360152631"/>
       </p:ext>
     </p:extLst>
   </p:cSld>
@@ -953,7 +953,7 @@
           <p:cNvPr id="2" name="标题 1">
             <a:extLst>
               <a:ext uri="{FF2B5EF4-FFF2-40B4-BE49-F238E27FC236}">
-                <a16:creationId xmlns:a16="http://schemas.microsoft.com/office/drawing/2014/main" id="{B5F7A7BC-D5AC-3C32-C699-CEFCD842DBBF}"/>
+                <a16:creationId xmlns:a16="http://schemas.microsoft.com/office/drawing/2014/main" id="{8534EF78-3D87-A063-8658-D6A5CB001518}"/>
               </a:ext>
             </a:extLst>
           </p:cNvPr>
@@ -990,7 +990,7 @@
           <p:cNvPr id="3" name="文本占位符 2">
             <a:extLst>
               <a:ext uri="{FF2B5EF4-FFF2-40B4-BE49-F238E27FC236}">
-                <a16:creationId xmlns:a16="http://schemas.microsoft.com/office/drawing/2014/main" id="{ED3D4D7A-D4D4-9AAB-D6AE-095575D872BB}"/>
+                <a16:creationId xmlns:a16="http://schemas.microsoft.com/office/drawing/2014/main" id="{CFE5DF41-942C-0FF8-FFFD-52BA5DE74C37}"/>
               </a:ext>
             </a:extLst>
           </p:cNvPr>
@@ -1115,7 +1115,7 @@
           <p:cNvPr id="4" name="日期占位符 3">
             <a:extLst>
               <a:ext uri="{FF2B5EF4-FFF2-40B4-BE49-F238E27FC236}">
-                <a16:creationId xmlns:a16="http://schemas.microsoft.com/office/drawing/2014/main" id="{F30595C2-8A75-7F0E-1A24-0A8D20A1695F}"/>
+                <a16:creationId xmlns:a16="http://schemas.microsoft.com/office/drawing/2014/main" id="{2EA9398C-7098-AB44-BA00-E281EEEA0ACC}"/>
               </a:ext>
             </a:extLst>
           </p:cNvPr>
@@ -1131,9 +1131,9 @@
           <a:bodyPr/>
           <a:lstStyle/>
           <a:p>
-            <a:fld id="{BE8E5DDC-8DBC-495D-83D8-7932EBA21A75}" type="datetimeFigureOut">
+            <a:fld id="{6384808E-1183-4387-8AB9-77C9D907A16E}" type="datetimeFigureOut">
               <a:rPr lang="zh-CN" altLang="en-US" smtClean="0"/>
-              <a:t>2026/10/13</a:t>
+              <a:t>2026/10/14</a:t>
             </a:fld>
             <a:endParaRPr lang="zh-CN" altLang="en-US"/>
           </a:p>
@@ -1144,7 +1144,7 @@
           <p:cNvPr id="5" name="页脚占位符 4">
             <a:extLst>
               <a:ext uri="{FF2B5EF4-FFF2-40B4-BE49-F238E27FC236}">
-                <a16:creationId xmlns:a16="http://schemas.microsoft.com/office/drawing/2014/main" id="{5C0F7148-A04D-239D-6D71-D12574AD4899}"/>
+                <a16:creationId xmlns:a16="http://schemas.microsoft.com/office/drawing/2014/main" id="{66B601AE-DF3E-FD23-74AA-864DADB53BDE}"/>
               </a:ext>
             </a:extLst>
           </p:cNvPr>
@@ -1169,7 +1169,7 @@
           <p:cNvPr id="6" name="灯片编号占位符 5">
             <a:extLst>
               <a:ext uri="{FF2B5EF4-FFF2-40B4-BE49-F238E27FC236}">
-                <a16:creationId xmlns:a16="http://schemas.microsoft.com/office/drawing/2014/main" id="{189BBBA6-93EC-00A2-8F67-29AA6A4A6389}"/>
+                <a16:creationId xmlns:a16="http://schemas.microsoft.com/office/drawing/2014/main" id="{2E2813A6-3C7B-87E6-C58F-052EF3B4D456}"/>
               </a:ext>
             </a:extLst>
           </p:cNvPr>
@@ -1185,7 +1185,7 @@
           <a:bodyPr/>
           <a:lstStyle/>
           <a:p>
-            <a:fld id="{41F10874-7FDD-43DA-9458-5F9582894316}" type="slidenum">
+            <a:fld id="{15780841-F22E-4DB3-84CB-AB615471C832}" type="slidenum">
               <a:rPr lang="zh-CN" altLang="en-US" smtClean="0"/>
               <a:t>‹#›</a:t>
             </a:fld>
@@ -1196,7 +1196,7 @@
     </p:spTree>
     <p:extLst>
       <p:ext uri="{BB962C8B-B14F-4D97-AF65-F5344CB8AC3E}">
-        <p14:creationId xmlns:p14="http://schemas.microsoft.com/office/powerpoint/2010/main" val="3063080850"/>
+        <p14:creationId xmlns:p14="http://schemas.microsoft.com/office/powerpoint/2010/main" val="115332956"/>
       </p:ext>
     </p:extLst>
   </p:cSld>
@@ -1228,7 +1228,7 @@
           <p:cNvPr id="2" name="标题 1">
             <a:extLst>
               <a:ext uri="{FF2B5EF4-FFF2-40B4-BE49-F238E27FC236}">
-                <a16:creationId xmlns:a16="http://schemas.microsoft.com/office/drawing/2014/main" id="{3FF32395-409D-AF0B-2CE9-640906510526}"/>
+                <a16:creationId xmlns:a16="http://schemas.microsoft.com/office/drawing/2014/main" id="{CE9A43CB-366B-F65E-1A05-06E63528DA05}"/>
               </a:ext>
             </a:extLst>
           </p:cNvPr>
@@ -1256,7 +1256,7 @@
           <p:cNvPr id="3" name="内容占位符 2">
             <a:extLst>
               <a:ext uri="{FF2B5EF4-FFF2-40B4-BE49-F238E27FC236}">
-                <a16:creationId xmlns:a16="http://schemas.microsoft.com/office/drawing/2014/main" id="{D3B3B4CA-289E-6B8E-84EC-5D57E18BEF11}"/>
+                <a16:creationId xmlns:a16="http://schemas.microsoft.com/office/drawing/2014/main" id="{ABD995DB-EFCE-778B-A525-441534B8B973}"/>
               </a:ext>
             </a:extLst>
           </p:cNvPr>
@@ -1318,7 +1318,7 @@
           <p:cNvPr id="4" name="内容占位符 3">
             <a:extLst>
               <a:ext uri="{FF2B5EF4-FFF2-40B4-BE49-F238E27FC236}">
-                <a16:creationId xmlns:a16="http://schemas.microsoft.com/office/drawing/2014/main" id="{E4553D61-E1F6-62E8-ADA5-162540DA488F}"/>
+                <a16:creationId xmlns:a16="http://schemas.microsoft.com/office/drawing/2014/main" id="{C1E2EE4A-AB77-0979-D69A-7952A7D43C18}"/>
               </a:ext>
             </a:extLst>
           </p:cNvPr>
@@ -1380,7 +1380,7 @@
           <p:cNvPr id="5" name="日期占位符 4">
             <a:extLst>
               <a:ext uri="{FF2B5EF4-FFF2-40B4-BE49-F238E27FC236}">
-                <a16:creationId xmlns:a16="http://schemas.microsoft.com/office/drawing/2014/main" id="{E6760AF9-F847-9F78-3B30-76EA6DA496A0}"/>
+                <a16:creationId xmlns:a16="http://schemas.microsoft.com/office/drawing/2014/main" id="{350B2191-B496-D3BD-5596-93D26827627F}"/>
               </a:ext>
             </a:extLst>
           </p:cNvPr>
@@ -1396,9 +1396,9 @@
           <a:bodyPr/>
           <a:lstStyle/>
           <a:p>
-            <a:fld id="{BE8E5DDC-8DBC-495D-83D8-7932EBA21A75}" type="datetimeFigureOut">
+            <a:fld id="{6384808E-1183-4387-8AB9-77C9D907A16E}" type="datetimeFigureOut">
               <a:rPr lang="zh-CN" altLang="en-US" smtClean="0"/>
-              <a:t>2026/10/13</a:t>
+              <a:t>2026/10/14</a:t>
             </a:fld>
             <a:endParaRPr lang="zh-CN" altLang="en-US"/>
           </a:p>
@@ -1409,7 +1409,7 @@
           <p:cNvPr id="6" name="页脚占位符 5">
             <a:extLst>
               <a:ext uri="{FF2B5EF4-FFF2-40B4-BE49-F238E27FC236}">
-                <a16:creationId xmlns:a16="http://schemas.microsoft.com/office/drawing/2014/main" id="{8C6127C1-56D0-AC64-45FF-E664A897BF14}"/>
+                <a16:creationId xmlns:a16="http://schemas.microsoft.com/office/drawing/2014/main" id="{27C55BAC-40B5-D44B-18A0-50EC15D41D69}"/>
               </a:ext>
             </a:extLst>
           </p:cNvPr>
@@ -1434,7 +1434,7 @@
           <p:cNvPr id="7" name="灯片编号占位符 6">
             <a:extLst>
               <a:ext uri="{FF2B5EF4-FFF2-40B4-BE49-F238E27FC236}">
-                <a16:creationId xmlns:a16="http://schemas.microsoft.com/office/drawing/2014/main" id="{E5BFB782-9680-2362-270D-8D478E99B4D0}"/>
+                <a16:creationId xmlns:a16="http://schemas.microsoft.com/office/drawing/2014/main" id="{3324885A-085D-00BC-5550-0A955E95435A}"/>
               </a:ext>
             </a:extLst>
           </p:cNvPr>
@@ -1450,7 +1450,7 @@
           <a:bodyPr/>
           <a:lstStyle/>
           <a:p>
-            <a:fld id="{41F10874-7FDD-43DA-9458-5F9582894316}" type="slidenum">
+            <a:fld id="{15780841-F22E-4DB3-84CB-AB615471C832}" type="slidenum">
               <a:rPr lang="zh-CN" altLang="en-US" smtClean="0"/>
               <a:t>‹#›</a:t>
             </a:fld>
@@ -1461,7 +1461,7 @@
     </p:spTree>
     <p:extLst>
       <p:ext uri="{BB962C8B-B14F-4D97-AF65-F5344CB8AC3E}">
-        <p14:creationId xmlns:p14="http://schemas.microsoft.com/office/powerpoint/2010/main" val="3371829173"/>
+        <p14:creationId xmlns:p14="http://schemas.microsoft.com/office/powerpoint/2010/main" val="1664681158"/>
       </p:ext>
     </p:extLst>
   </p:cSld>
@@ -1493,7 +1493,7 @@
           <p:cNvPr id="2" name="标题 1">
             <a:extLst>
               <a:ext uri="{FF2B5EF4-FFF2-40B4-BE49-F238E27FC236}">
-                <a16:creationId xmlns:a16="http://schemas.microsoft.com/office/drawing/2014/main" id="{B8BD012B-DC46-54C1-6980-A8829A575C29}"/>
+                <a16:creationId xmlns:a16="http://schemas.microsoft.com/office/drawing/2014/main" id="{BE8B6C96-28E4-88DC-D86D-A57352592573}"/>
               </a:ext>
             </a:extLst>
           </p:cNvPr>
@@ -1526,7 +1526,7 @@
           <p:cNvPr id="3" name="文本占位符 2">
             <a:extLst>
               <a:ext uri="{FF2B5EF4-FFF2-40B4-BE49-F238E27FC236}">
-                <a16:creationId xmlns:a16="http://schemas.microsoft.com/office/drawing/2014/main" id="{45D48E36-21BC-46BF-1AED-844503849DAF}"/>
+                <a16:creationId xmlns:a16="http://schemas.microsoft.com/office/drawing/2014/main" id="{6C4BBD9E-DD17-F441-5EB9-4AA77A73FE47}"/>
               </a:ext>
             </a:extLst>
           </p:cNvPr>
@@ -1597,7 +1597,7 @@
           <p:cNvPr id="4" name="内容占位符 3">
             <a:extLst>
               <a:ext uri="{FF2B5EF4-FFF2-40B4-BE49-F238E27FC236}">
-                <a16:creationId xmlns:a16="http://schemas.microsoft.com/office/drawing/2014/main" id="{F0051BAA-213A-2C59-FF05-92EBA45928F9}"/>
+                <a16:creationId xmlns:a16="http://schemas.microsoft.com/office/drawing/2014/main" id="{F41E655F-55C0-5EB5-D2B5-0E016532B11C}"/>
               </a:ext>
             </a:extLst>
           </p:cNvPr>
@@ -1659,7 +1659,7 @@
           <p:cNvPr id="5" name="文本占位符 4">
             <a:extLst>
               <a:ext uri="{FF2B5EF4-FFF2-40B4-BE49-F238E27FC236}">
-                <a16:creationId xmlns:a16="http://schemas.microsoft.com/office/drawing/2014/main" id="{E838B1D0-E89C-E75E-E080-6ECC3CA8BA47}"/>
+                <a16:creationId xmlns:a16="http://schemas.microsoft.com/office/drawing/2014/main" id="{41BC2BC4-5F86-0919-DA63-F33B1C262446}"/>
               </a:ext>
             </a:extLst>
           </p:cNvPr>
@@ -1730,7 +1730,7 @@
           <p:cNvPr id="6" name="内容占位符 5">
             <a:extLst>
               <a:ext uri="{FF2B5EF4-FFF2-40B4-BE49-F238E27FC236}">
-                <a16:creationId xmlns:a16="http://schemas.microsoft.com/office/drawing/2014/main" id="{70B94D84-A5C2-4BC5-D985-073A8F97F9B9}"/>
+                <a16:creationId xmlns:a16="http://schemas.microsoft.com/office/drawing/2014/main" id="{93BE9B83-D337-7406-4950-4A00F67800F9}"/>
               </a:ext>
             </a:extLst>
           </p:cNvPr>
@@ -1792,7 +1792,7 @@
           <p:cNvPr id="7" name="日期占位符 6">
             <a:extLst>
               <a:ext uri="{FF2B5EF4-FFF2-40B4-BE49-F238E27FC236}">
-                <a16:creationId xmlns:a16="http://schemas.microsoft.com/office/drawing/2014/main" id="{F9682FDF-E406-581D-A0E5-99EB659A93D2}"/>
+                <a16:creationId xmlns:a16="http://schemas.microsoft.com/office/drawing/2014/main" id="{BB1E5A32-5671-77EF-F3BA-5FE18F308EC3}"/>
               </a:ext>
             </a:extLst>
           </p:cNvPr>
@@ -1808,9 +1808,9 @@
           <a:bodyPr/>
           <a:lstStyle/>
           <a:p>
-            <a:fld id="{BE8E5DDC-8DBC-495D-83D8-7932EBA21A75}" type="datetimeFigureOut">
+            <a:fld id="{6384808E-1183-4387-8AB9-77C9D907A16E}" type="datetimeFigureOut">
               <a:rPr lang="zh-CN" altLang="en-US" smtClean="0"/>
-              <a:t>2026/10/13</a:t>
+              <a:t>2026/10/14</a:t>
             </a:fld>
             <a:endParaRPr lang="zh-CN" altLang="en-US"/>
           </a:p>
@@ -1821,7 +1821,7 @@
           <p:cNvPr id="8" name="页脚占位符 7">
             <a:extLst>
               <a:ext uri="{FF2B5EF4-FFF2-40B4-BE49-F238E27FC236}">
-                <a16:creationId xmlns:a16="http://schemas.microsoft.com/office/drawing/2014/main" id="{BAA82327-B930-1FF4-CBBB-30017966D515}"/>
+                <a16:creationId xmlns:a16="http://schemas.microsoft.com/office/drawing/2014/main" id="{FD7D180C-C8BF-CE1E-E7EE-876C3BB1C2BC}"/>
               </a:ext>
             </a:extLst>
           </p:cNvPr>
@@ -1846,7 +1846,7 @@
           <p:cNvPr id="9" name="灯片编号占位符 8">
             <a:extLst>
               <a:ext uri="{FF2B5EF4-FFF2-40B4-BE49-F238E27FC236}">
-                <a16:creationId xmlns:a16="http://schemas.microsoft.com/office/drawing/2014/main" id="{8F17A444-88FB-B13B-2688-53648FEDA8E0}"/>
+                <a16:creationId xmlns:a16="http://schemas.microsoft.com/office/drawing/2014/main" id="{8AFE49A5-DE84-8751-EE5A-5C0EB14CA807}"/>
               </a:ext>
             </a:extLst>
           </p:cNvPr>
@@ -1862,7 +1862,7 @@
           <a:bodyPr/>
           <a:lstStyle/>
           <a:p>
-            <a:fld id="{41F10874-7FDD-43DA-9458-5F9582894316}" type="slidenum">
+            <a:fld id="{15780841-F22E-4DB3-84CB-AB615471C832}" type="slidenum">
               <a:rPr lang="zh-CN" altLang="en-US" smtClean="0"/>
               <a:t>‹#›</a:t>
             </a:fld>
@@ -1873,7 +1873,7 @@
     </p:spTree>
     <p:extLst>
       <p:ext uri="{BB962C8B-B14F-4D97-AF65-F5344CB8AC3E}">
-        <p14:creationId xmlns:p14="http://schemas.microsoft.com/office/powerpoint/2010/main" val="3390688890"/>
+        <p14:creationId xmlns:p14="http://schemas.microsoft.com/office/powerpoint/2010/main" val="595661365"/>
       </p:ext>
     </p:extLst>
   </p:cSld>
@@ -1905,7 +1905,7 @@
           <p:cNvPr id="2" name="标题 1">
             <a:extLst>
               <a:ext uri="{FF2B5EF4-FFF2-40B4-BE49-F238E27FC236}">
-                <a16:creationId xmlns:a16="http://schemas.microsoft.com/office/drawing/2014/main" id="{C922E0C5-F38D-2E6B-2CE1-5DA7D7A03A0F}"/>
+                <a16:creationId xmlns:a16="http://schemas.microsoft.com/office/drawing/2014/main" id="{E425EA8F-1DF1-CD62-A8C0-3FD6B385C59A}"/>
               </a:ext>
             </a:extLst>
           </p:cNvPr>
@@ -1933,7 +1933,7 @@
           <p:cNvPr id="3" name="日期占位符 2">
             <a:extLst>
               <a:ext uri="{FF2B5EF4-FFF2-40B4-BE49-F238E27FC236}">
-                <a16:creationId xmlns:a16="http://schemas.microsoft.com/office/drawing/2014/main" id="{66FB5951-6560-686F-DC96-335BD9D2E9F7}"/>
+                <a16:creationId xmlns:a16="http://schemas.microsoft.com/office/drawing/2014/main" id="{CD6414AE-6864-B3AC-6D5F-2E19B3AA758A}"/>
               </a:ext>
             </a:extLst>
           </p:cNvPr>
@@ -1949,9 +1949,9 @@
           <a:bodyPr/>
           <a:lstStyle/>
           <a:p>
-            <a:fld id="{BE8E5DDC-8DBC-495D-83D8-7932EBA21A75}" type="datetimeFigureOut">
+            <a:fld id="{6384808E-1183-4387-8AB9-77C9D907A16E}" type="datetimeFigureOut">
               <a:rPr lang="zh-CN" altLang="en-US" smtClean="0"/>
-              <a:t>2026/10/13</a:t>
+              <a:t>2026/10/14</a:t>
             </a:fld>
             <a:endParaRPr lang="zh-CN" altLang="en-US"/>
           </a:p>
@@ -1962,7 +1962,7 @@
           <p:cNvPr id="4" name="页脚占位符 3">
             <a:extLst>
               <a:ext uri="{FF2B5EF4-FFF2-40B4-BE49-F238E27FC236}">
-                <a16:creationId xmlns:a16="http://schemas.microsoft.com/office/drawing/2014/main" id="{094B6044-8D8B-892D-2338-BF77058C54E0}"/>
+                <a16:creationId xmlns:a16="http://schemas.microsoft.com/office/drawing/2014/main" id="{3A2CD719-CCD6-B442-F2EA-BDB67407AEFE}"/>
               </a:ext>
             </a:extLst>
           </p:cNvPr>
@@ -1987,7 +1987,7 @@
           <p:cNvPr id="5" name="灯片编号占位符 4">
             <a:extLst>
               <a:ext uri="{FF2B5EF4-FFF2-40B4-BE49-F238E27FC236}">
-                <a16:creationId xmlns:a16="http://schemas.microsoft.com/office/drawing/2014/main" id="{E7ECE743-EBAB-8D2C-EFB5-F1A8AC78A8B5}"/>
+                <a16:creationId xmlns:a16="http://schemas.microsoft.com/office/drawing/2014/main" id="{BB9E995C-2647-4A05-81D8-252441F60E0F}"/>
               </a:ext>
             </a:extLst>
           </p:cNvPr>
@@ -2003,7 +2003,7 @@
           <a:bodyPr/>
           <a:lstStyle/>
           <a:p>
-            <a:fld id="{41F10874-7FDD-43DA-9458-5F9582894316}" type="slidenum">
+            <a:fld id="{15780841-F22E-4DB3-84CB-AB615471C832}" type="slidenum">
               <a:rPr lang="zh-CN" altLang="en-US" smtClean="0"/>
               <a:t>‹#›</a:t>
             </a:fld>
@@ -2014,7 +2014,7 @@
     </p:spTree>
     <p:extLst>
       <p:ext uri="{BB962C8B-B14F-4D97-AF65-F5344CB8AC3E}">
-        <p14:creationId xmlns:p14="http://schemas.microsoft.com/office/powerpoint/2010/main" val="2037880767"/>
+        <p14:creationId xmlns:p14="http://schemas.microsoft.com/office/powerpoint/2010/main" val="590050806"/>
       </p:ext>
     </p:extLst>
   </p:cSld>
@@ -2046,7 +2046,7 @@
           <p:cNvPr id="2" name="日期占位符 1">
             <a:extLst>
               <a:ext uri="{FF2B5EF4-FFF2-40B4-BE49-F238E27FC236}">
-                <a16:creationId xmlns:a16="http://schemas.microsoft.com/office/drawing/2014/main" id="{360AD8FB-EFD9-DB0F-849C-C4730F889C48}"/>
+                <a16:creationId xmlns:a16="http://schemas.microsoft.com/office/drawing/2014/main" id="{4DA924AF-895D-57E6-9594-2687ED7B0CD3}"/>
               </a:ext>
             </a:extLst>
           </p:cNvPr>
@@ -2062,9 +2062,9 @@
           <a:bodyPr/>
           <a:lstStyle/>
           <a:p>
-            <a:fld id="{BE8E5DDC-8DBC-495D-83D8-7932EBA21A75}" type="datetimeFigureOut">
+            <a:fld id="{6384808E-1183-4387-8AB9-77C9D907A16E}" type="datetimeFigureOut">
               <a:rPr lang="zh-CN" altLang="en-US" smtClean="0"/>
-              <a:t>2026/10/13</a:t>
+              <a:t>2026/10/14</a:t>
             </a:fld>
             <a:endParaRPr lang="zh-CN" altLang="en-US"/>
           </a:p>
@@ -2075,7 +2075,7 @@
           <p:cNvPr id="3" name="页脚占位符 2">
             <a:extLst>
               <a:ext uri="{FF2B5EF4-FFF2-40B4-BE49-F238E27FC236}">
-                <a16:creationId xmlns:a16="http://schemas.microsoft.com/office/drawing/2014/main" id="{2B1B5294-2361-7470-8295-13DCC65BC7D7}"/>
+                <a16:creationId xmlns:a16="http://schemas.microsoft.com/office/drawing/2014/main" id="{8BA969A9-743C-B556-5079-F2E1366A03D5}"/>
               </a:ext>
             </a:extLst>
           </p:cNvPr>
@@ -2100,7 +2100,7 @@
           <p:cNvPr id="4" name="灯片编号占位符 3">
             <a:extLst>
               <a:ext uri="{FF2B5EF4-FFF2-40B4-BE49-F238E27FC236}">
-                <a16:creationId xmlns:a16="http://schemas.microsoft.com/office/drawing/2014/main" id="{CEDE758B-2074-AC60-17BB-C9D47B433D71}"/>
+                <a16:creationId xmlns:a16="http://schemas.microsoft.com/office/drawing/2014/main" id="{6032BCC2-93FA-60B4-9774-773B14F26C4A}"/>
               </a:ext>
             </a:extLst>
           </p:cNvPr>
@@ -2116,7 +2116,7 @@
           <a:bodyPr/>
           <a:lstStyle/>
           <a:p>
-            <a:fld id="{41F10874-7FDD-43DA-9458-5F9582894316}" type="slidenum">
+            <a:fld id="{15780841-F22E-4DB3-84CB-AB615471C832}" type="slidenum">
               <a:rPr lang="zh-CN" altLang="en-US" smtClean="0"/>
               <a:t>‹#›</a:t>
             </a:fld>
@@ -2127,7 +2127,7 @@
     </p:spTree>
     <p:extLst>
       <p:ext uri="{BB962C8B-B14F-4D97-AF65-F5344CB8AC3E}">
-        <p14:creationId xmlns:p14="http://schemas.microsoft.com/office/powerpoint/2010/main" val="2237687775"/>
+        <p14:creationId xmlns:p14="http://schemas.microsoft.com/office/powerpoint/2010/main" val="2189725388"/>
       </p:ext>
     </p:extLst>
   </p:cSld>
@@ -2159,7 +2159,7 @@
           <p:cNvPr id="2" name="标题 1">
             <a:extLst>
               <a:ext uri="{FF2B5EF4-FFF2-40B4-BE49-F238E27FC236}">
-                <a16:creationId xmlns:a16="http://schemas.microsoft.com/office/drawing/2014/main" id="{452C6EC2-551F-1FFE-BE75-9E732AEBC34F}"/>
+                <a16:creationId xmlns:a16="http://schemas.microsoft.com/office/drawing/2014/main" id="{EB461C73-DC7D-DA38-A36F-67BCABED86B5}"/>
               </a:ext>
             </a:extLst>
           </p:cNvPr>
@@ -2196,7 +2196,7 @@
           <p:cNvPr id="3" name="内容占位符 2">
             <a:extLst>
               <a:ext uri="{FF2B5EF4-FFF2-40B4-BE49-F238E27FC236}">
-                <a16:creationId xmlns:a16="http://schemas.microsoft.com/office/drawing/2014/main" id="{25177CDB-20FD-F51A-84E2-AB04393BE591}"/>
+                <a16:creationId xmlns:a16="http://schemas.microsoft.com/office/drawing/2014/main" id="{F992B31B-0708-C308-9E01-59FEF4359213}"/>
               </a:ext>
             </a:extLst>
           </p:cNvPr>
@@ -2286,7 +2286,7 @@
           <p:cNvPr id="4" name="文本占位符 3">
             <a:extLst>
               <a:ext uri="{FF2B5EF4-FFF2-40B4-BE49-F238E27FC236}">
-                <a16:creationId xmlns:a16="http://schemas.microsoft.com/office/drawing/2014/main" id="{43555D83-1717-3B8B-8DF9-EA3067F802AE}"/>
+                <a16:creationId xmlns:a16="http://schemas.microsoft.com/office/drawing/2014/main" id="{27624F39-0F8C-B2DC-8EB3-C394E4FD84F1}"/>
               </a:ext>
             </a:extLst>
           </p:cNvPr>
@@ -2357,7 +2357,7 @@
           <p:cNvPr id="5" name="日期占位符 4">
             <a:extLst>
               <a:ext uri="{FF2B5EF4-FFF2-40B4-BE49-F238E27FC236}">
-                <a16:creationId xmlns:a16="http://schemas.microsoft.com/office/drawing/2014/main" id="{4600AE04-8111-A131-ABAA-206697F823A8}"/>
+                <a16:creationId xmlns:a16="http://schemas.microsoft.com/office/drawing/2014/main" id="{C4C6FB12-0DE5-7DCD-57BA-32CE60BEAC86}"/>
               </a:ext>
             </a:extLst>
           </p:cNvPr>
@@ -2373,9 +2373,9 @@
           <a:bodyPr/>
           <a:lstStyle/>
           <a:p>
-            <a:fld id="{BE8E5DDC-8DBC-495D-83D8-7932EBA21A75}" type="datetimeFigureOut">
+            <a:fld id="{6384808E-1183-4387-8AB9-77C9D907A16E}" type="datetimeFigureOut">
               <a:rPr lang="zh-CN" altLang="en-US" smtClean="0"/>
-              <a:t>2026/10/13</a:t>
+              <a:t>2026/10/14</a:t>
             </a:fld>
             <a:endParaRPr lang="zh-CN" altLang="en-US"/>
           </a:p>
@@ -2386,7 +2386,7 @@
           <p:cNvPr id="6" name="页脚占位符 5">
             <a:extLst>
               <a:ext uri="{FF2B5EF4-FFF2-40B4-BE49-F238E27FC236}">
-                <a16:creationId xmlns:a16="http://schemas.microsoft.com/office/drawing/2014/main" id="{707C7EAD-9961-DD31-037D-1C4798FFCBCE}"/>
+                <a16:creationId xmlns:a16="http://schemas.microsoft.com/office/drawing/2014/main" id="{EB8D3148-733E-E5A6-CD5B-F3D13DA3ACD0}"/>
               </a:ext>
             </a:extLst>
           </p:cNvPr>
@@ -2411,7 +2411,7 @@
           <p:cNvPr id="7" name="灯片编号占位符 6">
             <a:extLst>
               <a:ext uri="{FF2B5EF4-FFF2-40B4-BE49-F238E27FC236}">
-                <a16:creationId xmlns:a16="http://schemas.microsoft.com/office/drawing/2014/main" id="{32AF2F69-E7E5-C713-43D2-EDC87291EED0}"/>
+                <a16:creationId xmlns:a16="http://schemas.microsoft.com/office/drawing/2014/main" id="{8DB99664-3571-A5D1-9B21-345DBBAC6A47}"/>
               </a:ext>
             </a:extLst>
           </p:cNvPr>
@@ -2427,7 +2427,7 @@
           <a:bodyPr/>
           <a:lstStyle/>
           <a:p>
-            <a:fld id="{41F10874-7FDD-43DA-9458-5F9582894316}" type="slidenum">
+            <a:fld id="{15780841-F22E-4DB3-84CB-AB615471C832}" type="slidenum">
               <a:rPr lang="zh-CN" altLang="en-US" smtClean="0"/>
               <a:t>‹#›</a:t>
             </a:fld>
@@ -2438,7 +2438,7 @@
     </p:spTree>
     <p:extLst>
       <p:ext uri="{BB962C8B-B14F-4D97-AF65-F5344CB8AC3E}">
-        <p14:creationId xmlns:p14="http://schemas.microsoft.com/office/powerpoint/2010/main" val="2888055600"/>
+        <p14:creationId xmlns:p14="http://schemas.microsoft.com/office/powerpoint/2010/main" val="204427444"/>
       </p:ext>
     </p:extLst>
   </p:cSld>
@@ -2470,7 +2470,7 @@
           <p:cNvPr id="2" name="标题 1">
             <a:extLst>
               <a:ext uri="{FF2B5EF4-FFF2-40B4-BE49-F238E27FC236}">
-                <a16:creationId xmlns:a16="http://schemas.microsoft.com/office/drawing/2014/main" id="{DEF0E797-9076-C6BF-AB87-C3906BC7CFAE}"/>
+                <a16:creationId xmlns:a16="http://schemas.microsoft.com/office/drawing/2014/main" id="{D6373F4E-B62D-DDFD-D0FF-0C240462840E}"/>
               </a:ext>
             </a:extLst>
           </p:cNvPr>
@@ -2507,7 +2507,7 @@
           <p:cNvPr id="3" name="图片占位符 2">
             <a:extLst>
               <a:ext uri="{FF2B5EF4-FFF2-40B4-BE49-F238E27FC236}">
-                <a16:creationId xmlns:a16="http://schemas.microsoft.com/office/drawing/2014/main" id="{1FC206D9-B7C7-D077-D7A5-F2E8592E2A47}"/>
+                <a16:creationId xmlns:a16="http://schemas.microsoft.com/office/drawing/2014/main" id="{FFE119C2-2168-3B5C-BCF1-C4CFBBB643E3}"/>
               </a:ext>
             </a:extLst>
           </p:cNvPr>
@@ -2574,7 +2574,7 @@
           <p:cNvPr id="4" name="文本占位符 3">
             <a:extLst>
               <a:ext uri="{FF2B5EF4-FFF2-40B4-BE49-F238E27FC236}">
-                <a16:creationId xmlns:a16="http://schemas.microsoft.com/office/drawing/2014/main" id="{6738D70A-F53A-117C-905C-D915D3FEAD8C}"/>
+                <a16:creationId xmlns:a16="http://schemas.microsoft.com/office/drawing/2014/main" id="{14975028-73D3-D02F-0688-812375491C77}"/>
               </a:ext>
             </a:extLst>
           </p:cNvPr>
@@ -2645,7 +2645,7 @@
           <p:cNvPr id="5" name="日期占位符 4">
             <a:extLst>
               <a:ext uri="{FF2B5EF4-FFF2-40B4-BE49-F238E27FC236}">
-                <a16:creationId xmlns:a16="http://schemas.microsoft.com/office/drawing/2014/main" id="{4CCF0C5A-7C78-6D5F-075A-098B911D8901}"/>
+                <a16:creationId xmlns:a16="http://schemas.microsoft.com/office/drawing/2014/main" id="{D538094D-2263-0F1D-2E29-3C5381055D80}"/>
               </a:ext>
             </a:extLst>
           </p:cNvPr>
@@ -2661,9 +2661,9 @@
           <a:bodyPr/>
           <a:lstStyle/>
           <a:p>
-            <a:fld id="{BE8E5DDC-8DBC-495D-83D8-7932EBA21A75}" type="datetimeFigureOut">
+            <a:fld id="{6384808E-1183-4387-8AB9-77C9D907A16E}" type="datetimeFigureOut">
               <a:rPr lang="zh-CN" altLang="en-US" smtClean="0"/>
-              <a:t>2026/10/13</a:t>
+              <a:t>2026/10/14</a:t>
             </a:fld>
             <a:endParaRPr lang="zh-CN" altLang="en-US"/>
           </a:p>
@@ -2674,7 +2674,7 @@
           <p:cNvPr id="6" name="页脚占位符 5">
             <a:extLst>
               <a:ext uri="{FF2B5EF4-FFF2-40B4-BE49-F238E27FC236}">
-                <a16:creationId xmlns:a16="http://schemas.microsoft.com/office/drawing/2014/main" id="{EAA5ED8E-98FD-6570-326B-079B5CB7FF08}"/>
+                <a16:creationId xmlns:a16="http://schemas.microsoft.com/office/drawing/2014/main" id="{A2D42143-2670-E0D8-4721-BD16EADAF572}"/>
               </a:ext>
             </a:extLst>
           </p:cNvPr>
@@ -2699,7 +2699,7 @@
           <p:cNvPr id="7" name="灯片编号占位符 6">
             <a:extLst>
               <a:ext uri="{FF2B5EF4-FFF2-40B4-BE49-F238E27FC236}">
-                <a16:creationId xmlns:a16="http://schemas.microsoft.com/office/drawing/2014/main" id="{BE63E2F0-3472-BA92-2EE8-8F6533EEEE37}"/>
+                <a16:creationId xmlns:a16="http://schemas.microsoft.com/office/drawing/2014/main" id="{A1F73CBD-B99E-1D4E-F03B-5840168AA544}"/>
               </a:ext>
             </a:extLst>
           </p:cNvPr>
@@ -2715,7 +2715,7 @@
           <a:bodyPr/>
           <a:lstStyle/>
           <a:p>
-            <a:fld id="{41F10874-7FDD-43DA-9458-5F9582894316}" type="slidenum">
+            <a:fld id="{15780841-F22E-4DB3-84CB-AB615471C832}" type="slidenum">
               <a:rPr lang="zh-CN" altLang="en-US" smtClean="0"/>
               <a:t>‹#›</a:t>
             </a:fld>
@@ -2726,7 +2726,7 @@
     </p:spTree>
     <p:extLst>
       <p:ext uri="{BB962C8B-B14F-4D97-AF65-F5344CB8AC3E}">
-        <p14:creationId xmlns:p14="http://schemas.microsoft.com/office/powerpoint/2010/main" val="803427723"/>
+        <p14:creationId xmlns:p14="http://schemas.microsoft.com/office/powerpoint/2010/main" val="2282212187"/>
       </p:ext>
     </p:extLst>
   </p:cSld>
@@ -2763,7 +2763,7 @@
           <p:cNvPr id="2" name="标题占位符 1">
             <a:extLst>
               <a:ext uri="{FF2B5EF4-FFF2-40B4-BE49-F238E27FC236}">
-                <a16:creationId xmlns:a16="http://schemas.microsoft.com/office/drawing/2014/main" id="{F32B1E35-1CD3-DEB8-6765-865EA0A035AE}"/>
+                <a16:creationId xmlns:a16="http://schemas.microsoft.com/office/drawing/2014/main" id="{BFCFE042-764B-309D-E957-F15E7B72A6E2}"/>
               </a:ext>
             </a:extLst>
           </p:cNvPr>
@@ -2801,7 +2801,7 @@
           <p:cNvPr id="3" name="文本占位符 2">
             <a:extLst>
               <a:ext uri="{FF2B5EF4-FFF2-40B4-BE49-F238E27FC236}">
-                <a16:creationId xmlns:a16="http://schemas.microsoft.com/office/drawing/2014/main" id="{D6F23B91-C5FF-DA89-DD24-C7A193B18FDB}"/>
+                <a16:creationId xmlns:a16="http://schemas.microsoft.com/office/drawing/2014/main" id="{00D1D285-9F69-E9A9-7CFD-4FA2B4E10770}"/>
               </a:ext>
             </a:extLst>
           </p:cNvPr>
@@ -2868,7 +2868,7 @@
           <p:cNvPr id="4" name="日期占位符 3">
             <a:extLst>
               <a:ext uri="{FF2B5EF4-FFF2-40B4-BE49-F238E27FC236}">
-                <a16:creationId xmlns:a16="http://schemas.microsoft.com/office/drawing/2014/main" id="{A01F3C51-5ECA-677F-C797-96A575FD6DF1}"/>
+                <a16:creationId xmlns:a16="http://schemas.microsoft.com/office/drawing/2014/main" id="{542B65DD-1FD7-4B74-75E5-D638EEE6FF02}"/>
               </a:ext>
             </a:extLst>
           </p:cNvPr>
@@ -2902,9 +2902,9 @@
             </a:lvl1pPr>
           </a:lstStyle>
           <a:p>
-            <a:fld id="{BE8E5DDC-8DBC-495D-83D8-7932EBA21A75}" type="datetimeFigureOut">
+            <a:fld id="{6384808E-1183-4387-8AB9-77C9D907A16E}" type="datetimeFigureOut">
               <a:rPr lang="zh-CN" altLang="en-US" smtClean="0"/>
-              <a:t>2026/10/13</a:t>
+              <a:t>2026/10/14</a:t>
             </a:fld>
             <a:endParaRPr lang="zh-CN" altLang="en-US"/>
           </a:p>
@@ -2915,7 +2915,7 @@
           <p:cNvPr id="5" name="页脚占位符 4">
             <a:extLst>
               <a:ext uri="{FF2B5EF4-FFF2-40B4-BE49-F238E27FC236}">
-                <a16:creationId xmlns:a16="http://schemas.microsoft.com/office/drawing/2014/main" id="{D136B8A2-35F5-FF93-15AC-54AA3734753A}"/>
+                <a16:creationId xmlns:a16="http://schemas.microsoft.com/office/drawing/2014/main" id="{54E8F664-60B4-97C9-4D4A-1C17AF7689C7}"/>
               </a:ext>
             </a:extLst>
           </p:cNvPr>
@@ -2958,7 +2958,7 @@
           <p:cNvPr id="6" name="灯片编号占位符 5">
             <a:extLst>
               <a:ext uri="{FF2B5EF4-FFF2-40B4-BE49-F238E27FC236}">
-                <a16:creationId xmlns:a16="http://schemas.microsoft.com/office/drawing/2014/main" id="{7F5A1667-2070-4521-8776-9E3BA04A7AD4}"/>
+                <a16:creationId xmlns:a16="http://schemas.microsoft.com/office/drawing/2014/main" id="{1B9204D1-3E8D-8756-9817-6AE1B86D0B82}"/>
               </a:ext>
             </a:extLst>
           </p:cNvPr>
@@ -2992,7 +2992,7 @@
             </a:lvl1pPr>
           </a:lstStyle>
           <a:p>
-            <a:fld id="{41F10874-7FDD-43DA-9458-5F9582894316}" type="slidenum">
+            <a:fld id="{15780841-F22E-4DB3-84CB-AB615471C832}" type="slidenum">
               <a:rPr lang="zh-CN" altLang="en-US" smtClean="0"/>
               <a:t>‹#›</a:t>
             </a:fld>
@@ -3003,7 +3003,7 @@
     </p:spTree>
     <p:extLst>
       <p:ext uri="{BB962C8B-B14F-4D97-AF65-F5344CB8AC3E}">
-        <p14:creationId xmlns:p14="http://schemas.microsoft.com/office/powerpoint/2010/main" val="4004596357"/>
+        <p14:creationId xmlns:p14="http://schemas.microsoft.com/office/powerpoint/2010/main" val="2581602690"/>
       </p:ext>
     </p:extLst>
   </p:cSld>
@@ -3326,7 +3326,7 @@
           <p:cNvPr id="2" name="poster title">
             <a:extLst>
               <a:ext uri="{FF2B5EF4-FFF2-40B4-BE49-F238E27FC236}">
-                <a16:creationId xmlns:a16="http://schemas.microsoft.com/office/drawing/2014/main" id="{D907E541-EF34-F777-2F78-D43B7DE421ED}"/>
+                <a16:creationId xmlns:a16="http://schemas.microsoft.com/office/drawing/2014/main" id="{1DA1095D-9BA7-D19B-604F-4435992D2104}"/>
               </a:ext>
             </a:extLst>
           </p:cNvPr>
@@ -3372,7 +3372,7 @@
           <p:cNvPr id="3" name="subtitle">
             <a:extLst>
               <a:ext uri="{FF2B5EF4-FFF2-40B4-BE49-F238E27FC236}">
-                <a16:creationId xmlns:a16="http://schemas.microsoft.com/office/drawing/2014/main" id="{998AA84E-C807-05F6-FB5F-4AD2506BBB4E}"/>
+                <a16:creationId xmlns:a16="http://schemas.microsoft.com/office/drawing/2014/main" id="{31597CAB-2745-9E6A-7516-A0F469DBD353}"/>
               </a:ext>
             </a:extLst>
           </p:cNvPr>
@@ -3418,7 +3418,7 @@
           <p:cNvPr id="4" name="stat 0">
             <a:extLst>
               <a:ext uri="{FF2B5EF4-FFF2-40B4-BE49-F238E27FC236}">
-                <a16:creationId xmlns:a16="http://schemas.microsoft.com/office/drawing/2014/main" id="{27771538-55D1-75AF-C390-0A6E44361034}"/>
+                <a16:creationId xmlns:a16="http://schemas.microsoft.com/office/drawing/2014/main" id="{A305B644-9374-805E-0446-1D4B4C63A825}"/>
               </a:ext>
             </a:extLst>
           </p:cNvPr>
@@ -3488,7 +3488,7 @@
           <p:cNvPr id="5" name="stat value 0">
             <a:extLst>
               <a:ext uri="{FF2B5EF4-FFF2-40B4-BE49-F238E27FC236}">
-                <a16:creationId xmlns:a16="http://schemas.microsoft.com/office/drawing/2014/main" id="{A363A2A9-4BED-64C2-1465-0A820B622D92}"/>
+                <a16:creationId xmlns:a16="http://schemas.microsoft.com/office/drawing/2014/main" id="{9AB52EE5-1277-196A-4923-37BCD6DE265C}"/>
               </a:ext>
             </a:extLst>
           </p:cNvPr>
@@ -3534,7 +3534,7 @@
           <p:cNvPr id="6" name="stat label 0">
             <a:extLst>
               <a:ext uri="{FF2B5EF4-FFF2-40B4-BE49-F238E27FC236}">
-                <a16:creationId xmlns:a16="http://schemas.microsoft.com/office/drawing/2014/main" id="{4A2B69FD-3621-6623-CF9B-C2A066A6E1C3}"/>
+                <a16:creationId xmlns:a16="http://schemas.microsoft.com/office/drawing/2014/main" id="{39BAE9A8-7AEA-481C-A3EA-6449CF5AEC3D}"/>
               </a:ext>
             </a:extLst>
           </p:cNvPr>
@@ -3580,7 +3580,7 @@
           <p:cNvPr id="7" name="stat 1">
             <a:extLst>
               <a:ext uri="{FF2B5EF4-FFF2-40B4-BE49-F238E27FC236}">
-                <a16:creationId xmlns:a16="http://schemas.microsoft.com/office/drawing/2014/main" id="{81912138-8AD2-9F88-9DC3-FAB53BCA9D25}"/>
+                <a16:creationId xmlns:a16="http://schemas.microsoft.com/office/drawing/2014/main" id="{B41032B8-3F64-1D4E-13FB-1CCF519AB202}"/>
               </a:ext>
             </a:extLst>
           </p:cNvPr>
@@ -3650,7 +3650,7 @@
           <p:cNvPr id="8" name="stat value 1">
             <a:extLst>
               <a:ext uri="{FF2B5EF4-FFF2-40B4-BE49-F238E27FC236}">
-                <a16:creationId xmlns:a16="http://schemas.microsoft.com/office/drawing/2014/main" id="{7006E723-2FC2-5D12-0A79-8A37EB2EA2C4}"/>
+                <a16:creationId xmlns:a16="http://schemas.microsoft.com/office/drawing/2014/main" id="{DD7D42B2-1557-5558-DFDA-DB53B3B28715}"/>
               </a:ext>
             </a:extLst>
           </p:cNvPr>
@@ -3696,7 +3696,7 @@
           <p:cNvPr id="9" name="stat label 1">
             <a:extLst>
               <a:ext uri="{FF2B5EF4-FFF2-40B4-BE49-F238E27FC236}">
-                <a16:creationId xmlns:a16="http://schemas.microsoft.com/office/drawing/2014/main" id="{ADAF3ECF-49CC-3638-D39F-7E3363622112}"/>
+                <a16:creationId xmlns:a16="http://schemas.microsoft.com/office/drawing/2014/main" id="{18AC9AD1-092C-3A4B-133A-C18C2296B920}"/>
               </a:ext>
             </a:extLst>
           </p:cNvPr>
@@ -3742,7 +3742,7 @@
           <p:cNvPr id="10" name="stat 2">
             <a:extLst>
               <a:ext uri="{FF2B5EF4-FFF2-40B4-BE49-F238E27FC236}">
-                <a16:creationId xmlns:a16="http://schemas.microsoft.com/office/drawing/2014/main" id="{CD0E532C-7D9C-3310-229A-195E092ED09E}"/>
+                <a16:creationId xmlns:a16="http://schemas.microsoft.com/office/drawing/2014/main" id="{B12DDD14-E22B-5AF5-5031-B581AC13553A}"/>
               </a:ext>
             </a:extLst>
           </p:cNvPr>
@@ -3812,7 +3812,7 @@
           <p:cNvPr id="11" name="stat value 2">
             <a:extLst>
               <a:ext uri="{FF2B5EF4-FFF2-40B4-BE49-F238E27FC236}">
-                <a16:creationId xmlns:a16="http://schemas.microsoft.com/office/drawing/2014/main" id="{0551E793-5B4E-913D-B64F-9019B977CB41}"/>
+                <a16:creationId xmlns:a16="http://schemas.microsoft.com/office/drawing/2014/main" id="{0FB8FD14-40EF-4E45-86DE-026EF6BF720A}"/>
               </a:ext>
             </a:extLst>
           </p:cNvPr>
@@ -3858,7 +3858,7 @@
           <p:cNvPr id="12" name="stat label 2">
             <a:extLst>
               <a:ext uri="{FF2B5EF4-FFF2-40B4-BE49-F238E27FC236}">
-                <a16:creationId xmlns:a16="http://schemas.microsoft.com/office/drawing/2014/main" id="{DE7B3DB0-C377-A60A-E67B-C3558E0C5287}"/>
+                <a16:creationId xmlns:a16="http://schemas.microsoft.com/office/drawing/2014/main" id="{2C46601C-EB2A-0C04-722A-96BB39990DB5}"/>
               </a:ext>
             </a:extLst>
           </p:cNvPr>
@@ -3904,7 +3904,7 @@
           <p:cNvPr id="13" name="stat 3">
             <a:extLst>
               <a:ext uri="{FF2B5EF4-FFF2-40B4-BE49-F238E27FC236}">
-                <a16:creationId xmlns:a16="http://schemas.microsoft.com/office/drawing/2014/main" id="{180F8A2F-1348-FC90-9AD8-1A93F7614F3E}"/>
+                <a16:creationId xmlns:a16="http://schemas.microsoft.com/office/drawing/2014/main" id="{36F209F2-BCDF-DEF3-B518-421366E42E09}"/>
               </a:ext>
             </a:extLst>
           </p:cNvPr>
@@ -3974,7 +3974,7 @@
           <p:cNvPr id="14" name="stat value 3">
             <a:extLst>
               <a:ext uri="{FF2B5EF4-FFF2-40B4-BE49-F238E27FC236}">
-                <a16:creationId xmlns:a16="http://schemas.microsoft.com/office/drawing/2014/main" id="{9F4908E6-E41D-1AA8-A20D-3439B6954E66}"/>
+                <a16:creationId xmlns:a16="http://schemas.microsoft.com/office/drawing/2014/main" id="{F0781612-3F22-1794-152F-E77FBD660322}"/>
               </a:ext>
             </a:extLst>
           </p:cNvPr>
@@ -4020,7 +4020,7 @@
           <p:cNvPr id="15" name="stat label 3">
             <a:extLst>
               <a:ext uri="{FF2B5EF4-FFF2-40B4-BE49-F238E27FC236}">
-                <a16:creationId xmlns:a16="http://schemas.microsoft.com/office/drawing/2014/main" id="{674804A4-7C5D-1E37-6AF8-FE5C6E635C57}"/>
+                <a16:creationId xmlns:a16="http://schemas.microsoft.com/office/drawing/2014/main" id="{CFA65554-0D53-96DB-3AE1-03E1A0B577E0}"/>
               </a:ext>
             </a:extLst>
           </p:cNvPr>
@@ -4066,7 +4066,7 @@
           <p:cNvPr id="16" name="stat 4">
             <a:extLst>
               <a:ext uri="{FF2B5EF4-FFF2-40B4-BE49-F238E27FC236}">
-                <a16:creationId xmlns:a16="http://schemas.microsoft.com/office/drawing/2014/main" id="{7E97397A-D367-1FA6-0D00-1C5AC31F0941}"/>
+                <a16:creationId xmlns:a16="http://schemas.microsoft.com/office/drawing/2014/main" id="{C34EE10F-94A9-7EC4-4052-80049CD036A4}"/>
               </a:ext>
             </a:extLst>
           </p:cNvPr>
@@ -4136,7 +4136,7 @@
           <p:cNvPr id="17" name="stat value 4">
             <a:extLst>
               <a:ext uri="{FF2B5EF4-FFF2-40B4-BE49-F238E27FC236}">
-                <a16:creationId xmlns:a16="http://schemas.microsoft.com/office/drawing/2014/main" id="{8E3B7FAE-8796-02D6-0BC0-6D21A736D7FB}"/>
+                <a16:creationId xmlns:a16="http://schemas.microsoft.com/office/drawing/2014/main" id="{6DD44F3F-B197-E36A-9017-3468DC2307B3}"/>
               </a:ext>
             </a:extLst>
           </p:cNvPr>
@@ -4166,7 +4166,7 @@
                 </a:solidFill>
                 <a:latin typeface="Calibri" panose="020F0502020204030204" pitchFamily="34" charset="0"/>
               </a:rPr>
-              <a:t>4.5 / 4.9 W</a:t>
+              <a:t>3.1 / 3.7 W</a:t>
             </a:r>
             <a:endParaRPr lang="zh-CN" altLang="en-US" sz="7400" b="1">
               <a:solidFill>
@@ -4182,7 +4182,7 @@
           <p:cNvPr id="18" name="stat label 4">
             <a:extLst>
               <a:ext uri="{FF2B5EF4-FFF2-40B4-BE49-F238E27FC236}">
-                <a16:creationId xmlns:a16="http://schemas.microsoft.com/office/drawing/2014/main" id="{29E01A97-9952-A90F-5E0A-84ADACADC824}"/>
+                <a16:creationId xmlns:a16="http://schemas.microsoft.com/office/drawing/2014/main" id="{5AF48842-118F-399C-0AF4-BA65D8BDF9CD}"/>
               </a:ext>
             </a:extLst>
           </p:cNvPr>
@@ -4212,7 +4212,7 @@
                 </a:solidFill>
                 <a:latin typeface="Calibri" panose="020F0502020204030204" pitchFamily="34" charset="0"/>
               </a:rPr>
-              <a:t>TX / RX on-chip power (Vivado estimate)</a:t>
+              <a:t>TX / RX measured power (PL + PS + DDR rails)</a:t>
             </a:r>
             <a:endParaRPr lang="zh-CN" altLang="en-US" sz="2500">
               <a:solidFill>
@@ -4228,7 +4228,7 @@
           <p:cNvPr id="19" name="card 1">
             <a:extLst>
               <a:ext uri="{FF2B5EF4-FFF2-40B4-BE49-F238E27FC236}">
-                <a16:creationId xmlns:a16="http://schemas.microsoft.com/office/drawing/2014/main" id="{4AC753BA-EE6B-A0A5-628F-D7B597B1BCDE}"/>
+                <a16:creationId xmlns:a16="http://schemas.microsoft.com/office/drawing/2014/main" id="{D63E54A9-10AC-760F-2E28-4D5D89BC8C40}"/>
               </a:ext>
             </a:extLst>
           </p:cNvPr>
@@ -4298,7 +4298,7 @@
           <p:cNvPr id="20" name="badge 1">
             <a:extLst>
               <a:ext uri="{FF2B5EF4-FFF2-40B4-BE49-F238E27FC236}">
-                <a16:creationId xmlns:a16="http://schemas.microsoft.com/office/drawing/2014/main" id="{58FE3D1B-E0FB-977D-DBB1-A630B16A147D}"/>
+                <a16:creationId xmlns:a16="http://schemas.microsoft.com/office/drawing/2014/main" id="{C11BA5DE-2CCF-6FD8-CD10-F93CA0D79C4B}"/>
               </a:ext>
             </a:extLst>
           </p:cNvPr>
@@ -4380,7 +4380,7 @@
           <p:cNvPr id="21" name="title 1">
             <a:extLst>
               <a:ext uri="{FF2B5EF4-FFF2-40B4-BE49-F238E27FC236}">
-                <a16:creationId xmlns:a16="http://schemas.microsoft.com/office/drawing/2014/main" id="{1980FD73-0392-8696-07ED-278CB443C9CA}"/>
+                <a16:creationId xmlns:a16="http://schemas.microsoft.com/office/drawing/2014/main" id="{660CF24E-1AD4-0B7E-6BBC-EFDD7B76BC2A}"/>
               </a:ext>
             </a:extLst>
           </p:cNvPr>
@@ -4426,7 +4426,7 @@
           <p:cNvPr id="23" name="图片 22">
             <a:extLst>
               <a:ext uri="{FF2B5EF4-FFF2-40B4-BE49-F238E27FC236}">
-                <a16:creationId xmlns:a16="http://schemas.microsoft.com/office/drawing/2014/main" id="{DA61493D-89FB-1E79-1FDD-A34D0C81CA46}"/>
+                <a16:creationId xmlns:a16="http://schemas.microsoft.com/office/drawing/2014/main" id="{A68D3F68-909E-5C5B-ED3F-1AD3B6155981}"/>
               </a:ext>
             </a:extLst>
           </p:cNvPr>
@@ -4462,7 +4462,7 @@
           <p:cNvPr id="24" name="文本框 23">
             <a:extLst>
               <a:ext uri="{FF2B5EF4-FFF2-40B4-BE49-F238E27FC236}">
-                <a16:creationId xmlns:a16="http://schemas.microsoft.com/office/drawing/2014/main" id="{E9B97563-FB0C-ACF3-839E-365332215162}"/>
+                <a16:creationId xmlns:a16="http://schemas.microsoft.com/office/drawing/2014/main" id="{6FCA0AD5-098B-E9FF-960F-662B5FE9FA82}"/>
               </a:ext>
             </a:extLst>
           </p:cNvPr>
@@ -4508,7 +4508,7 @@
           <p:cNvPr id="25" name="card 2">
             <a:extLst>
               <a:ext uri="{FF2B5EF4-FFF2-40B4-BE49-F238E27FC236}">
-                <a16:creationId xmlns:a16="http://schemas.microsoft.com/office/drawing/2014/main" id="{DFF6720A-2616-F078-81F9-ED51C91C2A5A}"/>
+                <a16:creationId xmlns:a16="http://schemas.microsoft.com/office/drawing/2014/main" id="{F1B63663-00A3-661A-5916-545C896EE6F3}"/>
               </a:ext>
             </a:extLst>
           </p:cNvPr>
@@ -4578,7 +4578,7 @@
           <p:cNvPr id="26" name="badge 2">
             <a:extLst>
               <a:ext uri="{FF2B5EF4-FFF2-40B4-BE49-F238E27FC236}">
-                <a16:creationId xmlns:a16="http://schemas.microsoft.com/office/drawing/2014/main" id="{A238221B-4497-1DE7-97A1-C417CCF17A63}"/>
+                <a16:creationId xmlns:a16="http://schemas.microsoft.com/office/drawing/2014/main" id="{E6F7AF2E-7276-A528-9B58-7140294D363F}"/>
               </a:ext>
             </a:extLst>
           </p:cNvPr>
@@ -4660,7 +4660,7 @@
           <p:cNvPr id="27" name="title 2">
             <a:extLst>
               <a:ext uri="{FF2B5EF4-FFF2-40B4-BE49-F238E27FC236}">
-                <a16:creationId xmlns:a16="http://schemas.microsoft.com/office/drawing/2014/main" id="{6DC44B0E-3293-AE9C-05E2-3982479DA8F8}"/>
+                <a16:creationId xmlns:a16="http://schemas.microsoft.com/office/drawing/2014/main" id="{409473A2-23C0-7855-F8BE-9F3836B1D0F4}"/>
               </a:ext>
             </a:extLst>
           </p:cNvPr>
@@ -4706,7 +4706,7 @@
           <p:cNvPr id="28" name="文本框 27">
             <a:extLst>
               <a:ext uri="{FF2B5EF4-FFF2-40B4-BE49-F238E27FC236}">
-                <a16:creationId xmlns:a16="http://schemas.microsoft.com/office/drawing/2014/main" id="{3AF1CD94-BBC1-2BBB-AA61-2D5EE9870D54}"/>
+                <a16:creationId xmlns:a16="http://schemas.microsoft.com/office/drawing/2014/main" id="{2E13D04B-4D35-6437-728C-1381194F9A0D}"/>
               </a:ext>
             </a:extLst>
           </p:cNvPr>
@@ -4753,7 +4753,7 @@
           <p:cNvPr id="29" name="文本框 28">
             <a:extLst>
               <a:ext uri="{FF2B5EF4-FFF2-40B4-BE49-F238E27FC236}">
-                <a16:creationId xmlns:a16="http://schemas.microsoft.com/office/drawing/2014/main" id="{616F71F4-B4A3-E763-5860-DBD9274F3CC1}"/>
+                <a16:creationId xmlns:a16="http://schemas.microsoft.com/office/drawing/2014/main" id="{0F9944C7-1304-0F83-FA7B-0927214B6025}"/>
               </a:ext>
             </a:extLst>
           </p:cNvPr>
@@ -4800,7 +4800,7 @@
           <p:cNvPr id="30" name="矩形: 圆角 29">
             <a:extLst>
               <a:ext uri="{FF2B5EF4-FFF2-40B4-BE49-F238E27FC236}">
-                <a16:creationId xmlns:a16="http://schemas.microsoft.com/office/drawing/2014/main" id="{4CD07E43-DED7-943D-8B61-02B241247F3B}"/>
+                <a16:creationId xmlns:a16="http://schemas.microsoft.com/office/drawing/2014/main" id="{E54A466C-ED9B-5592-9F9E-57299C79B085}"/>
               </a:ext>
             </a:extLst>
           </p:cNvPr>
@@ -4882,7 +4882,7 @@
           <p:cNvPr id="31" name="矩形: 圆角 30">
             <a:extLst>
               <a:ext uri="{FF2B5EF4-FFF2-40B4-BE49-F238E27FC236}">
-                <a16:creationId xmlns:a16="http://schemas.microsoft.com/office/drawing/2014/main" id="{5AFD651D-9500-80A7-DB79-C96A792620A6}"/>
+                <a16:creationId xmlns:a16="http://schemas.microsoft.com/office/drawing/2014/main" id="{763E1003-26E8-D6F3-7E81-AB8496875B6C}"/>
               </a:ext>
             </a:extLst>
           </p:cNvPr>
@@ -4964,7 +4964,7 @@
           <p:cNvPr id="32" name="直接箭头连接符 31">
             <a:extLst>
               <a:ext uri="{FF2B5EF4-FFF2-40B4-BE49-F238E27FC236}">
-                <a16:creationId xmlns:a16="http://schemas.microsoft.com/office/drawing/2014/main" id="{503335A7-0A12-857D-C5EC-001A95BD8E9F}"/>
+                <a16:creationId xmlns:a16="http://schemas.microsoft.com/office/drawing/2014/main" id="{951AB448-404B-EC6F-3661-0881EF4AC595}"/>
               </a:ext>
             </a:extLst>
           </p:cNvPr>
@@ -5006,7 +5006,7 @@
           <p:cNvPr id="33" name="直接箭头连接符 32">
             <a:extLst>
               <a:ext uri="{FF2B5EF4-FFF2-40B4-BE49-F238E27FC236}">
-                <a16:creationId xmlns:a16="http://schemas.microsoft.com/office/drawing/2014/main" id="{4782A184-8D0C-4730-FBCF-5FF9084E929D}"/>
+                <a16:creationId xmlns:a16="http://schemas.microsoft.com/office/drawing/2014/main" id="{B7DA1BC0-5546-E26E-9327-57AE23061B6B}"/>
               </a:ext>
             </a:extLst>
           </p:cNvPr>
@@ -5048,7 +5048,7 @@
           <p:cNvPr id="34" name="矩形: 圆角 33">
             <a:extLst>
               <a:ext uri="{FF2B5EF4-FFF2-40B4-BE49-F238E27FC236}">
-                <a16:creationId xmlns:a16="http://schemas.microsoft.com/office/drawing/2014/main" id="{24123639-7A64-292E-0CA1-265122675892}"/>
+                <a16:creationId xmlns:a16="http://schemas.microsoft.com/office/drawing/2014/main" id="{C2D30F02-31BA-F729-9EE6-D2AFFEF23E0D}"/>
               </a:ext>
             </a:extLst>
           </p:cNvPr>
@@ -5130,7 +5130,7 @@
           <p:cNvPr id="35" name="矩形: 圆角 34">
             <a:extLst>
               <a:ext uri="{FF2B5EF4-FFF2-40B4-BE49-F238E27FC236}">
-                <a16:creationId xmlns:a16="http://schemas.microsoft.com/office/drawing/2014/main" id="{5CD8C88D-569E-B812-2C7A-765C6C7914F3}"/>
+                <a16:creationId xmlns:a16="http://schemas.microsoft.com/office/drawing/2014/main" id="{AE9091CE-526A-39F3-208B-27BC197559C0}"/>
               </a:ext>
             </a:extLst>
           </p:cNvPr>
@@ -5212,7 +5212,7 @@
           <p:cNvPr id="36" name="直接箭头连接符 35">
             <a:extLst>
               <a:ext uri="{FF2B5EF4-FFF2-40B4-BE49-F238E27FC236}">
-                <a16:creationId xmlns:a16="http://schemas.microsoft.com/office/drawing/2014/main" id="{97DB9C56-7B47-E019-A155-50445374AF7B}"/>
+                <a16:creationId xmlns:a16="http://schemas.microsoft.com/office/drawing/2014/main" id="{282998E6-F77E-659C-3D89-A76BAD5D941E}"/>
               </a:ext>
             </a:extLst>
           </p:cNvPr>
@@ -5254,7 +5254,7 @@
           <p:cNvPr id="37" name="直接箭头连接符 36">
             <a:extLst>
               <a:ext uri="{FF2B5EF4-FFF2-40B4-BE49-F238E27FC236}">
-                <a16:creationId xmlns:a16="http://schemas.microsoft.com/office/drawing/2014/main" id="{280CD0EB-78A7-9933-5729-CA6312527137}"/>
+                <a16:creationId xmlns:a16="http://schemas.microsoft.com/office/drawing/2014/main" id="{6D986505-BADE-0BCD-CE1C-0DF1763932A6}"/>
               </a:ext>
             </a:extLst>
           </p:cNvPr>
@@ -5296,7 +5296,7 @@
           <p:cNvPr id="38" name="矩形: 圆角 37">
             <a:extLst>
               <a:ext uri="{FF2B5EF4-FFF2-40B4-BE49-F238E27FC236}">
-                <a16:creationId xmlns:a16="http://schemas.microsoft.com/office/drawing/2014/main" id="{983CBB7C-234C-E289-A274-C95271020C29}"/>
+                <a16:creationId xmlns:a16="http://schemas.microsoft.com/office/drawing/2014/main" id="{CD4E84BB-9014-6EF4-B314-4F69640F8FCD}"/>
               </a:ext>
             </a:extLst>
           </p:cNvPr>
@@ -5378,7 +5378,7 @@
           <p:cNvPr id="39" name="矩形: 圆角 38">
             <a:extLst>
               <a:ext uri="{FF2B5EF4-FFF2-40B4-BE49-F238E27FC236}">
-                <a16:creationId xmlns:a16="http://schemas.microsoft.com/office/drawing/2014/main" id="{B03683E9-9901-29BB-53E1-F403A9BAE621}"/>
+                <a16:creationId xmlns:a16="http://schemas.microsoft.com/office/drawing/2014/main" id="{35E89B88-4998-9801-5CD4-5EB0796ACB7B}"/>
               </a:ext>
             </a:extLst>
           </p:cNvPr>
@@ -5460,7 +5460,7 @@
           <p:cNvPr id="40" name="直接箭头连接符 39">
             <a:extLst>
               <a:ext uri="{FF2B5EF4-FFF2-40B4-BE49-F238E27FC236}">
-                <a16:creationId xmlns:a16="http://schemas.microsoft.com/office/drawing/2014/main" id="{94C4DD22-11D8-2B3E-07E5-7A2FBF55CA98}"/>
+                <a16:creationId xmlns:a16="http://schemas.microsoft.com/office/drawing/2014/main" id="{B0C5BB20-DFA7-F79B-5711-7CB6A941D6B5}"/>
               </a:ext>
             </a:extLst>
           </p:cNvPr>
@@ -5502,7 +5502,7 @@
           <p:cNvPr id="41" name="直接箭头连接符 40">
             <a:extLst>
               <a:ext uri="{FF2B5EF4-FFF2-40B4-BE49-F238E27FC236}">
-                <a16:creationId xmlns:a16="http://schemas.microsoft.com/office/drawing/2014/main" id="{2AD18C80-ECA5-0144-FBA6-D676765A2F1E}"/>
+                <a16:creationId xmlns:a16="http://schemas.microsoft.com/office/drawing/2014/main" id="{43687458-EC80-DBE9-7F06-8094E4359896}"/>
               </a:ext>
             </a:extLst>
           </p:cNvPr>
@@ -5544,7 +5544,7 @@
           <p:cNvPr id="42" name="矩形: 圆角 41">
             <a:extLst>
               <a:ext uri="{FF2B5EF4-FFF2-40B4-BE49-F238E27FC236}">
-                <a16:creationId xmlns:a16="http://schemas.microsoft.com/office/drawing/2014/main" id="{63888C46-73E3-FAC3-DBFB-167428B60BF7}"/>
+                <a16:creationId xmlns:a16="http://schemas.microsoft.com/office/drawing/2014/main" id="{9657D2C3-290B-0D4F-381E-9A04E4AEA211}"/>
               </a:ext>
             </a:extLst>
           </p:cNvPr>
@@ -5626,7 +5626,7 @@
           <p:cNvPr id="43" name="矩形: 圆角 42">
             <a:extLst>
               <a:ext uri="{FF2B5EF4-FFF2-40B4-BE49-F238E27FC236}">
-                <a16:creationId xmlns:a16="http://schemas.microsoft.com/office/drawing/2014/main" id="{51F3DFE3-D243-3F6F-A12C-A9E26B2C88D6}"/>
+                <a16:creationId xmlns:a16="http://schemas.microsoft.com/office/drawing/2014/main" id="{C2B5D183-7723-2003-6A74-B7C52885295C}"/>
               </a:ext>
             </a:extLst>
           </p:cNvPr>
@@ -5708,7 +5708,7 @@
           <p:cNvPr id="44" name="直接箭头连接符 43">
             <a:extLst>
               <a:ext uri="{FF2B5EF4-FFF2-40B4-BE49-F238E27FC236}">
-                <a16:creationId xmlns:a16="http://schemas.microsoft.com/office/drawing/2014/main" id="{650E8FAD-9DB6-26A3-84A8-6F0704DCA2E7}"/>
+                <a16:creationId xmlns:a16="http://schemas.microsoft.com/office/drawing/2014/main" id="{58973C7D-9BD2-3B07-91DA-67E200B88E74}"/>
               </a:ext>
             </a:extLst>
           </p:cNvPr>
@@ -5750,7 +5750,7 @@
           <p:cNvPr id="45" name="文本框 44">
             <a:extLst>
               <a:ext uri="{FF2B5EF4-FFF2-40B4-BE49-F238E27FC236}">
-                <a16:creationId xmlns:a16="http://schemas.microsoft.com/office/drawing/2014/main" id="{50E341C4-DAAC-5DAB-4BAD-F2351869A2C5}"/>
+                <a16:creationId xmlns:a16="http://schemas.microsoft.com/office/drawing/2014/main" id="{ED97D530-B0FA-B097-691A-FE7A78D628FA}"/>
               </a:ext>
             </a:extLst>
           </p:cNvPr>
@@ -5797,7 +5797,7 @@
           <p:cNvPr id="46" name="文本框 45">
             <a:extLst>
               <a:ext uri="{FF2B5EF4-FFF2-40B4-BE49-F238E27FC236}">
-                <a16:creationId xmlns:a16="http://schemas.microsoft.com/office/drawing/2014/main" id="{F3AB406F-583E-558B-E0C2-AE5A30463CB8}"/>
+                <a16:creationId xmlns:a16="http://schemas.microsoft.com/office/drawing/2014/main" id="{B9C864E0-D791-A1C6-20AE-65D875B03288}"/>
               </a:ext>
             </a:extLst>
           </p:cNvPr>
@@ -5843,7 +5843,7 @@
           <p:cNvPr id="47" name="card 3">
             <a:extLst>
               <a:ext uri="{FF2B5EF4-FFF2-40B4-BE49-F238E27FC236}">
-                <a16:creationId xmlns:a16="http://schemas.microsoft.com/office/drawing/2014/main" id="{9948B86B-465E-B6A2-D22C-703C6F9F63E3}"/>
+                <a16:creationId xmlns:a16="http://schemas.microsoft.com/office/drawing/2014/main" id="{65516AF7-55FA-E2A4-4F67-9C3560323652}"/>
               </a:ext>
             </a:extLst>
           </p:cNvPr>
@@ -5913,7 +5913,7 @@
           <p:cNvPr id="48" name="badge 3">
             <a:extLst>
               <a:ext uri="{FF2B5EF4-FFF2-40B4-BE49-F238E27FC236}">
-                <a16:creationId xmlns:a16="http://schemas.microsoft.com/office/drawing/2014/main" id="{AE1521F0-C578-8E87-B0D1-4F6A756BDF57}"/>
+                <a16:creationId xmlns:a16="http://schemas.microsoft.com/office/drawing/2014/main" id="{415C865C-B3F5-E79C-537B-561751325404}"/>
               </a:ext>
             </a:extLst>
           </p:cNvPr>
@@ -5995,7 +5995,7 @@
           <p:cNvPr id="49" name="title 3">
             <a:extLst>
               <a:ext uri="{FF2B5EF4-FFF2-40B4-BE49-F238E27FC236}">
-                <a16:creationId xmlns:a16="http://schemas.microsoft.com/office/drawing/2014/main" id="{2ABB9E2E-6AC6-9437-B950-D0B567C332C0}"/>
+                <a16:creationId xmlns:a16="http://schemas.microsoft.com/office/drawing/2014/main" id="{B3C87F8A-604C-EFEE-E854-387C5300DCEE}"/>
               </a:ext>
             </a:extLst>
           </p:cNvPr>
@@ -6041,7 +6041,7 @@
           <p:cNvPr id="50" name="文本框 49">
             <a:extLst>
               <a:ext uri="{FF2B5EF4-FFF2-40B4-BE49-F238E27FC236}">
-                <a16:creationId xmlns:a16="http://schemas.microsoft.com/office/drawing/2014/main" id="{757D6735-9858-B8A7-A7A1-E14989242E51}"/>
+                <a16:creationId xmlns:a16="http://schemas.microsoft.com/office/drawing/2014/main" id="{DF61BEF3-8FC7-8DF9-2FC4-E2C4BF988182}"/>
               </a:ext>
             </a:extLst>
           </p:cNvPr>
@@ -6087,7 +6087,7 @@
           <p:cNvPr id="51" name="矩形: 圆角 50">
             <a:extLst>
               <a:ext uri="{FF2B5EF4-FFF2-40B4-BE49-F238E27FC236}">
-                <a16:creationId xmlns:a16="http://schemas.microsoft.com/office/drawing/2014/main" id="{903CFAAA-1F96-772C-A7F1-4A162B52178E}"/>
+                <a16:creationId xmlns:a16="http://schemas.microsoft.com/office/drawing/2014/main" id="{F3E0E8D7-00D1-35EF-223F-49017685F3C9}"/>
               </a:ext>
             </a:extLst>
           </p:cNvPr>
@@ -6171,7 +6171,7 @@
           <p:cNvPr id="52" name="矩形: 圆角 51">
             <a:extLst>
               <a:ext uri="{FF2B5EF4-FFF2-40B4-BE49-F238E27FC236}">
-                <a16:creationId xmlns:a16="http://schemas.microsoft.com/office/drawing/2014/main" id="{67A744AC-BB59-3D7E-9933-B549E45C4249}"/>
+                <a16:creationId xmlns:a16="http://schemas.microsoft.com/office/drawing/2014/main" id="{64A3F4A6-6C2F-D037-CF89-26AE8FCFB280}"/>
               </a:ext>
             </a:extLst>
           </p:cNvPr>
@@ -6255,7 +6255,7 @@
           <p:cNvPr id="53" name="直接箭头连接符 52">
             <a:extLst>
               <a:ext uri="{FF2B5EF4-FFF2-40B4-BE49-F238E27FC236}">
-                <a16:creationId xmlns:a16="http://schemas.microsoft.com/office/drawing/2014/main" id="{1F39E7CD-42D0-4AFA-1A5B-CF399B88CB09}"/>
+                <a16:creationId xmlns:a16="http://schemas.microsoft.com/office/drawing/2014/main" id="{B106802A-8A47-76C6-5493-CC24B54F4001}"/>
               </a:ext>
             </a:extLst>
           </p:cNvPr>
@@ -6301,7 +6301,7 @@
           <p:cNvPr id="54" name="矩形: 圆角 53">
             <a:extLst>
               <a:ext uri="{FF2B5EF4-FFF2-40B4-BE49-F238E27FC236}">
-                <a16:creationId xmlns:a16="http://schemas.microsoft.com/office/drawing/2014/main" id="{DEB90D95-8F1C-9B38-6CD9-2A91DC55FF0D}"/>
+                <a16:creationId xmlns:a16="http://schemas.microsoft.com/office/drawing/2014/main" id="{821D639A-4D90-0390-E970-221C347E20EA}"/>
               </a:ext>
             </a:extLst>
           </p:cNvPr>
@@ -6385,7 +6385,7 @@
           <p:cNvPr id="55" name="直接箭头连接符 54">
             <a:extLst>
               <a:ext uri="{FF2B5EF4-FFF2-40B4-BE49-F238E27FC236}">
-                <a16:creationId xmlns:a16="http://schemas.microsoft.com/office/drawing/2014/main" id="{B140D45A-7D5B-352D-66C9-A59601521CA9}"/>
+                <a16:creationId xmlns:a16="http://schemas.microsoft.com/office/drawing/2014/main" id="{8AA02136-2C0C-4B34-2613-F6B9BA6B7EFD}"/>
               </a:ext>
             </a:extLst>
           </p:cNvPr>
@@ -6431,7 +6431,7 @@
           <p:cNvPr id="56" name="矩形: 圆角 55">
             <a:extLst>
               <a:ext uri="{FF2B5EF4-FFF2-40B4-BE49-F238E27FC236}">
-                <a16:creationId xmlns:a16="http://schemas.microsoft.com/office/drawing/2014/main" id="{67A53A47-9DDC-BBA3-201F-63C4607CA43C}"/>
+                <a16:creationId xmlns:a16="http://schemas.microsoft.com/office/drawing/2014/main" id="{4179B97B-06F9-41C7-4CAE-DF9405D0D45F}"/>
               </a:ext>
             </a:extLst>
           </p:cNvPr>
@@ -6515,7 +6515,7 @@
           <p:cNvPr id="57" name="直接箭头连接符 56">
             <a:extLst>
               <a:ext uri="{FF2B5EF4-FFF2-40B4-BE49-F238E27FC236}">
-                <a16:creationId xmlns:a16="http://schemas.microsoft.com/office/drawing/2014/main" id="{54CDA925-203E-CAAD-2A98-F14105934C94}"/>
+                <a16:creationId xmlns:a16="http://schemas.microsoft.com/office/drawing/2014/main" id="{623D507B-0ADE-CE73-765F-741B60FEA52B}"/>
               </a:ext>
             </a:extLst>
           </p:cNvPr>
@@ -6561,7 +6561,7 @@
           <p:cNvPr id="58" name="矩形: 圆角 57">
             <a:extLst>
               <a:ext uri="{FF2B5EF4-FFF2-40B4-BE49-F238E27FC236}">
-                <a16:creationId xmlns:a16="http://schemas.microsoft.com/office/drawing/2014/main" id="{BA7ADC38-D7F9-0C0D-3750-D91EB4C6FAD1}"/>
+                <a16:creationId xmlns:a16="http://schemas.microsoft.com/office/drawing/2014/main" id="{E9A540CD-CF75-3E0E-08A4-9C8B89417D10}"/>
               </a:ext>
             </a:extLst>
           </p:cNvPr>
@@ -6645,7 +6645,7 @@
           <p:cNvPr id="59" name="直接箭头连接符 58">
             <a:extLst>
               <a:ext uri="{FF2B5EF4-FFF2-40B4-BE49-F238E27FC236}">
-                <a16:creationId xmlns:a16="http://schemas.microsoft.com/office/drawing/2014/main" id="{683CD1FA-D29A-24A6-341F-2A40E9E68491}"/>
+                <a16:creationId xmlns:a16="http://schemas.microsoft.com/office/drawing/2014/main" id="{93D5DD8B-5920-E128-02E9-53A139F3F03C}"/>
               </a:ext>
             </a:extLst>
           </p:cNvPr>
@@ -6691,7 +6691,7 @@
           <p:cNvPr id="60" name="矩形: 圆角 59">
             <a:extLst>
               <a:ext uri="{FF2B5EF4-FFF2-40B4-BE49-F238E27FC236}">
-                <a16:creationId xmlns:a16="http://schemas.microsoft.com/office/drawing/2014/main" id="{618DC254-8DD8-02BC-ED60-B0C9E76C8A4A}"/>
+                <a16:creationId xmlns:a16="http://schemas.microsoft.com/office/drawing/2014/main" id="{52B40107-0981-3C98-5267-B94EB1D8083F}"/>
               </a:ext>
             </a:extLst>
           </p:cNvPr>
@@ -6775,7 +6775,7 @@
           <p:cNvPr id="61" name="直接箭头连接符 60">
             <a:extLst>
               <a:ext uri="{FF2B5EF4-FFF2-40B4-BE49-F238E27FC236}">
-                <a16:creationId xmlns:a16="http://schemas.microsoft.com/office/drawing/2014/main" id="{6D41A184-239E-E211-42AB-79295E4AC5C4}"/>
+                <a16:creationId xmlns:a16="http://schemas.microsoft.com/office/drawing/2014/main" id="{96DEC756-9709-C264-32AF-25D1F3E2D574}"/>
               </a:ext>
             </a:extLst>
           </p:cNvPr>
@@ -6821,7 +6821,7 @@
           <p:cNvPr id="62" name="矩形: 圆角 61">
             <a:extLst>
               <a:ext uri="{FF2B5EF4-FFF2-40B4-BE49-F238E27FC236}">
-                <a16:creationId xmlns:a16="http://schemas.microsoft.com/office/drawing/2014/main" id="{1C76FA0A-D4D8-5F03-7C4B-EAEA71E70F01}"/>
+                <a16:creationId xmlns:a16="http://schemas.microsoft.com/office/drawing/2014/main" id="{2DBE0BF4-FC7A-C97C-B39A-E280EAF4BF3B}"/>
               </a:ext>
             </a:extLst>
           </p:cNvPr>
@@ -6905,7 +6905,7 @@
           <p:cNvPr id="63" name="直接箭头连接符 62">
             <a:extLst>
               <a:ext uri="{FF2B5EF4-FFF2-40B4-BE49-F238E27FC236}">
-                <a16:creationId xmlns:a16="http://schemas.microsoft.com/office/drawing/2014/main" id="{89E4BB2C-9B1C-23F7-FD0F-B7E2FB8F3B59}"/>
+                <a16:creationId xmlns:a16="http://schemas.microsoft.com/office/drawing/2014/main" id="{37143D45-B60C-D1F5-199D-DDF84FD25506}"/>
               </a:ext>
             </a:extLst>
           </p:cNvPr>
@@ -6951,7 +6951,7 @@
           <p:cNvPr id="64" name="矩形: 圆角 63">
             <a:extLst>
               <a:ext uri="{FF2B5EF4-FFF2-40B4-BE49-F238E27FC236}">
-                <a16:creationId xmlns:a16="http://schemas.microsoft.com/office/drawing/2014/main" id="{24EAE674-1482-E553-7EC9-23FF5D3A6735}"/>
+                <a16:creationId xmlns:a16="http://schemas.microsoft.com/office/drawing/2014/main" id="{DBCC217B-6EAD-CC95-8CE6-29EC27A0D277}"/>
               </a:ext>
             </a:extLst>
           </p:cNvPr>
@@ -7035,7 +7035,7 @@
           <p:cNvPr id="65" name="直接箭头连接符 64">
             <a:extLst>
               <a:ext uri="{FF2B5EF4-FFF2-40B4-BE49-F238E27FC236}">
-                <a16:creationId xmlns:a16="http://schemas.microsoft.com/office/drawing/2014/main" id="{B8A997A0-313C-110B-3590-8412A9D30024}"/>
+                <a16:creationId xmlns:a16="http://schemas.microsoft.com/office/drawing/2014/main" id="{C43A8E19-A556-5AB7-26E8-405A782E0802}"/>
               </a:ext>
             </a:extLst>
           </p:cNvPr>
@@ -7081,7 +7081,7 @@
           <p:cNvPr id="66" name="矩形: 圆角 65">
             <a:extLst>
               <a:ext uri="{FF2B5EF4-FFF2-40B4-BE49-F238E27FC236}">
-                <a16:creationId xmlns:a16="http://schemas.microsoft.com/office/drawing/2014/main" id="{EC738D8B-47D9-0FB8-C61D-0720041951EC}"/>
+                <a16:creationId xmlns:a16="http://schemas.microsoft.com/office/drawing/2014/main" id="{B859B88A-A5C3-2DF6-4666-25B51EB0611E}"/>
               </a:ext>
             </a:extLst>
           </p:cNvPr>
@@ -7165,7 +7165,7 @@
           <p:cNvPr id="67" name="直接箭头连接符 66">
             <a:extLst>
               <a:ext uri="{FF2B5EF4-FFF2-40B4-BE49-F238E27FC236}">
-                <a16:creationId xmlns:a16="http://schemas.microsoft.com/office/drawing/2014/main" id="{39FB3B9E-75F6-EDB3-4FF4-16D866FE64F9}"/>
+                <a16:creationId xmlns:a16="http://schemas.microsoft.com/office/drawing/2014/main" id="{C6E4378D-B7BF-8844-8A8E-02539CCA0249}"/>
               </a:ext>
             </a:extLst>
           </p:cNvPr>
@@ -7211,7 +7211,7 @@
           <p:cNvPr id="68" name="矩形: 圆角 67">
             <a:extLst>
               <a:ext uri="{FF2B5EF4-FFF2-40B4-BE49-F238E27FC236}">
-                <a16:creationId xmlns:a16="http://schemas.microsoft.com/office/drawing/2014/main" id="{2BC1716A-578F-0EA6-8998-4F003CC5E416}"/>
+                <a16:creationId xmlns:a16="http://schemas.microsoft.com/office/drawing/2014/main" id="{DCB52AD5-958D-930D-11CF-B2893B271C89}"/>
               </a:ext>
             </a:extLst>
           </p:cNvPr>
@@ -7295,7 +7295,7 @@
           <p:cNvPr id="69" name="矩形: 圆角 68">
             <a:extLst>
               <a:ext uri="{FF2B5EF4-FFF2-40B4-BE49-F238E27FC236}">
-                <a16:creationId xmlns:a16="http://schemas.microsoft.com/office/drawing/2014/main" id="{5A3B205A-0711-986C-05B6-CA6AAFA42331}"/>
+                <a16:creationId xmlns:a16="http://schemas.microsoft.com/office/drawing/2014/main" id="{BA094D24-2C1E-D5D1-CC13-59097C496FE8}"/>
               </a:ext>
             </a:extLst>
           </p:cNvPr>
@@ -7379,7 +7379,7 @@
           <p:cNvPr id="70" name="直接箭头连接符 69">
             <a:extLst>
               <a:ext uri="{FF2B5EF4-FFF2-40B4-BE49-F238E27FC236}">
-                <a16:creationId xmlns:a16="http://schemas.microsoft.com/office/drawing/2014/main" id="{E3D54DAC-A3F1-AE1C-2A3E-038E51BD2165}"/>
+                <a16:creationId xmlns:a16="http://schemas.microsoft.com/office/drawing/2014/main" id="{1DE7A032-120A-4E07-970D-5F580AAADF49}"/>
               </a:ext>
             </a:extLst>
           </p:cNvPr>
@@ -7425,7 +7425,7 @@
           <p:cNvPr id="71" name="矩形: 圆角 70">
             <a:extLst>
               <a:ext uri="{FF2B5EF4-FFF2-40B4-BE49-F238E27FC236}">
-                <a16:creationId xmlns:a16="http://schemas.microsoft.com/office/drawing/2014/main" id="{0C27030E-A015-1653-34D5-893E4E3757B0}"/>
+                <a16:creationId xmlns:a16="http://schemas.microsoft.com/office/drawing/2014/main" id="{E1624121-9E0C-B981-B20B-F24E0F1FCC84}"/>
               </a:ext>
             </a:extLst>
           </p:cNvPr>
@@ -7509,7 +7509,7 @@
           <p:cNvPr id="72" name="直接箭头连接符 71">
             <a:extLst>
               <a:ext uri="{FF2B5EF4-FFF2-40B4-BE49-F238E27FC236}">
-                <a16:creationId xmlns:a16="http://schemas.microsoft.com/office/drawing/2014/main" id="{3ACF0569-103A-42A3-164E-921876304F76}"/>
+                <a16:creationId xmlns:a16="http://schemas.microsoft.com/office/drawing/2014/main" id="{FDF18249-32D1-47DC-6EDB-92C25BDD2950}"/>
               </a:ext>
             </a:extLst>
           </p:cNvPr>
@@ -7555,7 +7555,7 @@
           <p:cNvPr id="73" name="矩形: 圆角 72">
             <a:extLst>
               <a:ext uri="{FF2B5EF4-FFF2-40B4-BE49-F238E27FC236}">
-                <a16:creationId xmlns:a16="http://schemas.microsoft.com/office/drawing/2014/main" id="{6047F4E2-E821-A93A-C318-4256622C846C}"/>
+                <a16:creationId xmlns:a16="http://schemas.microsoft.com/office/drawing/2014/main" id="{F49C11F6-26C2-ED99-3F80-7511170C8B96}"/>
               </a:ext>
             </a:extLst>
           </p:cNvPr>
@@ -7639,7 +7639,7 @@
           <p:cNvPr id="74" name="直接箭头连接符 73">
             <a:extLst>
               <a:ext uri="{FF2B5EF4-FFF2-40B4-BE49-F238E27FC236}">
-                <a16:creationId xmlns:a16="http://schemas.microsoft.com/office/drawing/2014/main" id="{A2C90E8D-33B9-4D40-B97A-E2F62285D9B5}"/>
+                <a16:creationId xmlns:a16="http://schemas.microsoft.com/office/drawing/2014/main" id="{7DF718F3-B8BA-7273-AF9F-791E81EB2490}"/>
               </a:ext>
             </a:extLst>
           </p:cNvPr>
@@ -7685,7 +7685,7 @@
           <p:cNvPr id="75" name="矩形: 圆角 74">
             <a:extLst>
               <a:ext uri="{FF2B5EF4-FFF2-40B4-BE49-F238E27FC236}">
-                <a16:creationId xmlns:a16="http://schemas.microsoft.com/office/drawing/2014/main" id="{EBD9B2F9-1C1D-E113-FB9E-937E9B90AD45}"/>
+                <a16:creationId xmlns:a16="http://schemas.microsoft.com/office/drawing/2014/main" id="{318A61F7-C792-486C-73AC-66B372FBE868}"/>
               </a:ext>
             </a:extLst>
           </p:cNvPr>
@@ -7769,7 +7769,7 @@
           <p:cNvPr id="76" name="直接箭头连接符 75">
             <a:extLst>
               <a:ext uri="{FF2B5EF4-FFF2-40B4-BE49-F238E27FC236}">
-                <a16:creationId xmlns:a16="http://schemas.microsoft.com/office/drawing/2014/main" id="{F382524F-4D55-E6F9-074E-19C543DC34F8}"/>
+                <a16:creationId xmlns:a16="http://schemas.microsoft.com/office/drawing/2014/main" id="{95D29543-3190-A504-6C2C-E27155ACA04F}"/>
               </a:ext>
             </a:extLst>
           </p:cNvPr>
@@ -7815,7 +7815,7 @@
           <p:cNvPr id="77" name="矩形: 圆角 76">
             <a:extLst>
               <a:ext uri="{FF2B5EF4-FFF2-40B4-BE49-F238E27FC236}">
-                <a16:creationId xmlns:a16="http://schemas.microsoft.com/office/drawing/2014/main" id="{CD8D7BF3-6B95-6CC0-7843-D6A60098EAA8}"/>
+                <a16:creationId xmlns:a16="http://schemas.microsoft.com/office/drawing/2014/main" id="{63CA1265-BEF2-9C1B-1DA7-11CE2DD22AC1}"/>
               </a:ext>
             </a:extLst>
           </p:cNvPr>
@@ -7899,7 +7899,7 @@
           <p:cNvPr id="78" name="直接箭头连接符 77">
             <a:extLst>
               <a:ext uri="{FF2B5EF4-FFF2-40B4-BE49-F238E27FC236}">
-                <a16:creationId xmlns:a16="http://schemas.microsoft.com/office/drawing/2014/main" id="{E5B1AB76-8010-00EB-C7F7-0FEC14FCE991}"/>
+                <a16:creationId xmlns:a16="http://schemas.microsoft.com/office/drawing/2014/main" id="{BCDDC3B2-6A20-9DB7-A982-34DA4D1009A9}"/>
               </a:ext>
             </a:extLst>
           </p:cNvPr>
@@ -7945,7 +7945,7 @@
           <p:cNvPr id="79" name="矩形: 圆角 78">
             <a:extLst>
               <a:ext uri="{FF2B5EF4-FFF2-40B4-BE49-F238E27FC236}">
-                <a16:creationId xmlns:a16="http://schemas.microsoft.com/office/drawing/2014/main" id="{AE708656-155F-D214-A6B1-393D2AB1117F}"/>
+                <a16:creationId xmlns:a16="http://schemas.microsoft.com/office/drawing/2014/main" id="{64E31F3F-F522-42F2-EAF2-CE5F77C1E1C3}"/>
               </a:ext>
             </a:extLst>
           </p:cNvPr>
@@ -8029,7 +8029,7 @@
           <p:cNvPr id="80" name="直接箭头连接符 79">
             <a:extLst>
               <a:ext uri="{FF2B5EF4-FFF2-40B4-BE49-F238E27FC236}">
-                <a16:creationId xmlns:a16="http://schemas.microsoft.com/office/drawing/2014/main" id="{12F377F4-8179-FC0E-B919-6E5AB6D0EBB2}"/>
+                <a16:creationId xmlns:a16="http://schemas.microsoft.com/office/drawing/2014/main" id="{2C1BB4CA-DAF8-77F0-1686-1B80B70D08EB}"/>
               </a:ext>
             </a:extLst>
           </p:cNvPr>
@@ -8075,7 +8075,7 @@
           <p:cNvPr id="81" name="矩形: 圆角 80">
             <a:extLst>
               <a:ext uri="{FF2B5EF4-FFF2-40B4-BE49-F238E27FC236}">
-                <a16:creationId xmlns:a16="http://schemas.microsoft.com/office/drawing/2014/main" id="{6ECCAF79-C919-ED2C-9E20-2E58410C94E1}"/>
+                <a16:creationId xmlns:a16="http://schemas.microsoft.com/office/drawing/2014/main" id="{ABD14EA8-73C1-BF68-B7D5-809E78014405}"/>
               </a:ext>
             </a:extLst>
           </p:cNvPr>
@@ -8159,7 +8159,7 @@
           <p:cNvPr id="82" name="直接箭头连接符 81">
             <a:extLst>
               <a:ext uri="{FF2B5EF4-FFF2-40B4-BE49-F238E27FC236}">
-                <a16:creationId xmlns:a16="http://schemas.microsoft.com/office/drawing/2014/main" id="{5EB85A99-0763-9235-EA4F-37308BA1F112}"/>
+                <a16:creationId xmlns:a16="http://schemas.microsoft.com/office/drawing/2014/main" id="{6457E6E2-09CC-D7AE-E361-BDF36688780A}"/>
               </a:ext>
             </a:extLst>
           </p:cNvPr>
@@ -8205,7 +8205,7 @@
           <p:cNvPr id="83" name="矩形: 圆角 82">
             <a:extLst>
               <a:ext uri="{FF2B5EF4-FFF2-40B4-BE49-F238E27FC236}">
-                <a16:creationId xmlns:a16="http://schemas.microsoft.com/office/drawing/2014/main" id="{C1D4207D-B7D4-019E-8AD2-5EB24B05164E}"/>
+                <a16:creationId xmlns:a16="http://schemas.microsoft.com/office/drawing/2014/main" id="{DDD3287A-7FC1-6B23-0B96-15689395F54F}"/>
               </a:ext>
             </a:extLst>
           </p:cNvPr>
@@ -8289,7 +8289,7 @@
           <p:cNvPr id="84" name="直接箭头连接符 83">
             <a:extLst>
               <a:ext uri="{FF2B5EF4-FFF2-40B4-BE49-F238E27FC236}">
-                <a16:creationId xmlns:a16="http://schemas.microsoft.com/office/drawing/2014/main" id="{3FF20E93-2B46-6489-E539-2635BB45B783}"/>
+                <a16:creationId xmlns:a16="http://schemas.microsoft.com/office/drawing/2014/main" id="{382C71F9-ACD1-5073-E53E-490F54509EB8}"/>
               </a:ext>
             </a:extLst>
           </p:cNvPr>
@@ -8335,7 +8335,7 @@
           <p:cNvPr id="85" name="矩形: 圆角 84">
             <a:extLst>
               <a:ext uri="{FF2B5EF4-FFF2-40B4-BE49-F238E27FC236}">
-                <a16:creationId xmlns:a16="http://schemas.microsoft.com/office/drawing/2014/main" id="{3D752CD0-2C7E-CB26-0ABD-89338D7BC9BB}"/>
+                <a16:creationId xmlns:a16="http://schemas.microsoft.com/office/drawing/2014/main" id="{4DB19A54-9F8F-98DE-463E-41CCC360218E}"/>
               </a:ext>
             </a:extLst>
           </p:cNvPr>
@@ -8419,7 +8419,7 @@
           <p:cNvPr id="86" name="直接箭头连接符 85">
             <a:extLst>
               <a:ext uri="{FF2B5EF4-FFF2-40B4-BE49-F238E27FC236}">
-                <a16:creationId xmlns:a16="http://schemas.microsoft.com/office/drawing/2014/main" id="{4BC9506E-A971-9441-D142-68927D87298A}"/>
+                <a16:creationId xmlns:a16="http://schemas.microsoft.com/office/drawing/2014/main" id="{89E75101-CDF0-97F4-8B46-3240F194A76B}"/>
               </a:ext>
             </a:extLst>
           </p:cNvPr>
@@ -8465,7 +8465,7 @@
           <p:cNvPr id="87" name="连接符: 肘形 86">
             <a:extLst>
               <a:ext uri="{FF2B5EF4-FFF2-40B4-BE49-F238E27FC236}">
-                <a16:creationId xmlns:a16="http://schemas.microsoft.com/office/drawing/2014/main" id="{3E2BB58A-3ECD-D026-0AF6-3A546573C0E7}"/>
+                <a16:creationId xmlns:a16="http://schemas.microsoft.com/office/drawing/2014/main" id="{0C6BF7A1-C119-C9BA-67A6-B5F872769E23}"/>
               </a:ext>
             </a:extLst>
           </p:cNvPr>
@@ -8513,7 +8513,7 @@
           <p:cNvPr id="88" name="矩形: 圆角 87">
             <a:extLst>
               <a:ext uri="{FF2B5EF4-FFF2-40B4-BE49-F238E27FC236}">
-                <a16:creationId xmlns:a16="http://schemas.microsoft.com/office/drawing/2014/main" id="{20D58471-D5D0-542E-72D4-D9359565A75C}"/>
+                <a16:creationId xmlns:a16="http://schemas.microsoft.com/office/drawing/2014/main" id="{84A45E47-8870-14A2-C21F-398D10968482}"/>
               </a:ext>
             </a:extLst>
           </p:cNvPr>
@@ -8583,7 +8583,7 @@
           <p:cNvPr id="89" name="文本框 88">
             <a:extLst>
               <a:ext uri="{FF2B5EF4-FFF2-40B4-BE49-F238E27FC236}">
-                <a16:creationId xmlns:a16="http://schemas.microsoft.com/office/drawing/2014/main" id="{73ECB067-C60A-BE39-C831-5EA080AA47AD}"/>
+                <a16:creationId xmlns:a16="http://schemas.microsoft.com/office/drawing/2014/main" id="{22679623-1C0C-9EB8-05E5-1809CE20775C}"/>
               </a:ext>
             </a:extLst>
           </p:cNvPr>
@@ -8629,7 +8629,7 @@
           <p:cNvPr id="90" name="文本框 89">
             <a:extLst>
               <a:ext uri="{FF2B5EF4-FFF2-40B4-BE49-F238E27FC236}">
-                <a16:creationId xmlns:a16="http://schemas.microsoft.com/office/drawing/2014/main" id="{6266DEB2-7BD8-F8E9-6C59-0D45E7230B3A}"/>
+                <a16:creationId xmlns:a16="http://schemas.microsoft.com/office/drawing/2014/main" id="{4A35DB51-1D99-BDB1-7BE6-7D10C64FB6DE}"/>
               </a:ext>
             </a:extLst>
           </p:cNvPr>
@@ -8675,7 +8675,7 @@
           <p:cNvPr id="91" name="文本框 90">
             <a:extLst>
               <a:ext uri="{FF2B5EF4-FFF2-40B4-BE49-F238E27FC236}">
-                <a16:creationId xmlns:a16="http://schemas.microsoft.com/office/drawing/2014/main" id="{7A87E92A-AD72-0936-904E-292BE086E77A}"/>
+                <a16:creationId xmlns:a16="http://schemas.microsoft.com/office/drawing/2014/main" id="{E16B7429-13A0-1DD0-A6BB-89397990CEB0}"/>
               </a:ext>
             </a:extLst>
           </p:cNvPr>
@@ -8752,7 +8752,7 @@
           <p:cNvPr id="92" name="card 4">
             <a:extLst>
               <a:ext uri="{FF2B5EF4-FFF2-40B4-BE49-F238E27FC236}">
-                <a16:creationId xmlns:a16="http://schemas.microsoft.com/office/drawing/2014/main" id="{B20AB575-DDA3-8A9A-B442-83202A8F87E5}"/>
+                <a16:creationId xmlns:a16="http://schemas.microsoft.com/office/drawing/2014/main" id="{9333A0C7-C1D6-484B-61E4-D0D50484A657}"/>
               </a:ext>
             </a:extLst>
           </p:cNvPr>
@@ -8822,7 +8822,7 @@
           <p:cNvPr id="93" name="badge 4">
             <a:extLst>
               <a:ext uri="{FF2B5EF4-FFF2-40B4-BE49-F238E27FC236}">
-                <a16:creationId xmlns:a16="http://schemas.microsoft.com/office/drawing/2014/main" id="{2681D068-6943-5B32-4ACF-15D37398FB3A}"/>
+                <a16:creationId xmlns:a16="http://schemas.microsoft.com/office/drawing/2014/main" id="{8D1D6B08-96BA-170B-91B7-253A32768C03}"/>
               </a:ext>
             </a:extLst>
           </p:cNvPr>
@@ -8904,7 +8904,7 @@
           <p:cNvPr id="94" name="title 4">
             <a:extLst>
               <a:ext uri="{FF2B5EF4-FFF2-40B4-BE49-F238E27FC236}">
-                <a16:creationId xmlns:a16="http://schemas.microsoft.com/office/drawing/2014/main" id="{F9991551-B5D0-36B2-EC8D-2B8FDA85F15F}"/>
+                <a16:creationId xmlns:a16="http://schemas.microsoft.com/office/drawing/2014/main" id="{5421263A-399F-6828-B168-C1087DD756A8}"/>
               </a:ext>
             </a:extLst>
           </p:cNvPr>
@@ -8950,7 +8950,7 @@
           <p:cNvPr id="95" name="文本框 94">
             <a:extLst>
               <a:ext uri="{FF2B5EF4-FFF2-40B4-BE49-F238E27FC236}">
-                <a16:creationId xmlns:a16="http://schemas.microsoft.com/office/drawing/2014/main" id="{53763C73-A1AE-ADE3-9F2B-DE9508DB03C3}"/>
+                <a16:creationId xmlns:a16="http://schemas.microsoft.com/office/drawing/2014/main" id="{90D73281-81F2-7390-B48B-E483E4F27968}"/>
               </a:ext>
             </a:extLst>
           </p:cNvPr>
@@ -9069,7 +9069,7 @@
           <p:cNvPr id="97" name="图片 96">
             <a:extLst>
               <a:ext uri="{FF2B5EF4-FFF2-40B4-BE49-F238E27FC236}">
-                <a16:creationId xmlns:a16="http://schemas.microsoft.com/office/drawing/2014/main" id="{08C1F404-9F33-DDA2-B64A-4C52939507E1}"/>
+                <a16:creationId xmlns:a16="http://schemas.microsoft.com/office/drawing/2014/main" id="{C10AE307-BAE6-3C6C-9D1C-32A7143F2097}"/>
               </a:ext>
             </a:extLst>
           </p:cNvPr>
@@ -9110,7 +9110,7 @@
           <p:cNvPr id="98" name="文本框 97">
             <a:extLst>
               <a:ext uri="{FF2B5EF4-FFF2-40B4-BE49-F238E27FC236}">
-                <a16:creationId xmlns:a16="http://schemas.microsoft.com/office/drawing/2014/main" id="{EC787625-29C1-7B86-2D9D-AF997C9F7682}"/>
+                <a16:creationId xmlns:a16="http://schemas.microsoft.com/office/drawing/2014/main" id="{B4051D10-BA84-9B65-877B-C4C3997A0576}"/>
               </a:ext>
             </a:extLst>
           </p:cNvPr>
@@ -9157,7 +9157,7 @@
           <p:cNvPr id="99" name="card 5">
             <a:extLst>
               <a:ext uri="{FF2B5EF4-FFF2-40B4-BE49-F238E27FC236}">
-                <a16:creationId xmlns:a16="http://schemas.microsoft.com/office/drawing/2014/main" id="{7276B9E9-D420-E4D5-F2EB-5977F476B5B2}"/>
+                <a16:creationId xmlns:a16="http://schemas.microsoft.com/office/drawing/2014/main" id="{9307E042-B8F8-C172-51CB-90FC2E7B8734}"/>
               </a:ext>
             </a:extLst>
           </p:cNvPr>
@@ -9227,7 +9227,7 @@
           <p:cNvPr id="100" name="badge 5">
             <a:extLst>
               <a:ext uri="{FF2B5EF4-FFF2-40B4-BE49-F238E27FC236}">
-                <a16:creationId xmlns:a16="http://schemas.microsoft.com/office/drawing/2014/main" id="{7731B3D4-E91B-1BC1-2607-D666E16DFEDA}"/>
+                <a16:creationId xmlns:a16="http://schemas.microsoft.com/office/drawing/2014/main" id="{04260809-8B4C-A35A-DE8B-4A96B7D7DA64}"/>
               </a:ext>
             </a:extLst>
           </p:cNvPr>
@@ -9309,7 +9309,7 @@
           <p:cNvPr id="101" name="title 5">
             <a:extLst>
               <a:ext uri="{FF2B5EF4-FFF2-40B4-BE49-F238E27FC236}">
-                <a16:creationId xmlns:a16="http://schemas.microsoft.com/office/drawing/2014/main" id="{7FE643CE-524B-9DE7-8673-F5DFC5FE30CE}"/>
+                <a16:creationId xmlns:a16="http://schemas.microsoft.com/office/drawing/2014/main" id="{3890C9BB-12C5-5382-2426-9513EEFA213E}"/>
               </a:ext>
             </a:extLst>
           </p:cNvPr>
@@ -9355,7 +9355,7 @@
           <p:cNvPr id="102" name="文本框 101">
             <a:extLst>
               <a:ext uri="{FF2B5EF4-FFF2-40B4-BE49-F238E27FC236}">
-                <a16:creationId xmlns:a16="http://schemas.microsoft.com/office/drawing/2014/main" id="{95050220-ECBC-0072-62F0-57B381DF511C}"/>
+                <a16:creationId xmlns:a16="http://schemas.microsoft.com/office/drawing/2014/main" id="{87EAF432-7662-29BF-5357-37926BDDE24E}"/>
               </a:ext>
             </a:extLst>
           </p:cNvPr>
@@ -9453,7 +9453,7 @@
           <p:cNvPr id="103" name="矩形: 圆角 102">
             <a:extLst>
               <a:ext uri="{FF2B5EF4-FFF2-40B4-BE49-F238E27FC236}">
-                <a16:creationId xmlns:a16="http://schemas.microsoft.com/office/drawing/2014/main" id="{7762CB4C-ED42-5B12-849D-C2900B8F8364}"/>
+                <a16:creationId xmlns:a16="http://schemas.microsoft.com/office/drawing/2014/main" id="{FD47A110-B8C9-31A6-2761-320A0204A01C}"/>
               </a:ext>
             </a:extLst>
           </p:cNvPr>
@@ -9535,7 +9535,7 @@
           <p:cNvPr id="104" name="直接箭头连接符 103">
             <a:extLst>
               <a:ext uri="{FF2B5EF4-FFF2-40B4-BE49-F238E27FC236}">
-                <a16:creationId xmlns:a16="http://schemas.microsoft.com/office/drawing/2014/main" id="{5EAD585B-A919-102F-B51D-EAD9710C4CA6}"/>
+                <a16:creationId xmlns:a16="http://schemas.microsoft.com/office/drawing/2014/main" id="{12B8D160-30BD-A37B-148A-A207B02CD612}"/>
               </a:ext>
             </a:extLst>
           </p:cNvPr>
@@ -9577,7 +9577,7 @@
           <p:cNvPr id="105" name="矩形: 圆角 104">
             <a:extLst>
               <a:ext uri="{FF2B5EF4-FFF2-40B4-BE49-F238E27FC236}">
-                <a16:creationId xmlns:a16="http://schemas.microsoft.com/office/drawing/2014/main" id="{D7C7177C-8516-E70B-A3FD-2E55508E6EF7}"/>
+                <a16:creationId xmlns:a16="http://schemas.microsoft.com/office/drawing/2014/main" id="{ADA17E4C-8067-0ABF-CBDF-464298B6CC21}"/>
               </a:ext>
             </a:extLst>
           </p:cNvPr>
@@ -9659,7 +9659,7 @@
           <p:cNvPr id="106" name="直接箭头连接符 105">
             <a:extLst>
               <a:ext uri="{FF2B5EF4-FFF2-40B4-BE49-F238E27FC236}">
-                <a16:creationId xmlns:a16="http://schemas.microsoft.com/office/drawing/2014/main" id="{F069743A-69CB-6019-F7F9-E07F095D64AD}"/>
+                <a16:creationId xmlns:a16="http://schemas.microsoft.com/office/drawing/2014/main" id="{0CE92A35-0E76-9FB3-DEAD-C95DF97B2114}"/>
               </a:ext>
             </a:extLst>
           </p:cNvPr>
@@ -9701,7 +9701,7 @@
           <p:cNvPr id="107" name="矩形: 圆角 106">
             <a:extLst>
               <a:ext uri="{FF2B5EF4-FFF2-40B4-BE49-F238E27FC236}">
-                <a16:creationId xmlns:a16="http://schemas.microsoft.com/office/drawing/2014/main" id="{C631A303-F312-2259-ECA6-C0DA85D97C0E}"/>
+                <a16:creationId xmlns:a16="http://schemas.microsoft.com/office/drawing/2014/main" id="{B95DEA6C-B7A5-1010-40E8-ACAB42C8F052}"/>
               </a:ext>
             </a:extLst>
           </p:cNvPr>
@@ -9783,7 +9783,7 @@
           <p:cNvPr id="108" name="直接箭头连接符 107">
             <a:extLst>
               <a:ext uri="{FF2B5EF4-FFF2-40B4-BE49-F238E27FC236}">
-                <a16:creationId xmlns:a16="http://schemas.microsoft.com/office/drawing/2014/main" id="{F90C66D5-D175-DC23-9BB1-E01C658DCFEC}"/>
+                <a16:creationId xmlns:a16="http://schemas.microsoft.com/office/drawing/2014/main" id="{F6F3074F-273A-67D0-135F-3E809A09F798}"/>
               </a:ext>
             </a:extLst>
           </p:cNvPr>
@@ -9825,7 +9825,7 @@
           <p:cNvPr id="109" name="矩形: 圆角 108">
             <a:extLst>
               <a:ext uri="{FF2B5EF4-FFF2-40B4-BE49-F238E27FC236}">
-                <a16:creationId xmlns:a16="http://schemas.microsoft.com/office/drawing/2014/main" id="{3A74B5CA-15EC-8E30-2803-D870E0F4FECA}"/>
+                <a16:creationId xmlns:a16="http://schemas.microsoft.com/office/drawing/2014/main" id="{4AB3D436-763D-33C8-5041-239686C96FB2}"/>
               </a:ext>
             </a:extLst>
           </p:cNvPr>
@@ -9907,7 +9907,7 @@
           <p:cNvPr id="110" name="文本框 109">
             <a:extLst>
               <a:ext uri="{FF2B5EF4-FFF2-40B4-BE49-F238E27FC236}">
-                <a16:creationId xmlns:a16="http://schemas.microsoft.com/office/drawing/2014/main" id="{8A979131-6870-7ADD-4EB9-39D55852ED83}"/>
+                <a16:creationId xmlns:a16="http://schemas.microsoft.com/office/drawing/2014/main" id="{03B2C484-ADD4-CCBC-25E1-94CD9C5045DE}"/>
               </a:ext>
             </a:extLst>
           </p:cNvPr>
@@ -9954,7 +9954,7 @@
           <p:cNvPr id="111" name="文本框 110">
             <a:extLst>
               <a:ext uri="{FF2B5EF4-FFF2-40B4-BE49-F238E27FC236}">
-                <a16:creationId xmlns:a16="http://schemas.microsoft.com/office/drawing/2014/main" id="{9CD67D8E-38BC-3000-2797-9318EAEAA901}"/>
+                <a16:creationId xmlns:a16="http://schemas.microsoft.com/office/drawing/2014/main" id="{4386988B-419F-52A3-A4BA-D624B806F94B}"/>
               </a:ext>
             </a:extLst>
           </p:cNvPr>
@@ -10000,7 +10000,7 @@
           <p:cNvPr id="112" name="表格 111">
             <a:extLst>
               <a:ext uri="{FF2B5EF4-FFF2-40B4-BE49-F238E27FC236}">
-                <a16:creationId xmlns:a16="http://schemas.microsoft.com/office/drawing/2014/main" id="{CB0F9B42-DA6C-9716-212D-3E2F09BFD7CA}"/>
+                <a16:creationId xmlns:a16="http://schemas.microsoft.com/office/drawing/2014/main" id="{43D55F8A-1DA5-A37E-0162-301053AE8889}"/>
               </a:ext>
             </a:extLst>
           </p:cNvPr>
@@ -10010,7 +10010,7 @@
           <p:nvPr>
             <p:extLst>
               <p:ext uri="{D42A27DB-BD31-4B8C-83A1-F6EECF244321}">
-                <p14:modId xmlns:p14="http://schemas.microsoft.com/office/powerpoint/2010/main" val="4275897796"/>
+                <p14:modId xmlns:p14="http://schemas.microsoft.com/office/powerpoint/2010/main" val="4062232227"/>
               </p:ext>
             </p:extLst>
           </p:nvPr>
@@ -10029,21 +10029,21 @@
                 <a:gridCol w="3594100">
                   <a:extLst>
                     <a:ext uri="{9D8B030D-6E8A-4147-A177-3AD203B41FA5}">
-                      <a16:colId xmlns:a16="http://schemas.microsoft.com/office/drawing/2014/main" val="4014726553"/>
+                      <a16:colId xmlns:a16="http://schemas.microsoft.com/office/drawing/2014/main" val="618035185"/>
                     </a:ext>
                   </a:extLst>
                 </a:gridCol>
                 <a:gridCol w="2286000">
                   <a:extLst>
                     <a:ext uri="{9D8B030D-6E8A-4147-A177-3AD203B41FA5}">
-                      <a16:colId xmlns:a16="http://schemas.microsoft.com/office/drawing/2014/main" val="3018637457"/>
+                      <a16:colId xmlns:a16="http://schemas.microsoft.com/office/drawing/2014/main" val="3483479922"/>
                     </a:ext>
                   </a:extLst>
                 </a:gridCol>
                 <a:gridCol w="2286000">
                   <a:extLst>
                     <a:ext uri="{9D8B030D-6E8A-4147-A177-3AD203B41FA5}">
-                      <a16:colId xmlns:a16="http://schemas.microsoft.com/office/drawing/2014/main" val="4003018153"/>
+                      <a16:colId xmlns:a16="http://schemas.microsoft.com/office/drawing/2014/main" val="4259471027"/>
                     </a:ext>
                   </a:extLst>
                 </a:gridCol>
@@ -10129,7 +10129,7 @@
                 </a:tc>
                 <a:extLst>
                   <a:ext uri="{0D108BD9-81ED-4DB2-BD59-A6C34878D82A}">
-                    <a16:rowId xmlns:a16="http://schemas.microsoft.com/office/drawing/2014/main" val="3070731997"/>
+                    <a16:rowId xmlns:a16="http://schemas.microsoft.com/office/drawing/2014/main" val="3743804330"/>
                   </a:ext>
                 </a:extLst>
               </a:tr>
@@ -10223,7 +10223,7 @@
                 </a:tc>
                 <a:extLst>
                   <a:ext uri="{0D108BD9-81ED-4DB2-BD59-A6C34878D82A}">
-                    <a16:rowId xmlns:a16="http://schemas.microsoft.com/office/drawing/2014/main" val="2326238389"/>
+                    <a16:rowId xmlns:a16="http://schemas.microsoft.com/office/drawing/2014/main" val="3777610916"/>
                   </a:ext>
                 </a:extLst>
               </a:tr>
@@ -10317,7 +10317,7 @@
                 </a:tc>
                 <a:extLst>
                   <a:ext uri="{0D108BD9-81ED-4DB2-BD59-A6C34878D82A}">
-                    <a16:rowId xmlns:a16="http://schemas.microsoft.com/office/drawing/2014/main" val="161774773"/>
+                    <a16:rowId xmlns:a16="http://schemas.microsoft.com/office/drawing/2014/main" val="490821023"/>
                   </a:ext>
                 </a:extLst>
               </a:tr>
@@ -10411,7 +10411,7 @@
                 </a:tc>
                 <a:extLst>
                   <a:ext uri="{0D108BD9-81ED-4DB2-BD59-A6C34878D82A}">
-                    <a16:rowId xmlns:a16="http://schemas.microsoft.com/office/drawing/2014/main" val="1619479670"/>
+                    <a16:rowId xmlns:a16="http://schemas.microsoft.com/office/drawing/2014/main" val="943743820"/>
                   </a:ext>
                 </a:extLst>
               </a:tr>
@@ -10505,7 +10505,7 @@
                 </a:tc>
                 <a:extLst>
                   <a:ext uri="{0D108BD9-81ED-4DB2-BD59-A6C34878D82A}">
-                    <a16:rowId xmlns:a16="http://schemas.microsoft.com/office/drawing/2014/main" val="1559185791"/>
+                    <a16:rowId xmlns:a16="http://schemas.microsoft.com/office/drawing/2014/main" val="4168657628"/>
                   </a:ext>
                 </a:extLst>
               </a:tr>
@@ -10518,7 +10518,7 @@
           <p:cNvPr id="113" name="文本框 112">
             <a:extLst>
               <a:ext uri="{FF2B5EF4-FFF2-40B4-BE49-F238E27FC236}">
-                <a16:creationId xmlns:a16="http://schemas.microsoft.com/office/drawing/2014/main" id="{2B54F5AF-6699-2AAA-1AB8-F5173D2C013B}"/>
+                <a16:creationId xmlns:a16="http://schemas.microsoft.com/office/drawing/2014/main" id="{DF61767F-6DC0-07CA-9E3A-50ACCA8F6DF7}"/>
               </a:ext>
             </a:extLst>
           </p:cNvPr>
@@ -10564,7 +10564,7 @@
           <p:cNvPr id="114" name="表格 113">
             <a:extLst>
               <a:ext uri="{FF2B5EF4-FFF2-40B4-BE49-F238E27FC236}">
-                <a16:creationId xmlns:a16="http://schemas.microsoft.com/office/drawing/2014/main" id="{707EB77B-DC0D-8552-2948-0B4F71E337AE}"/>
+                <a16:creationId xmlns:a16="http://schemas.microsoft.com/office/drawing/2014/main" id="{34ACBBFA-843C-E5C9-7A32-A72D41377CC7}"/>
               </a:ext>
             </a:extLst>
           </p:cNvPr>
@@ -10574,7 +10574,7 @@
           <p:nvPr>
             <p:extLst>
               <p:ext uri="{D42A27DB-BD31-4B8C-83A1-F6EECF244321}">
-                <p14:modId xmlns:p14="http://schemas.microsoft.com/office/powerpoint/2010/main" val="1902862977"/>
+                <p14:modId xmlns:p14="http://schemas.microsoft.com/office/powerpoint/2010/main" val="2816336545"/>
               </p:ext>
             </p:extLst>
           </p:nvPr>
@@ -10593,42 +10593,42 @@
                 <a:gridCol w="1054100">
                   <a:extLst>
                     <a:ext uri="{9D8B030D-6E8A-4147-A177-3AD203B41FA5}">
-                      <a16:colId xmlns:a16="http://schemas.microsoft.com/office/drawing/2014/main" val="374448750"/>
+                      <a16:colId xmlns:a16="http://schemas.microsoft.com/office/drawing/2014/main" val="459354956"/>
                     </a:ext>
                   </a:extLst>
                 </a:gridCol>
                 <a:gridCol w="1524000">
                   <a:extLst>
                     <a:ext uri="{9D8B030D-6E8A-4147-A177-3AD203B41FA5}">
-                      <a16:colId xmlns:a16="http://schemas.microsoft.com/office/drawing/2014/main" val="3018366560"/>
+                      <a16:colId xmlns:a16="http://schemas.microsoft.com/office/drawing/2014/main" val="2666206889"/>
                     </a:ext>
                   </a:extLst>
                 </a:gridCol>
                 <a:gridCol w="1587500">
                   <a:extLst>
                     <a:ext uri="{9D8B030D-6E8A-4147-A177-3AD203B41FA5}">
-                      <a16:colId xmlns:a16="http://schemas.microsoft.com/office/drawing/2014/main" val="57786743"/>
+                      <a16:colId xmlns:a16="http://schemas.microsoft.com/office/drawing/2014/main" val="1210456811"/>
                     </a:ext>
                   </a:extLst>
                 </a:gridCol>
                 <a:gridCol w="1270000">
                   <a:extLst>
                     <a:ext uri="{9D8B030D-6E8A-4147-A177-3AD203B41FA5}">
-                      <a16:colId xmlns:a16="http://schemas.microsoft.com/office/drawing/2014/main" val="972226433"/>
+                      <a16:colId xmlns:a16="http://schemas.microsoft.com/office/drawing/2014/main" val="640509947"/>
                     </a:ext>
                   </a:extLst>
                 </a:gridCol>
                 <a:gridCol w="1270000">
                   <a:extLst>
                     <a:ext uri="{9D8B030D-6E8A-4147-A177-3AD203B41FA5}">
-                      <a16:colId xmlns:a16="http://schemas.microsoft.com/office/drawing/2014/main" val="980480718"/>
+                      <a16:colId xmlns:a16="http://schemas.microsoft.com/office/drawing/2014/main" val="218671221"/>
                     </a:ext>
                   </a:extLst>
                 </a:gridCol>
                 <a:gridCol w="1460500">
                   <a:extLst>
                     <a:ext uri="{9D8B030D-6E8A-4147-A177-3AD203B41FA5}">
-                      <a16:colId xmlns:a16="http://schemas.microsoft.com/office/drawing/2014/main" val="607827423"/>
+                      <a16:colId xmlns:a16="http://schemas.microsoft.com/office/drawing/2014/main" val="1760828717"/>
                     </a:ext>
                   </a:extLst>
                 </a:gridCol>
@@ -10801,7 +10801,7 @@
                 </a:tc>
                 <a:extLst>
                   <a:ext uri="{0D108BD9-81ED-4DB2-BD59-A6C34878D82A}">
-                    <a16:rowId xmlns:a16="http://schemas.microsoft.com/office/drawing/2014/main" val="2394424475"/>
+                    <a16:rowId xmlns:a16="http://schemas.microsoft.com/office/drawing/2014/main" val="804704411"/>
                   </a:ext>
                 </a:extLst>
               </a:tr>
@@ -10982,7 +10982,7 @@
                 </a:tc>
                 <a:extLst>
                   <a:ext uri="{0D108BD9-81ED-4DB2-BD59-A6C34878D82A}">
-                    <a16:rowId xmlns:a16="http://schemas.microsoft.com/office/drawing/2014/main" val="1956640234"/>
+                    <a16:rowId xmlns:a16="http://schemas.microsoft.com/office/drawing/2014/main" val="2030896858"/>
                   </a:ext>
                 </a:extLst>
               </a:tr>
@@ -11163,7 +11163,7 @@
                 </a:tc>
                 <a:extLst>
                   <a:ext uri="{0D108BD9-81ED-4DB2-BD59-A6C34878D82A}">
-                    <a16:rowId xmlns:a16="http://schemas.microsoft.com/office/drawing/2014/main" val="1983762462"/>
+                    <a16:rowId xmlns:a16="http://schemas.microsoft.com/office/drawing/2014/main" val="1498366418"/>
                   </a:ext>
                 </a:extLst>
               </a:tr>
@@ -11176,7 +11176,7 @@
           <p:cNvPr id="115" name="card 6">
             <a:extLst>
               <a:ext uri="{FF2B5EF4-FFF2-40B4-BE49-F238E27FC236}">
-                <a16:creationId xmlns:a16="http://schemas.microsoft.com/office/drawing/2014/main" id="{BA1AD1B0-AF34-5396-D21F-05029F9B7AEE}"/>
+                <a16:creationId xmlns:a16="http://schemas.microsoft.com/office/drawing/2014/main" id="{03FCE49F-EF47-2FCC-8DBE-E0291DDCD7A9}"/>
               </a:ext>
             </a:extLst>
           </p:cNvPr>
@@ -11246,7 +11246,7 @@
           <p:cNvPr id="116" name="badge 6">
             <a:extLst>
               <a:ext uri="{FF2B5EF4-FFF2-40B4-BE49-F238E27FC236}">
-                <a16:creationId xmlns:a16="http://schemas.microsoft.com/office/drawing/2014/main" id="{7453FACF-14F4-C613-59B0-C2C2C0EB9D02}"/>
+                <a16:creationId xmlns:a16="http://schemas.microsoft.com/office/drawing/2014/main" id="{BD82B4B8-F184-4A44-3151-844C854E85B4}"/>
               </a:ext>
             </a:extLst>
           </p:cNvPr>
@@ -11328,7 +11328,7 @@
           <p:cNvPr id="117" name="title 6">
             <a:extLst>
               <a:ext uri="{FF2B5EF4-FFF2-40B4-BE49-F238E27FC236}">
-                <a16:creationId xmlns:a16="http://schemas.microsoft.com/office/drawing/2014/main" id="{8B0F140A-F65E-726B-01E3-F73A942E7E1A}"/>
+                <a16:creationId xmlns:a16="http://schemas.microsoft.com/office/drawing/2014/main" id="{C3023596-B31D-4EA7-1717-4A595090A4B2}"/>
               </a:ext>
             </a:extLst>
           </p:cNvPr>
@@ -11374,7 +11374,7 @@
           <p:cNvPr id="119" name="图片 118">
             <a:extLst>
               <a:ext uri="{FF2B5EF4-FFF2-40B4-BE49-F238E27FC236}">
-                <a16:creationId xmlns:a16="http://schemas.microsoft.com/office/drawing/2014/main" id="{F5911503-E58C-C992-45BB-5DB5378095E6}"/>
+                <a16:creationId xmlns:a16="http://schemas.microsoft.com/office/drawing/2014/main" id="{3993F341-F568-B8A0-895F-A4E883146489}"/>
               </a:ext>
             </a:extLst>
           </p:cNvPr>
@@ -11410,7 +11410,7 @@
           <p:cNvPr id="120" name="文本框 119">
             <a:extLst>
               <a:ext uri="{FF2B5EF4-FFF2-40B4-BE49-F238E27FC236}">
-                <a16:creationId xmlns:a16="http://schemas.microsoft.com/office/drawing/2014/main" id="{8682FFC2-191C-2228-1A13-52381D3B10BA}"/>
+                <a16:creationId xmlns:a16="http://schemas.microsoft.com/office/drawing/2014/main" id="{E99ECC11-0529-CABE-4CDA-6AE674994CA5}"/>
               </a:ext>
             </a:extLst>
           </p:cNvPr>
@@ -11487,7 +11487,7 @@
           <p:cNvPr id="121" name="card 7">
             <a:extLst>
               <a:ext uri="{FF2B5EF4-FFF2-40B4-BE49-F238E27FC236}">
-                <a16:creationId xmlns:a16="http://schemas.microsoft.com/office/drawing/2014/main" id="{4A7F605B-7E68-D95A-839F-768930810AAA}"/>
+                <a16:creationId xmlns:a16="http://schemas.microsoft.com/office/drawing/2014/main" id="{40789039-DB1C-F24F-EAF5-30DA1F4D4DD7}"/>
               </a:ext>
             </a:extLst>
           </p:cNvPr>
@@ -11557,7 +11557,7 @@
           <p:cNvPr id="122" name="badge 7">
             <a:extLst>
               <a:ext uri="{FF2B5EF4-FFF2-40B4-BE49-F238E27FC236}">
-                <a16:creationId xmlns:a16="http://schemas.microsoft.com/office/drawing/2014/main" id="{0BAEF2EE-A656-CEF6-0989-4EA9FE115409}"/>
+                <a16:creationId xmlns:a16="http://schemas.microsoft.com/office/drawing/2014/main" id="{37665064-F464-EDD1-5061-9509C91A18CD}"/>
               </a:ext>
             </a:extLst>
           </p:cNvPr>
@@ -11639,7 +11639,7 @@
           <p:cNvPr id="123" name="title 7">
             <a:extLst>
               <a:ext uri="{FF2B5EF4-FFF2-40B4-BE49-F238E27FC236}">
-                <a16:creationId xmlns:a16="http://schemas.microsoft.com/office/drawing/2014/main" id="{AB014EBB-5986-78B7-4270-6B291B1B347F}"/>
+                <a16:creationId xmlns:a16="http://schemas.microsoft.com/office/drawing/2014/main" id="{CA6EFBFA-E268-1015-4AF1-670715E90C52}"/>
               </a:ext>
             </a:extLst>
           </p:cNvPr>
@@ -11685,7 +11685,7 @@
           <p:cNvPr id="124" name="表格 123">
             <a:extLst>
               <a:ext uri="{FF2B5EF4-FFF2-40B4-BE49-F238E27FC236}">
-                <a16:creationId xmlns:a16="http://schemas.microsoft.com/office/drawing/2014/main" id="{10DA6328-6BCF-5A41-C725-78E3CED9E3FB}"/>
+                <a16:creationId xmlns:a16="http://schemas.microsoft.com/office/drawing/2014/main" id="{08801DEA-079B-A88F-3884-C2EE6471746C}"/>
               </a:ext>
             </a:extLst>
           </p:cNvPr>
@@ -11695,7 +11695,7 @@
           <p:nvPr>
             <p:extLst>
               <p:ext uri="{D42A27DB-BD31-4B8C-83A1-F6EECF244321}">
-                <p14:modId xmlns:p14="http://schemas.microsoft.com/office/powerpoint/2010/main" val="437787023"/>
+                <p14:modId xmlns:p14="http://schemas.microsoft.com/office/powerpoint/2010/main" val="3148503075"/>
               </p:ext>
             </p:extLst>
           </p:nvPr>
@@ -11714,21 +11714,21 @@
                 <a:gridCol w="2730500">
                   <a:extLst>
                     <a:ext uri="{9D8B030D-6E8A-4147-A177-3AD203B41FA5}">
-                      <a16:colId xmlns:a16="http://schemas.microsoft.com/office/drawing/2014/main" val="129918804"/>
+                      <a16:colId xmlns:a16="http://schemas.microsoft.com/office/drawing/2014/main" val="3397485856"/>
                     </a:ext>
                   </a:extLst>
                 </a:gridCol>
                 <a:gridCol w="2705100">
                   <a:extLst>
                     <a:ext uri="{9D8B030D-6E8A-4147-A177-3AD203B41FA5}">
-                      <a16:colId xmlns:a16="http://schemas.microsoft.com/office/drawing/2014/main" val="993240396"/>
+                      <a16:colId xmlns:a16="http://schemas.microsoft.com/office/drawing/2014/main" val="4199961569"/>
                     </a:ext>
                   </a:extLst>
                 </a:gridCol>
                 <a:gridCol w="2730500">
                   <a:extLst>
                     <a:ext uri="{9D8B030D-6E8A-4147-A177-3AD203B41FA5}">
-                      <a16:colId xmlns:a16="http://schemas.microsoft.com/office/drawing/2014/main" val="499665444"/>
+                      <a16:colId xmlns:a16="http://schemas.microsoft.com/office/drawing/2014/main" val="3451948444"/>
                     </a:ext>
                   </a:extLst>
                 </a:gridCol>
@@ -11814,7 +11814,7 @@
                 </a:tc>
                 <a:extLst>
                   <a:ext uri="{0D108BD9-81ED-4DB2-BD59-A6C34878D82A}">
-                    <a16:rowId xmlns:a16="http://schemas.microsoft.com/office/drawing/2014/main" val="1818555207"/>
+                    <a16:rowId xmlns:a16="http://schemas.microsoft.com/office/drawing/2014/main" val="2182700084"/>
                   </a:ext>
                 </a:extLst>
               </a:tr>
@@ -11908,7 +11908,7 @@
                 </a:tc>
                 <a:extLst>
                   <a:ext uri="{0D108BD9-81ED-4DB2-BD59-A6C34878D82A}">
-                    <a16:rowId xmlns:a16="http://schemas.microsoft.com/office/drawing/2014/main" val="1393723304"/>
+                    <a16:rowId xmlns:a16="http://schemas.microsoft.com/office/drawing/2014/main" val="3206632125"/>
                   </a:ext>
                 </a:extLst>
               </a:tr>
@@ -12002,7 +12002,7 @@
                 </a:tc>
                 <a:extLst>
                   <a:ext uri="{0D108BD9-81ED-4DB2-BD59-A6C34878D82A}">
-                    <a16:rowId xmlns:a16="http://schemas.microsoft.com/office/drawing/2014/main" val="86234312"/>
+                    <a16:rowId xmlns:a16="http://schemas.microsoft.com/office/drawing/2014/main" val="3710363389"/>
                   </a:ext>
                 </a:extLst>
               </a:tr>
@@ -12096,7 +12096,7 @@
                 </a:tc>
                 <a:extLst>
                   <a:ext uri="{0D108BD9-81ED-4DB2-BD59-A6C34878D82A}">
-                    <a16:rowId xmlns:a16="http://schemas.microsoft.com/office/drawing/2014/main" val="2913505710"/>
+                    <a16:rowId xmlns:a16="http://schemas.microsoft.com/office/drawing/2014/main" val="4089437001"/>
                   </a:ext>
                 </a:extLst>
               </a:tr>
@@ -12190,7 +12190,7 @@
                 </a:tc>
                 <a:extLst>
                   <a:ext uri="{0D108BD9-81ED-4DB2-BD59-A6C34878D82A}">
-                    <a16:rowId xmlns:a16="http://schemas.microsoft.com/office/drawing/2014/main" val="658396329"/>
+                    <a16:rowId xmlns:a16="http://schemas.microsoft.com/office/drawing/2014/main" val="701203547"/>
                   </a:ext>
                 </a:extLst>
               </a:tr>
@@ -12284,7 +12284,7 @@
                 </a:tc>
                 <a:extLst>
                   <a:ext uri="{0D108BD9-81ED-4DB2-BD59-A6C34878D82A}">
-                    <a16:rowId xmlns:a16="http://schemas.microsoft.com/office/drawing/2014/main" val="1673636343"/>
+                    <a16:rowId xmlns:a16="http://schemas.microsoft.com/office/drawing/2014/main" val="2616648062"/>
                   </a:ext>
                 </a:extLst>
               </a:tr>
@@ -12297,7 +12297,7 @@
           <p:cNvPr id="125" name="文本框 124">
             <a:extLst>
               <a:ext uri="{FF2B5EF4-FFF2-40B4-BE49-F238E27FC236}">
-                <a16:creationId xmlns:a16="http://schemas.microsoft.com/office/drawing/2014/main" id="{5FE32F0F-FA31-BAC9-1E89-8C4339115356}"/>
+                <a16:creationId xmlns:a16="http://schemas.microsoft.com/office/drawing/2014/main" id="{4B7DD994-5BA5-52EE-A237-243BAF10C651}"/>
               </a:ext>
             </a:extLst>
           </p:cNvPr>
@@ -12343,7 +12343,7 @@
           <p:cNvPr id="126" name="card 8">
             <a:extLst>
               <a:ext uri="{FF2B5EF4-FFF2-40B4-BE49-F238E27FC236}">
-                <a16:creationId xmlns:a16="http://schemas.microsoft.com/office/drawing/2014/main" id="{DFC22B31-AB82-B8DC-EC93-8C7C27B24A0B}"/>
+                <a16:creationId xmlns:a16="http://schemas.microsoft.com/office/drawing/2014/main" id="{58B5CD9D-C8C8-7849-8BFB-B5FBF53F9E55}"/>
               </a:ext>
             </a:extLst>
           </p:cNvPr>
@@ -12413,7 +12413,7 @@
           <p:cNvPr id="127" name="badge 8">
             <a:extLst>
               <a:ext uri="{FF2B5EF4-FFF2-40B4-BE49-F238E27FC236}">
-                <a16:creationId xmlns:a16="http://schemas.microsoft.com/office/drawing/2014/main" id="{CBCA01D9-9929-F260-5EDC-209DF585E89E}"/>
+                <a16:creationId xmlns:a16="http://schemas.microsoft.com/office/drawing/2014/main" id="{EF622579-0D60-22A4-AF75-43978757961E}"/>
               </a:ext>
             </a:extLst>
           </p:cNvPr>
@@ -12495,7 +12495,7 @@
           <p:cNvPr id="128" name="title 8">
             <a:extLst>
               <a:ext uri="{FF2B5EF4-FFF2-40B4-BE49-F238E27FC236}">
-                <a16:creationId xmlns:a16="http://schemas.microsoft.com/office/drawing/2014/main" id="{492AAF10-7D65-3545-813D-145CFCE6BD4C}"/>
+                <a16:creationId xmlns:a16="http://schemas.microsoft.com/office/drawing/2014/main" id="{7EBEE69E-CC28-BDED-F639-345FAFD66EE0}"/>
               </a:ext>
             </a:extLst>
           </p:cNvPr>
@@ -12541,7 +12541,7 @@
           <p:cNvPr id="130" name="图片 129">
             <a:extLst>
               <a:ext uri="{FF2B5EF4-FFF2-40B4-BE49-F238E27FC236}">
-                <a16:creationId xmlns:a16="http://schemas.microsoft.com/office/drawing/2014/main" id="{273804B8-CD0D-5E41-97F4-E21B6EE17E43}"/>
+                <a16:creationId xmlns:a16="http://schemas.microsoft.com/office/drawing/2014/main" id="{67F96977-C02A-CDF6-145B-5CBD137BE724}"/>
               </a:ext>
             </a:extLst>
           </p:cNvPr>
@@ -12577,7 +12577,7 @@
           <p:cNvPr id="131" name="文本框 130">
             <a:extLst>
               <a:ext uri="{FF2B5EF4-FFF2-40B4-BE49-F238E27FC236}">
-                <a16:creationId xmlns:a16="http://schemas.microsoft.com/office/drawing/2014/main" id="{60DA4EAE-22C7-6EE3-F43C-65AF9899BEF4}"/>
+                <a16:creationId xmlns:a16="http://schemas.microsoft.com/office/drawing/2014/main" id="{59A4CA40-53B4-F637-48FC-40BF78D70FC4}"/>
               </a:ext>
             </a:extLst>
           </p:cNvPr>
@@ -12717,7 +12717,7 @@
           <p:cNvPr id="133" name="图片 132">
             <a:extLst>
               <a:ext uri="{FF2B5EF4-FFF2-40B4-BE49-F238E27FC236}">
-                <a16:creationId xmlns:a16="http://schemas.microsoft.com/office/drawing/2014/main" id="{6C1B6074-7AFE-22CE-49A5-3FCAF978DF55}"/>
+                <a16:creationId xmlns:a16="http://schemas.microsoft.com/office/drawing/2014/main" id="{FCD85AC0-3B4E-8A27-1C3E-4C3B9963008A}"/>
               </a:ext>
             </a:extLst>
           </p:cNvPr>
@@ -12753,7 +12753,7 @@
           <p:cNvPr id="134" name="文本框 133">
             <a:extLst>
               <a:ext uri="{FF2B5EF4-FFF2-40B4-BE49-F238E27FC236}">
-                <a16:creationId xmlns:a16="http://schemas.microsoft.com/office/drawing/2014/main" id="{FAAADF6C-7CFB-20B4-C796-E7BDA0552A3B}"/>
+                <a16:creationId xmlns:a16="http://schemas.microsoft.com/office/drawing/2014/main" id="{64196445-B47F-9A2C-8763-770891648D98}"/>
               </a:ext>
             </a:extLst>
           </p:cNvPr>
@@ -12799,7 +12799,7 @@
           <p:cNvPr id="135" name="文本框 134">
             <a:extLst>
               <a:ext uri="{FF2B5EF4-FFF2-40B4-BE49-F238E27FC236}">
-                <a16:creationId xmlns:a16="http://schemas.microsoft.com/office/drawing/2014/main" id="{3CE4E6E5-B0F7-C244-0D38-3FFF72C53725}"/>
+                <a16:creationId xmlns:a16="http://schemas.microsoft.com/office/drawing/2014/main" id="{FCE74DAC-9CA3-377E-DE07-86943AA76C40}"/>
               </a:ext>
             </a:extLst>
           </p:cNvPr>
@@ -12843,7 +12843,7 @@
     </p:spTree>
     <p:extLst>
       <p:ext uri="{BB962C8B-B14F-4D97-AF65-F5344CB8AC3E}">
-        <p14:creationId xmlns:p14="http://schemas.microsoft.com/office/powerpoint/2010/main" val="1801104658"/>
+        <p14:creationId xmlns:p14="http://schemas.microsoft.com/office/powerpoint/2010/main" val="331902769"/>
       </p:ext>
     </p:extLst>
   </p:cSld>

</xml_diff>